<commit_message>
changes to final presentation
</commit_message>
<xml_diff>
--- a/report/Präsentation.pptx
+++ b/report/Präsentation.pptx
@@ -5,19 +5,23 @@
     <p:sldMasterId id="2147483648" r:id="rId4"/>
   </p:sldMasterIdLst>
   <p:notesMasterIdLst>
-    <p:notesMasterId r:id="rId15"/>
+    <p:notesMasterId r:id="rId19"/>
   </p:notesMasterIdLst>
   <p:sldIdLst>
     <p:sldId id="256" r:id="rId5"/>
     <p:sldId id="257" r:id="rId6"/>
     <p:sldId id="258" r:id="rId7"/>
     <p:sldId id="261" r:id="rId8"/>
-    <p:sldId id="262" r:id="rId9"/>
-    <p:sldId id="263" r:id="rId10"/>
-    <p:sldId id="264" r:id="rId11"/>
-    <p:sldId id="267" r:id="rId12"/>
-    <p:sldId id="265" r:id="rId13"/>
-    <p:sldId id="266" r:id="rId14"/>
+    <p:sldId id="263" r:id="rId9"/>
+    <p:sldId id="269" r:id="rId10"/>
+    <p:sldId id="268" r:id="rId11"/>
+    <p:sldId id="264" r:id="rId12"/>
+    <p:sldId id="270" r:id="rId13"/>
+    <p:sldId id="271" r:id="rId14"/>
+    <p:sldId id="262" r:id="rId15"/>
+    <p:sldId id="267" r:id="rId16"/>
+    <p:sldId id="265" r:id="rId17"/>
+    <p:sldId id="266" r:id="rId18"/>
   </p:sldIdLst>
   <p:sldSz cx="12192000" cy="6858000"/>
   <p:notesSz cx="6858000" cy="9144000"/>
@@ -206,7 +210,7 @@
           <a:p>
             <a:fld id="{34FDB5A7-DA16-4448-8282-3E19F6C995A7}" type="datetimeFigureOut">
               <a:rPr lang="de-AT" smtClean="0"/>
-              <a:t>20.02.2026</a:t>
+              <a:t>21.02.2026</a:t>
             </a:fld>
             <a:endParaRPr lang="de-AT"/>
           </a:p>
@@ -472,6 +476,90 @@
     </a:lvl9pPr>
   </p:notesStyle>
 </p:notesMaster>
+</file>
+
+<file path=ppt/notesSlides/notesSlide1.xml><?xml version="1.0" encoding="utf-8"?>
+<p:notes xmlns:a="http://schemas.openxmlformats.org/drawingml/2006/main" xmlns:r="http://schemas.openxmlformats.org/officeDocument/2006/relationships" xmlns:p="http://schemas.openxmlformats.org/presentationml/2006/main">
+  <p:cSld>
+    <p:spTree>
+      <p:nvGrpSpPr>
+        <p:cNvPr id="1" name=""/>
+        <p:cNvGrpSpPr/>
+        <p:nvPr/>
+      </p:nvGrpSpPr>
+      <p:grpSpPr>
+        <a:xfrm>
+          <a:off x="0" y="0"/>
+          <a:ext cx="0" cy="0"/>
+          <a:chOff x="0" y="0"/>
+          <a:chExt cx="0" cy="0"/>
+        </a:xfrm>
+      </p:grpSpPr>
+      <p:sp>
+        <p:nvSpPr>
+          <p:cNvPr id="2" name="Folienbildplatzhalter 1"/>
+          <p:cNvSpPr>
+            <a:spLocks noGrp="1" noRot="1" noChangeAspect="1"/>
+          </p:cNvSpPr>
+          <p:nvPr>
+            <p:ph type="sldImg"/>
+          </p:nvPr>
+        </p:nvSpPr>
+        <p:spPr/>
+      </p:sp>
+      <p:sp>
+        <p:nvSpPr>
+          <p:cNvPr id="3" name="Notizenplatzhalter 2"/>
+          <p:cNvSpPr>
+            <a:spLocks noGrp="1"/>
+          </p:cNvSpPr>
+          <p:nvPr>
+            <p:ph type="body" idx="1"/>
+          </p:nvPr>
+        </p:nvSpPr>
+        <p:spPr/>
+        <p:txBody>
+          <a:bodyPr/>
+          <a:lstStyle/>
+          <a:p>
+            <a:endParaRPr lang="de-AT" dirty="0"/>
+          </a:p>
+        </p:txBody>
+      </p:sp>
+      <p:sp>
+        <p:nvSpPr>
+          <p:cNvPr id="4" name="Foliennummernplatzhalter 3"/>
+          <p:cNvSpPr>
+            <a:spLocks noGrp="1"/>
+          </p:cNvSpPr>
+          <p:nvPr>
+            <p:ph type="sldNum" sz="quarter" idx="5"/>
+          </p:nvPr>
+        </p:nvSpPr>
+        <p:spPr/>
+        <p:txBody>
+          <a:bodyPr/>
+          <a:lstStyle/>
+          <a:p>
+            <a:fld id="{46421F40-A2A0-451B-91E9-F1FF0F435D37}" type="slidenum">
+              <a:rPr lang="de-AT" smtClean="0"/>
+              <a:t>8</a:t>
+            </a:fld>
+            <a:endParaRPr lang="de-AT"/>
+          </a:p>
+        </p:txBody>
+      </p:sp>
+    </p:spTree>
+    <p:extLst>
+      <p:ext uri="{BB962C8B-B14F-4D97-AF65-F5344CB8AC3E}">
+        <p14:creationId xmlns:p14="http://schemas.microsoft.com/office/powerpoint/2010/main" val="48734738"/>
+      </p:ext>
+    </p:extLst>
+  </p:cSld>
+  <p:clrMapOvr>
+    <a:masterClrMapping/>
+  </p:clrMapOvr>
+</p:notes>
 </file>
 
 <file path=ppt/slideLayouts/slideLayout1.xml><?xml version="1.0" encoding="utf-8"?>
@@ -3876,7 +3964,7 @@
         </p:nvSpPr>
         <p:spPr>
           <a:xfrm>
-            <a:off x="6895550" y="6059646"/>
+            <a:off x="8019775" y="6535926"/>
             <a:ext cx="5296450" cy="369332"/>
           </a:xfrm>
           <a:prstGeom prst="rect">
@@ -3931,7 +4019,7 @@
         </p:nvSpPr>
         <p:spPr>
           <a:xfrm>
-            <a:off x="838200" y="6110378"/>
+            <a:off x="-1200150" y="6105812"/>
             <a:ext cx="1007007" cy="646331"/>
           </a:xfrm>
           <a:prstGeom prst="rect">
@@ -3979,7 +4067,12 @@
             <p:ph type="dt" sz="half" idx="10"/>
           </p:nvPr>
         </p:nvSpPr>
-        <p:spPr/>
+        <p:spPr>
+          <a:xfrm>
+            <a:off x="-1200150" y="6387018"/>
+            <a:ext cx="2743200" cy="365125"/>
+          </a:xfrm>
+        </p:spPr>
         <p:txBody>
           <a:bodyPr/>
           <a:lstStyle/>
@@ -4034,6 +4127,1028 @@
 </file>
 
 <file path=ppt/slides/slide10.xml><?xml version="1.0" encoding="utf-8"?>
+<p:sld xmlns:a="http://schemas.openxmlformats.org/drawingml/2006/main" xmlns:r="http://schemas.openxmlformats.org/officeDocument/2006/relationships" xmlns:p="http://schemas.openxmlformats.org/presentationml/2006/main">
+  <p:cSld>
+    <p:spTree>
+      <p:nvGrpSpPr>
+        <p:cNvPr id="1" name="">
+          <a:extLst>
+            <a:ext uri="{FF2B5EF4-FFF2-40B4-BE49-F238E27FC236}">
+              <a16:creationId xmlns:a16="http://schemas.microsoft.com/office/drawing/2014/main" id="{8FBE68D7-2926-547B-759F-905B45C7A03D}"/>
+            </a:ext>
+          </a:extLst>
+        </p:cNvPr>
+        <p:cNvGrpSpPr/>
+        <p:nvPr/>
+      </p:nvGrpSpPr>
+      <p:grpSpPr>
+        <a:xfrm>
+          <a:off x="0" y="0"/>
+          <a:ext cx="0" cy="0"/>
+          <a:chOff x="0" y="0"/>
+          <a:chExt cx="0" cy="0"/>
+        </a:xfrm>
+      </p:grpSpPr>
+      <p:sp>
+        <p:nvSpPr>
+          <p:cNvPr id="2" name="Titel 1">
+            <a:extLst>
+              <a:ext uri="{FF2B5EF4-FFF2-40B4-BE49-F238E27FC236}">
+                <a16:creationId xmlns:a16="http://schemas.microsoft.com/office/drawing/2014/main" id="{E480F9FB-47AF-52EB-CAFC-EE7CC7631B52}"/>
+              </a:ext>
+            </a:extLst>
+          </p:cNvPr>
+          <p:cNvSpPr>
+            <a:spLocks noGrp="1"/>
+          </p:cNvSpPr>
+          <p:nvPr>
+            <p:ph type="title"/>
+          </p:nvPr>
+        </p:nvSpPr>
+        <p:spPr/>
+        <p:txBody>
+          <a:bodyPr/>
+          <a:lstStyle/>
+          <a:p>
+            <a:endParaRPr lang="en-GB" noProof="0" dirty="0"/>
+          </a:p>
+        </p:txBody>
+      </p:sp>
+      <p:sp>
+        <p:nvSpPr>
+          <p:cNvPr id="3" name="Inhaltsplatzhalter 2">
+            <a:extLst>
+              <a:ext uri="{FF2B5EF4-FFF2-40B4-BE49-F238E27FC236}">
+                <a16:creationId xmlns:a16="http://schemas.microsoft.com/office/drawing/2014/main" id="{81D83B08-D5ED-F1AE-4C68-8F439E7FE99D}"/>
+              </a:ext>
+            </a:extLst>
+          </p:cNvPr>
+          <p:cNvSpPr>
+            <a:spLocks noGrp="1"/>
+          </p:cNvSpPr>
+          <p:nvPr>
+            <p:ph idx="1"/>
+          </p:nvPr>
+        </p:nvSpPr>
+        <p:spPr/>
+        <p:txBody>
+          <a:bodyPr/>
+          <a:lstStyle/>
+          <a:p>
+            <a:r>
+              <a:rPr lang="en-GB" noProof="0" dirty="0"/>
+              <a:t>Generated Code of used Model and converted it to usable MP-model</a:t>
+            </a:r>
+          </a:p>
+        </p:txBody>
+      </p:sp>
+      <p:sp>
+        <p:nvSpPr>
+          <p:cNvPr id="4" name="Datumsplatzhalter 3">
+            <a:extLst>
+              <a:ext uri="{FF2B5EF4-FFF2-40B4-BE49-F238E27FC236}">
+                <a16:creationId xmlns:a16="http://schemas.microsoft.com/office/drawing/2014/main" id="{1481A1BE-373A-5FDD-44F3-E3FFDC5FED11}"/>
+              </a:ext>
+            </a:extLst>
+          </p:cNvPr>
+          <p:cNvSpPr>
+            <a:spLocks noGrp="1"/>
+          </p:cNvSpPr>
+          <p:nvPr>
+            <p:ph type="dt" sz="half" idx="10"/>
+          </p:nvPr>
+        </p:nvSpPr>
+        <p:spPr/>
+        <p:txBody>
+          <a:bodyPr/>
+          <a:lstStyle/>
+          <a:p>
+            <a:r>
+              <a:rPr lang="en-GB" noProof="0" dirty="0"/>
+              <a:t>23.02.2026</a:t>
+            </a:r>
+          </a:p>
+        </p:txBody>
+      </p:sp>
+      <p:sp>
+        <p:nvSpPr>
+          <p:cNvPr id="5" name="Foliennummernplatzhalter 4">
+            <a:extLst>
+              <a:ext uri="{FF2B5EF4-FFF2-40B4-BE49-F238E27FC236}">
+                <a16:creationId xmlns:a16="http://schemas.microsoft.com/office/drawing/2014/main" id="{A67E69F2-9F56-AF44-B4AD-1335808D1D98}"/>
+              </a:ext>
+            </a:extLst>
+          </p:cNvPr>
+          <p:cNvSpPr>
+            <a:spLocks noGrp="1"/>
+          </p:cNvSpPr>
+          <p:nvPr>
+            <p:ph type="sldNum" sz="quarter" idx="12"/>
+          </p:nvPr>
+        </p:nvSpPr>
+        <p:spPr/>
+        <p:txBody>
+          <a:bodyPr/>
+          <a:lstStyle/>
+          <a:p>
+            <a:fld id="{533690DF-FFD6-462A-8578-786984FF8DCB}" type="slidenum">
+              <a:rPr lang="en-GB" noProof="0" smtClean="0"/>
+              <a:t>10</a:t>
+            </a:fld>
+            <a:endParaRPr lang="en-GB" noProof="0" dirty="0"/>
+          </a:p>
+        </p:txBody>
+      </p:sp>
+      <p:sp>
+        <p:nvSpPr>
+          <p:cNvPr id="8" name="Rectangle: Rounded Corners 3">
+            <a:extLst>
+              <a:ext uri="{FF2B5EF4-FFF2-40B4-BE49-F238E27FC236}">
+                <a16:creationId xmlns:a16="http://schemas.microsoft.com/office/drawing/2014/main" id="{798DA5B3-5766-002C-E7E4-331B21440828}"/>
+              </a:ext>
+            </a:extLst>
+          </p:cNvPr>
+          <p:cNvSpPr/>
+          <p:nvPr/>
+        </p:nvSpPr>
+        <p:spPr bwMode="auto">
+          <a:xfrm>
+            <a:off x="388302" y="681037"/>
+            <a:ext cx="11522076" cy="828438"/>
+          </a:xfrm>
+          <a:prstGeom prst="roundRect">
+            <a:avLst>
+              <a:gd name="adj" fmla="val 9662"/>
+            </a:avLst>
+          </a:prstGeom>
+          <a:solidFill>
+            <a:srgbClr val="0A8276"/>
+          </a:solidFill>
+          <a:ln w="9525">
+            <a:noFill/>
+            <a:miter lim="800000"/>
+            <a:headEnd/>
+            <a:tailEnd/>
+          </a:ln>
+        </p:spPr>
+        <p:txBody>
+          <a:bodyPr rot="0" spcFirstLastPara="0" vertOverflow="overflow" horzOverflow="overflow" vert="horz" wrap="square" lIns="72000" tIns="72000" rIns="72000" bIns="72000" numCol="1" spcCol="0" rtlCol="0" fromWordArt="0" anchor="ctr" anchorCtr="0" forceAA="0" compatLnSpc="1">
+            <a:prstTxWarp prst="textNoShape">
+              <a:avLst/>
+            </a:prstTxWarp>
+            <a:noAutofit/>
+          </a:bodyPr>
+          <a:lstStyle/>
+          <a:p>
+            <a:pPr defTabSz="576000" eaLnBrk="0" fontAlgn="base" hangingPunct="0">
+              <a:lnSpc>
+                <a:spcPct val="120000"/>
+              </a:lnSpc>
+              <a:spcBef>
+                <a:spcPct val="0"/>
+              </a:spcBef>
+              <a:spcAft>
+                <a:spcPct val="0"/>
+              </a:spcAft>
+              <a:defRPr/>
+            </a:pPr>
+            <a:r>
+              <a:rPr lang="en-GB" sz="2000" b="1" kern="0" noProof="0" dirty="0" err="1">
+                <a:solidFill>
+                  <a:srgbClr val="FFFFFF"/>
+                </a:solidFill>
+                <a:latin typeface="Arial"/>
+                <a:cs typeface="Arial"/>
+              </a:rPr>
+              <a:t>Micropython</a:t>
+            </a:r>
+            <a:r>
+              <a:rPr lang="en-GB" sz="2000" b="1" kern="0" noProof="0" dirty="0">
+                <a:solidFill>
+                  <a:srgbClr val="FFFFFF"/>
+                </a:solidFill>
+                <a:latin typeface="Arial"/>
+                <a:cs typeface="Arial"/>
+              </a:rPr>
+              <a:t> Code</a:t>
+            </a:r>
+            <a:endParaRPr lang="en-GB" sz="2000" b="1" i="1" kern="0" baseline="30000" noProof="0" dirty="0">
+              <a:solidFill>
+                <a:srgbClr val="FFFFFF"/>
+              </a:solidFill>
+              <a:latin typeface="Arial"/>
+              <a:cs typeface="Arial"/>
+            </a:endParaRPr>
+          </a:p>
+        </p:txBody>
+      </p:sp>
+    </p:spTree>
+    <p:extLst>
+      <p:ext uri="{BB962C8B-B14F-4D97-AF65-F5344CB8AC3E}">
+        <p14:creationId xmlns:p14="http://schemas.microsoft.com/office/powerpoint/2010/main" val="4267612672"/>
+      </p:ext>
+    </p:extLst>
+  </p:cSld>
+  <p:clrMapOvr>
+    <a:masterClrMapping/>
+  </p:clrMapOvr>
+</p:sld>
+</file>
+
+<file path=ppt/slides/slide11.xml><?xml version="1.0" encoding="utf-8"?>
+<p:sld xmlns:a="http://schemas.openxmlformats.org/drawingml/2006/main" xmlns:r="http://schemas.openxmlformats.org/officeDocument/2006/relationships" xmlns:p="http://schemas.openxmlformats.org/presentationml/2006/main">
+  <p:cSld>
+    <p:spTree>
+      <p:nvGrpSpPr>
+        <p:cNvPr id="1" name="">
+          <a:extLst>
+            <a:ext uri="{FF2B5EF4-FFF2-40B4-BE49-F238E27FC236}">
+              <a16:creationId xmlns:a16="http://schemas.microsoft.com/office/drawing/2014/main" id="{BA88F5AF-2E23-BEFE-6BC1-B4D534AFB1B6}"/>
+            </a:ext>
+          </a:extLst>
+        </p:cNvPr>
+        <p:cNvGrpSpPr/>
+        <p:nvPr/>
+      </p:nvGrpSpPr>
+      <p:grpSpPr>
+        <a:xfrm>
+          <a:off x="0" y="0"/>
+          <a:ext cx="0" cy="0"/>
+          <a:chOff x="0" y="0"/>
+          <a:chExt cx="0" cy="0"/>
+        </a:xfrm>
+      </p:grpSpPr>
+      <p:sp>
+        <p:nvSpPr>
+          <p:cNvPr id="2" name="Titel 1">
+            <a:extLst>
+              <a:ext uri="{FF2B5EF4-FFF2-40B4-BE49-F238E27FC236}">
+                <a16:creationId xmlns:a16="http://schemas.microsoft.com/office/drawing/2014/main" id="{E9F140C5-9AA7-C982-774A-2DE2FE881DE4}"/>
+              </a:ext>
+            </a:extLst>
+          </p:cNvPr>
+          <p:cNvSpPr>
+            <a:spLocks noGrp="1"/>
+          </p:cNvSpPr>
+          <p:nvPr>
+            <p:ph type="title"/>
+          </p:nvPr>
+        </p:nvSpPr>
+        <p:spPr/>
+        <p:txBody>
+          <a:bodyPr/>
+          <a:lstStyle/>
+          <a:p>
+            <a:endParaRPr lang="en-GB" noProof="0" dirty="0"/>
+          </a:p>
+        </p:txBody>
+      </p:sp>
+      <p:sp>
+        <p:nvSpPr>
+          <p:cNvPr id="3" name="Inhaltsplatzhalter 2">
+            <a:extLst>
+              <a:ext uri="{FF2B5EF4-FFF2-40B4-BE49-F238E27FC236}">
+                <a16:creationId xmlns:a16="http://schemas.microsoft.com/office/drawing/2014/main" id="{16E70A6D-D365-C64A-387A-75AAE10CB406}"/>
+              </a:ext>
+            </a:extLst>
+          </p:cNvPr>
+          <p:cNvSpPr>
+            <a:spLocks noGrp="1"/>
+          </p:cNvSpPr>
+          <p:nvPr>
+            <p:ph idx="1"/>
+          </p:nvPr>
+        </p:nvSpPr>
+        <p:spPr/>
+        <p:txBody>
+          <a:bodyPr>
+            <a:normAutofit fontScale="92500" lnSpcReduction="10000"/>
+          </a:bodyPr>
+          <a:lstStyle/>
+          <a:p>
+            <a:r>
+              <a:rPr lang="en-GB" noProof="0" dirty="0"/>
+              <a:t>Overlapping labels</a:t>
+            </a:r>
+            <a:r>
+              <a:rPr lang="en-GB" dirty="0"/>
+              <a:t>, DEEPCRAFT Studio sometimes set two labels above each other</a:t>
+            </a:r>
+            <a:endParaRPr lang="en-GB" noProof="0" dirty="0"/>
+          </a:p>
+          <a:p>
+            <a:r>
+              <a:rPr lang="en-GB" noProof="0" dirty="0"/>
+              <a:t>No clear indications on what ma</a:t>
+            </a:r>
+            <a:r>
+              <a:rPr lang="en-GB" dirty="0" err="1"/>
+              <a:t>kes</a:t>
+            </a:r>
+            <a:r>
+              <a:rPr lang="en-GB" dirty="0"/>
+              <a:t> model better or worse</a:t>
+            </a:r>
+          </a:p>
+          <a:p>
+            <a:r>
+              <a:rPr lang="en-GB" dirty="0"/>
+              <a:t>It was not achievable to enqueue Data fast enough in our </a:t>
+            </a:r>
+            <a:r>
+              <a:rPr lang="en-GB" dirty="0" err="1"/>
+              <a:t>Micropython</a:t>
+            </a:r>
+            <a:r>
+              <a:rPr lang="en-GB" dirty="0"/>
+              <a:t> Code (fastest Loop runtime 3ms). Needed to </a:t>
+            </a:r>
+            <a:r>
+              <a:rPr lang="en-GB" dirty="0" err="1"/>
+              <a:t>downsample</a:t>
+            </a:r>
+            <a:r>
+              <a:rPr lang="en-GB" dirty="0"/>
+              <a:t> our Data to 100Hz</a:t>
+            </a:r>
+          </a:p>
+          <a:p>
+            <a:r>
+              <a:rPr lang="en-GB" dirty="0"/>
+              <a:t>Using an if-selection to time enqueue did not work/lead to the PSOC6 stalling after a few seconds (Busy waiting). Used </a:t>
+            </a:r>
+            <a:r>
+              <a:rPr lang="en-GB" dirty="0" err="1"/>
+              <a:t>time.wait_ms</a:t>
+            </a:r>
+            <a:r>
+              <a:rPr lang="en-GB" dirty="0"/>
+              <a:t>() instead</a:t>
+            </a:r>
+          </a:p>
+          <a:p>
+            <a:r>
+              <a:rPr lang="en-GB" dirty="0"/>
+              <a:t>Predictions for one punch are greater than 0.6 over two contextual windows.</a:t>
+            </a:r>
+          </a:p>
+          <a:p>
+            <a:endParaRPr lang="en-GB" dirty="0"/>
+          </a:p>
+          <a:p>
+            <a:endParaRPr lang="en-GB" dirty="0"/>
+          </a:p>
+          <a:p>
+            <a:endParaRPr lang="en-GB" noProof="0" dirty="0"/>
+          </a:p>
+        </p:txBody>
+      </p:sp>
+      <p:sp>
+        <p:nvSpPr>
+          <p:cNvPr id="4" name="Datumsplatzhalter 3">
+            <a:extLst>
+              <a:ext uri="{FF2B5EF4-FFF2-40B4-BE49-F238E27FC236}">
+                <a16:creationId xmlns:a16="http://schemas.microsoft.com/office/drawing/2014/main" id="{A662B3FA-00C1-9EE6-1D74-E4B044BBECD8}"/>
+              </a:ext>
+            </a:extLst>
+          </p:cNvPr>
+          <p:cNvSpPr>
+            <a:spLocks noGrp="1"/>
+          </p:cNvSpPr>
+          <p:nvPr>
+            <p:ph type="dt" sz="half" idx="10"/>
+          </p:nvPr>
+        </p:nvSpPr>
+        <p:spPr/>
+        <p:txBody>
+          <a:bodyPr/>
+          <a:lstStyle/>
+          <a:p>
+            <a:r>
+              <a:rPr lang="en-GB" noProof="0" dirty="0"/>
+              <a:t>23.02.2026</a:t>
+            </a:r>
+          </a:p>
+        </p:txBody>
+      </p:sp>
+      <p:sp>
+        <p:nvSpPr>
+          <p:cNvPr id="5" name="Foliennummernplatzhalter 4">
+            <a:extLst>
+              <a:ext uri="{FF2B5EF4-FFF2-40B4-BE49-F238E27FC236}">
+                <a16:creationId xmlns:a16="http://schemas.microsoft.com/office/drawing/2014/main" id="{1358572C-AB05-ECD6-B505-C87F61376D78}"/>
+              </a:ext>
+            </a:extLst>
+          </p:cNvPr>
+          <p:cNvSpPr>
+            <a:spLocks noGrp="1"/>
+          </p:cNvSpPr>
+          <p:nvPr>
+            <p:ph type="sldNum" sz="quarter" idx="12"/>
+          </p:nvPr>
+        </p:nvSpPr>
+        <p:spPr/>
+        <p:txBody>
+          <a:bodyPr/>
+          <a:lstStyle/>
+          <a:p>
+            <a:fld id="{533690DF-FFD6-462A-8578-786984FF8DCB}" type="slidenum">
+              <a:rPr lang="en-GB" noProof="0" smtClean="0"/>
+              <a:t>11</a:t>
+            </a:fld>
+            <a:endParaRPr lang="en-GB" noProof="0" dirty="0"/>
+          </a:p>
+        </p:txBody>
+      </p:sp>
+      <p:sp>
+        <p:nvSpPr>
+          <p:cNvPr id="8" name="Rectangle: Rounded Corners 3">
+            <a:extLst>
+              <a:ext uri="{FF2B5EF4-FFF2-40B4-BE49-F238E27FC236}">
+                <a16:creationId xmlns:a16="http://schemas.microsoft.com/office/drawing/2014/main" id="{2B3438B7-EF5B-59AA-36AC-D1B6B1D0A3AA}"/>
+              </a:ext>
+            </a:extLst>
+          </p:cNvPr>
+          <p:cNvSpPr/>
+          <p:nvPr/>
+        </p:nvSpPr>
+        <p:spPr bwMode="auto">
+          <a:xfrm>
+            <a:off x="388302" y="681037"/>
+            <a:ext cx="11522076" cy="828438"/>
+          </a:xfrm>
+          <a:prstGeom prst="roundRect">
+            <a:avLst>
+              <a:gd name="adj" fmla="val 9662"/>
+            </a:avLst>
+          </a:prstGeom>
+          <a:solidFill>
+            <a:srgbClr val="0A8276"/>
+          </a:solidFill>
+          <a:ln w="9525">
+            <a:noFill/>
+            <a:miter lim="800000"/>
+            <a:headEnd/>
+            <a:tailEnd/>
+          </a:ln>
+        </p:spPr>
+        <p:txBody>
+          <a:bodyPr rot="0" spcFirstLastPara="0" vertOverflow="overflow" horzOverflow="overflow" vert="horz" wrap="square" lIns="72000" tIns="72000" rIns="72000" bIns="72000" numCol="1" spcCol="0" rtlCol="0" fromWordArt="0" anchor="ctr" anchorCtr="0" forceAA="0" compatLnSpc="1">
+            <a:prstTxWarp prst="textNoShape">
+              <a:avLst/>
+            </a:prstTxWarp>
+            <a:noAutofit/>
+          </a:bodyPr>
+          <a:lstStyle/>
+          <a:p>
+            <a:pPr defTabSz="576000" eaLnBrk="0" fontAlgn="base" hangingPunct="0">
+              <a:lnSpc>
+                <a:spcPct val="120000"/>
+              </a:lnSpc>
+              <a:spcBef>
+                <a:spcPct val="0"/>
+              </a:spcBef>
+              <a:spcAft>
+                <a:spcPct val="0"/>
+              </a:spcAft>
+              <a:defRPr/>
+            </a:pPr>
+            <a:r>
+              <a:rPr lang="en-GB" sz="2000" b="1" kern="0" noProof="0" dirty="0">
+                <a:solidFill>
+                  <a:srgbClr val="FFFFFF"/>
+                </a:solidFill>
+                <a:latin typeface="Arial"/>
+                <a:cs typeface="Arial"/>
+              </a:rPr>
+              <a:t>Problems faced</a:t>
+            </a:r>
+            <a:endParaRPr lang="en-GB" sz="2000" b="1" i="1" kern="0" baseline="30000" noProof="0" dirty="0">
+              <a:solidFill>
+                <a:srgbClr val="FFFFFF"/>
+              </a:solidFill>
+              <a:latin typeface="Arial"/>
+              <a:cs typeface="Arial"/>
+            </a:endParaRPr>
+          </a:p>
+        </p:txBody>
+      </p:sp>
+    </p:spTree>
+    <p:extLst>
+      <p:ext uri="{BB962C8B-B14F-4D97-AF65-F5344CB8AC3E}">
+        <p14:creationId xmlns:p14="http://schemas.microsoft.com/office/powerpoint/2010/main" val="616278457"/>
+      </p:ext>
+    </p:extLst>
+  </p:cSld>
+  <p:clrMapOvr>
+    <a:masterClrMapping/>
+  </p:clrMapOvr>
+</p:sld>
+</file>
+
+<file path=ppt/slides/slide12.xml><?xml version="1.0" encoding="utf-8"?>
+<p:sld xmlns:a="http://schemas.openxmlformats.org/drawingml/2006/main" xmlns:r="http://schemas.openxmlformats.org/officeDocument/2006/relationships" xmlns:p="http://schemas.openxmlformats.org/presentationml/2006/main">
+  <p:cSld>
+    <p:spTree>
+      <p:nvGrpSpPr>
+        <p:cNvPr id="1" name="">
+          <a:extLst>
+            <a:ext uri="{FF2B5EF4-FFF2-40B4-BE49-F238E27FC236}">
+              <a16:creationId xmlns:a16="http://schemas.microsoft.com/office/drawing/2014/main" id="{580E206E-F9F0-B1F3-3831-EFA56FAF9180}"/>
+            </a:ext>
+          </a:extLst>
+        </p:cNvPr>
+        <p:cNvGrpSpPr/>
+        <p:nvPr/>
+      </p:nvGrpSpPr>
+      <p:grpSpPr>
+        <a:xfrm>
+          <a:off x="0" y="0"/>
+          <a:ext cx="0" cy="0"/>
+          <a:chOff x="0" y="0"/>
+          <a:chExt cx="0" cy="0"/>
+        </a:xfrm>
+      </p:grpSpPr>
+      <p:sp>
+        <p:nvSpPr>
+          <p:cNvPr id="2" name="Titel 1">
+            <a:extLst>
+              <a:ext uri="{FF2B5EF4-FFF2-40B4-BE49-F238E27FC236}">
+                <a16:creationId xmlns:a16="http://schemas.microsoft.com/office/drawing/2014/main" id="{63651015-7065-37DE-2A96-992FCAE30DD3}"/>
+              </a:ext>
+            </a:extLst>
+          </p:cNvPr>
+          <p:cNvSpPr>
+            <a:spLocks noGrp="1"/>
+          </p:cNvSpPr>
+          <p:nvPr>
+            <p:ph type="title"/>
+          </p:nvPr>
+        </p:nvSpPr>
+        <p:spPr/>
+        <p:txBody>
+          <a:bodyPr/>
+          <a:lstStyle/>
+          <a:p>
+            <a:endParaRPr lang="en-GB" noProof="0" dirty="0"/>
+          </a:p>
+        </p:txBody>
+      </p:sp>
+      <p:sp>
+        <p:nvSpPr>
+          <p:cNvPr id="3" name="Inhaltsplatzhalter 2">
+            <a:extLst>
+              <a:ext uri="{FF2B5EF4-FFF2-40B4-BE49-F238E27FC236}">
+                <a16:creationId xmlns:a16="http://schemas.microsoft.com/office/drawing/2014/main" id="{F02E0872-877F-0BA3-51D1-35C51BF24B60}"/>
+              </a:ext>
+            </a:extLst>
+          </p:cNvPr>
+          <p:cNvSpPr>
+            <a:spLocks noGrp="1"/>
+          </p:cNvSpPr>
+          <p:nvPr>
+            <p:ph idx="1"/>
+          </p:nvPr>
+        </p:nvSpPr>
+        <p:spPr>
+          <a:xfrm>
+            <a:off x="838200" y="1825625"/>
+            <a:ext cx="10515600" cy="4349512"/>
+          </a:xfrm>
+        </p:spPr>
+        <p:txBody>
+          <a:bodyPr/>
+          <a:lstStyle/>
+          <a:p>
+            <a:r>
+              <a:rPr lang="en-GB" noProof="0" dirty="0"/>
+              <a:t>Implementing the game function</a:t>
+            </a:r>
+          </a:p>
+          <a:p>
+            <a:r>
+              <a:rPr lang="en-GB" dirty="0"/>
+              <a:t>Gathering more sampling data from more different people </a:t>
+            </a:r>
+          </a:p>
+          <a:p>
+            <a:r>
+              <a:rPr lang="en-GB" dirty="0"/>
+              <a:t>Gather data of left hand punches to make it suitable for real training purposes</a:t>
+            </a:r>
+          </a:p>
+          <a:p>
+            <a:r>
+              <a:rPr lang="en-GB" noProof="0" dirty="0"/>
+              <a:t>Creating a function to read the velocity of thrown punches/calculate it using the IMU-Data</a:t>
+            </a:r>
+          </a:p>
+          <a:p>
+            <a:r>
+              <a:rPr lang="en-GB" noProof="0" dirty="0"/>
+              <a:t>Using the boards button </a:t>
+            </a:r>
+            <a:r>
+              <a:rPr lang="en-GB" dirty="0"/>
+              <a:t>to start and stop sessions</a:t>
+            </a:r>
+          </a:p>
+          <a:p>
+            <a:r>
+              <a:rPr lang="en-GB" noProof="0" dirty="0"/>
+              <a:t>Creation of c</a:t>
+            </a:r>
+            <a:r>
+              <a:rPr lang="en-GB" dirty="0"/>
+              <a:t>harts for easier understanding/adding statistic analysis (number of certain punches, highest velocity, …)</a:t>
+            </a:r>
+            <a:endParaRPr lang="en-GB" noProof="0" dirty="0"/>
+          </a:p>
+          <a:p>
+            <a:endParaRPr lang="en-GB" noProof="0" dirty="0"/>
+          </a:p>
+        </p:txBody>
+      </p:sp>
+      <p:sp>
+        <p:nvSpPr>
+          <p:cNvPr id="4" name="Datumsplatzhalter 3">
+            <a:extLst>
+              <a:ext uri="{FF2B5EF4-FFF2-40B4-BE49-F238E27FC236}">
+                <a16:creationId xmlns:a16="http://schemas.microsoft.com/office/drawing/2014/main" id="{B5D3B9EB-9901-5950-F169-B1D0A08C57BD}"/>
+              </a:ext>
+            </a:extLst>
+          </p:cNvPr>
+          <p:cNvSpPr>
+            <a:spLocks noGrp="1"/>
+          </p:cNvSpPr>
+          <p:nvPr>
+            <p:ph type="dt" sz="half" idx="10"/>
+          </p:nvPr>
+        </p:nvSpPr>
+        <p:spPr/>
+        <p:txBody>
+          <a:bodyPr/>
+          <a:lstStyle/>
+          <a:p>
+            <a:r>
+              <a:rPr lang="en-GB" noProof="0" dirty="0"/>
+              <a:t>23.02.2026</a:t>
+            </a:r>
+          </a:p>
+        </p:txBody>
+      </p:sp>
+      <p:sp>
+        <p:nvSpPr>
+          <p:cNvPr id="5" name="Foliennummernplatzhalter 4">
+            <a:extLst>
+              <a:ext uri="{FF2B5EF4-FFF2-40B4-BE49-F238E27FC236}">
+                <a16:creationId xmlns:a16="http://schemas.microsoft.com/office/drawing/2014/main" id="{8A053F44-783F-C8DC-CE39-9F9027F85018}"/>
+              </a:ext>
+            </a:extLst>
+          </p:cNvPr>
+          <p:cNvSpPr>
+            <a:spLocks noGrp="1"/>
+          </p:cNvSpPr>
+          <p:nvPr>
+            <p:ph type="sldNum" sz="quarter" idx="12"/>
+          </p:nvPr>
+        </p:nvSpPr>
+        <p:spPr/>
+        <p:txBody>
+          <a:bodyPr/>
+          <a:lstStyle/>
+          <a:p>
+            <a:fld id="{533690DF-FFD6-462A-8578-786984FF8DCB}" type="slidenum">
+              <a:rPr lang="en-GB" noProof="0" smtClean="0"/>
+              <a:t>12</a:t>
+            </a:fld>
+            <a:endParaRPr lang="en-GB" noProof="0" dirty="0"/>
+          </a:p>
+        </p:txBody>
+      </p:sp>
+      <p:sp>
+        <p:nvSpPr>
+          <p:cNvPr id="8" name="Rectangle: Rounded Corners 3">
+            <a:extLst>
+              <a:ext uri="{FF2B5EF4-FFF2-40B4-BE49-F238E27FC236}">
+                <a16:creationId xmlns:a16="http://schemas.microsoft.com/office/drawing/2014/main" id="{FDB87BB3-2B66-4842-355C-9286C653C6EA}"/>
+              </a:ext>
+            </a:extLst>
+          </p:cNvPr>
+          <p:cNvSpPr/>
+          <p:nvPr/>
+        </p:nvSpPr>
+        <p:spPr bwMode="auto">
+          <a:xfrm>
+            <a:off x="388302" y="681037"/>
+            <a:ext cx="11522076" cy="828438"/>
+          </a:xfrm>
+          <a:prstGeom prst="roundRect">
+            <a:avLst>
+              <a:gd name="adj" fmla="val 9662"/>
+            </a:avLst>
+          </a:prstGeom>
+          <a:solidFill>
+            <a:srgbClr val="0A8276"/>
+          </a:solidFill>
+          <a:ln w="9525">
+            <a:noFill/>
+            <a:miter lim="800000"/>
+            <a:headEnd/>
+            <a:tailEnd/>
+          </a:ln>
+        </p:spPr>
+        <p:txBody>
+          <a:bodyPr rot="0" spcFirstLastPara="0" vertOverflow="overflow" horzOverflow="overflow" vert="horz" wrap="square" lIns="72000" tIns="72000" rIns="72000" bIns="72000" numCol="1" spcCol="0" rtlCol="0" fromWordArt="0" anchor="ctr" anchorCtr="0" forceAA="0" compatLnSpc="1">
+            <a:prstTxWarp prst="textNoShape">
+              <a:avLst/>
+            </a:prstTxWarp>
+            <a:noAutofit/>
+          </a:bodyPr>
+          <a:lstStyle/>
+          <a:p>
+            <a:pPr defTabSz="576000" eaLnBrk="0" fontAlgn="base" hangingPunct="0">
+              <a:lnSpc>
+                <a:spcPct val="120000"/>
+              </a:lnSpc>
+              <a:spcBef>
+                <a:spcPct val="0"/>
+              </a:spcBef>
+              <a:spcAft>
+                <a:spcPct val="0"/>
+              </a:spcAft>
+              <a:defRPr/>
+            </a:pPr>
+            <a:r>
+              <a:rPr lang="en-GB" sz="2000" b="1" kern="0" dirty="0">
+                <a:solidFill>
+                  <a:srgbClr val="FFFFFF"/>
+                </a:solidFill>
+                <a:latin typeface="Arial"/>
+                <a:cs typeface="Arial"/>
+              </a:rPr>
+              <a:t>About</a:t>
+            </a:r>
+            <a:r>
+              <a:rPr lang="en-GB" sz="2000" b="1" kern="0" noProof="0" dirty="0">
+                <a:solidFill>
+                  <a:srgbClr val="FFFFFF"/>
+                </a:solidFill>
+                <a:latin typeface="Arial"/>
+                <a:cs typeface="Arial"/>
+              </a:rPr>
+              <a:t> the future </a:t>
+            </a:r>
+            <a:endParaRPr lang="en-GB" sz="2000" b="1" i="1" kern="0" baseline="30000" noProof="0" dirty="0">
+              <a:solidFill>
+                <a:srgbClr val="FFFFFF"/>
+              </a:solidFill>
+              <a:latin typeface="Arial"/>
+              <a:cs typeface="Arial"/>
+            </a:endParaRPr>
+          </a:p>
+        </p:txBody>
+      </p:sp>
+    </p:spTree>
+    <p:extLst>
+      <p:ext uri="{BB962C8B-B14F-4D97-AF65-F5344CB8AC3E}">
+        <p14:creationId xmlns:p14="http://schemas.microsoft.com/office/powerpoint/2010/main" val="3854629248"/>
+      </p:ext>
+    </p:extLst>
+  </p:cSld>
+  <p:clrMapOvr>
+    <a:masterClrMapping/>
+  </p:clrMapOvr>
+</p:sld>
+</file>
+
+<file path=ppt/slides/slide13.xml><?xml version="1.0" encoding="utf-8"?>
+<p:sld xmlns:a="http://schemas.openxmlformats.org/drawingml/2006/main" xmlns:r="http://schemas.openxmlformats.org/officeDocument/2006/relationships" xmlns:p="http://schemas.openxmlformats.org/presentationml/2006/main">
+  <p:cSld>
+    <p:spTree>
+      <p:nvGrpSpPr>
+        <p:cNvPr id="1" name="">
+          <a:extLst>
+            <a:ext uri="{FF2B5EF4-FFF2-40B4-BE49-F238E27FC236}">
+              <a16:creationId xmlns:a16="http://schemas.microsoft.com/office/drawing/2014/main" id="{A57008C3-ED2D-EB62-394B-433722099C04}"/>
+            </a:ext>
+          </a:extLst>
+        </p:cNvPr>
+        <p:cNvGrpSpPr/>
+        <p:nvPr/>
+      </p:nvGrpSpPr>
+      <p:grpSpPr>
+        <a:xfrm>
+          <a:off x="0" y="0"/>
+          <a:ext cx="0" cy="0"/>
+          <a:chOff x="0" y="0"/>
+          <a:chExt cx="0" cy="0"/>
+        </a:xfrm>
+      </p:grpSpPr>
+      <p:sp>
+        <p:nvSpPr>
+          <p:cNvPr id="2" name="Titel 1">
+            <a:extLst>
+              <a:ext uri="{FF2B5EF4-FFF2-40B4-BE49-F238E27FC236}">
+                <a16:creationId xmlns:a16="http://schemas.microsoft.com/office/drawing/2014/main" id="{0D9A040E-1E96-2C07-B001-F42A0250F033}"/>
+              </a:ext>
+            </a:extLst>
+          </p:cNvPr>
+          <p:cNvSpPr>
+            <a:spLocks noGrp="1"/>
+          </p:cNvSpPr>
+          <p:nvPr>
+            <p:ph type="title"/>
+          </p:nvPr>
+        </p:nvSpPr>
+        <p:spPr/>
+        <p:txBody>
+          <a:bodyPr/>
+          <a:lstStyle/>
+          <a:p>
+            <a:endParaRPr lang="en-GB" noProof="0" dirty="0"/>
+          </a:p>
+        </p:txBody>
+      </p:sp>
+      <p:sp>
+        <p:nvSpPr>
+          <p:cNvPr id="3" name="Inhaltsplatzhalter 2">
+            <a:extLst>
+              <a:ext uri="{FF2B5EF4-FFF2-40B4-BE49-F238E27FC236}">
+                <a16:creationId xmlns:a16="http://schemas.microsoft.com/office/drawing/2014/main" id="{F3F8CDC0-BC9F-14E4-28C1-E083C63F0BC5}"/>
+              </a:ext>
+            </a:extLst>
+          </p:cNvPr>
+          <p:cNvSpPr>
+            <a:spLocks noGrp="1"/>
+          </p:cNvSpPr>
+          <p:nvPr>
+            <p:ph idx="1"/>
+          </p:nvPr>
+        </p:nvSpPr>
+        <p:spPr/>
+        <p:txBody>
+          <a:bodyPr/>
+          <a:lstStyle/>
+          <a:p>
+            <a:endParaRPr lang="en-GB" noProof="0" dirty="0"/>
+          </a:p>
+        </p:txBody>
+      </p:sp>
+      <p:sp>
+        <p:nvSpPr>
+          <p:cNvPr id="4" name="Datumsplatzhalter 3">
+            <a:extLst>
+              <a:ext uri="{FF2B5EF4-FFF2-40B4-BE49-F238E27FC236}">
+                <a16:creationId xmlns:a16="http://schemas.microsoft.com/office/drawing/2014/main" id="{79CDA017-7409-470C-BDAC-910FD8EBC774}"/>
+              </a:ext>
+            </a:extLst>
+          </p:cNvPr>
+          <p:cNvSpPr>
+            <a:spLocks noGrp="1"/>
+          </p:cNvSpPr>
+          <p:nvPr>
+            <p:ph type="dt" sz="half" idx="10"/>
+          </p:nvPr>
+        </p:nvSpPr>
+        <p:spPr/>
+        <p:txBody>
+          <a:bodyPr/>
+          <a:lstStyle/>
+          <a:p>
+            <a:r>
+              <a:rPr lang="en-GB" noProof="0" dirty="0"/>
+              <a:t>23.02.2026</a:t>
+            </a:r>
+          </a:p>
+        </p:txBody>
+      </p:sp>
+      <p:sp>
+        <p:nvSpPr>
+          <p:cNvPr id="5" name="Foliennummernplatzhalter 4">
+            <a:extLst>
+              <a:ext uri="{FF2B5EF4-FFF2-40B4-BE49-F238E27FC236}">
+                <a16:creationId xmlns:a16="http://schemas.microsoft.com/office/drawing/2014/main" id="{44323A6F-8BD8-7FEF-6E7C-D070DC6A6CAC}"/>
+              </a:ext>
+            </a:extLst>
+          </p:cNvPr>
+          <p:cNvSpPr>
+            <a:spLocks noGrp="1"/>
+          </p:cNvSpPr>
+          <p:nvPr>
+            <p:ph type="sldNum" sz="quarter" idx="12"/>
+          </p:nvPr>
+        </p:nvSpPr>
+        <p:spPr/>
+        <p:txBody>
+          <a:bodyPr/>
+          <a:lstStyle/>
+          <a:p>
+            <a:fld id="{533690DF-FFD6-462A-8578-786984FF8DCB}" type="slidenum">
+              <a:rPr lang="en-GB" noProof="0" smtClean="0"/>
+              <a:t>13</a:t>
+            </a:fld>
+            <a:endParaRPr lang="en-GB" noProof="0" dirty="0"/>
+          </a:p>
+        </p:txBody>
+      </p:sp>
+      <p:sp>
+        <p:nvSpPr>
+          <p:cNvPr id="8" name="Rectangle: Rounded Corners 3">
+            <a:extLst>
+              <a:ext uri="{FF2B5EF4-FFF2-40B4-BE49-F238E27FC236}">
+                <a16:creationId xmlns:a16="http://schemas.microsoft.com/office/drawing/2014/main" id="{9F550BB5-19AF-75E8-64F7-05BABF369E56}"/>
+              </a:ext>
+            </a:extLst>
+          </p:cNvPr>
+          <p:cNvSpPr/>
+          <p:nvPr/>
+        </p:nvSpPr>
+        <p:spPr bwMode="auto">
+          <a:xfrm>
+            <a:off x="334962" y="365125"/>
+            <a:ext cx="11522076" cy="5811838"/>
+          </a:xfrm>
+          <a:prstGeom prst="roundRect">
+            <a:avLst>
+              <a:gd name="adj" fmla="val 9662"/>
+            </a:avLst>
+          </a:prstGeom>
+          <a:solidFill>
+            <a:srgbClr val="0A8276"/>
+          </a:solidFill>
+          <a:ln w="9525">
+            <a:noFill/>
+            <a:miter lim="800000"/>
+            <a:headEnd/>
+            <a:tailEnd/>
+          </a:ln>
+        </p:spPr>
+        <p:txBody>
+          <a:bodyPr rot="0" spcFirstLastPara="0" vertOverflow="overflow" horzOverflow="overflow" vert="horz" wrap="square" lIns="72000" tIns="72000" rIns="72000" bIns="72000" numCol="1" spcCol="0" rtlCol="0" fromWordArt="0" anchor="ctr" anchorCtr="0" forceAA="0" compatLnSpc="1">
+            <a:prstTxWarp prst="textNoShape">
+              <a:avLst/>
+            </a:prstTxWarp>
+            <a:noAutofit/>
+          </a:bodyPr>
+          <a:lstStyle/>
+          <a:p>
+            <a:pPr algn="ctr" defTabSz="576000" eaLnBrk="0" fontAlgn="base" hangingPunct="0">
+              <a:lnSpc>
+                <a:spcPct val="120000"/>
+              </a:lnSpc>
+              <a:spcBef>
+                <a:spcPct val="0"/>
+              </a:spcBef>
+              <a:spcAft>
+                <a:spcPct val="0"/>
+              </a:spcAft>
+              <a:defRPr/>
+            </a:pPr>
+            <a:r>
+              <a:rPr lang="en-GB" sz="6000" b="1" kern="0" noProof="0" dirty="0">
+                <a:solidFill>
+                  <a:srgbClr val="FFFFFF"/>
+                </a:solidFill>
+                <a:latin typeface="Arial"/>
+                <a:cs typeface="Arial"/>
+              </a:rPr>
+              <a:t>Demonstration</a:t>
+            </a:r>
+            <a:r>
+              <a:rPr lang="en-GB" sz="2000" b="1" kern="0" noProof="0" dirty="0">
+                <a:solidFill>
+                  <a:srgbClr val="FFFFFF"/>
+                </a:solidFill>
+                <a:latin typeface="Arial"/>
+                <a:cs typeface="Arial"/>
+              </a:rPr>
+              <a:t> </a:t>
+            </a:r>
+            <a:endParaRPr lang="en-GB" sz="2000" b="1" i="1" kern="0" baseline="30000" noProof="0" dirty="0">
+              <a:solidFill>
+                <a:srgbClr val="FFFFFF"/>
+              </a:solidFill>
+              <a:latin typeface="Arial"/>
+              <a:cs typeface="Arial"/>
+            </a:endParaRPr>
+          </a:p>
+        </p:txBody>
+      </p:sp>
+    </p:spTree>
+    <p:extLst>
+      <p:ext uri="{BB962C8B-B14F-4D97-AF65-F5344CB8AC3E}">
+        <p14:creationId xmlns:p14="http://schemas.microsoft.com/office/powerpoint/2010/main" val="2089918606"/>
+      </p:ext>
+    </p:extLst>
+  </p:cSld>
+  <p:clrMapOvr>
+    <a:masterClrMapping/>
+  </p:clrMapOvr>
+</p:sld>
+</file>
+
+<file path=ppt/slides/slide14.xml><?xml version="1.0" encoding="utf-8"?>
 <p:sld xmlns:a="http://schemas.openxmlformats.org/drawingml/2006/main" xmlns:r="http://schemas.openxmlformats.org/officeDocument/2006/relationships" xmlns:p="http://schemas.openxmlformats.org/presentationml/2006/main">
   <p:cSld>
     <p:spTree>
@@ -4157,7 +5272,7 @@
           <a:p>
             <a:fld id="{533690DF-FFD6-462A-8578-786984FF8DCB}" type="slidenum">
               <a:rPr lang="en-GB" noProof="0" smtClean="0"/>
-              <a:t>10</a:t>
+              <a:t>14</a:t>
             </a:fld>
             <a:endParaRPr lang="en-GB" noProof="0" dirty="0"/>
           </a:p>
@@ -4352,13 +5467,13 @@
           <a:p>
             <a:r>
               <a:rPr lang="en-GB" noProof="0" dirty="0"/>
-              <a:t>Helping boxers to analyse their performance</a:t>
+              <a:t>Helping boxers to analyse their performance in training</a:t>
             </a:r>
           </a:p>
           <a:p>
             <a:r>
               <a:rPr lang="en-GB" noProof="0" dirty="0"/>
-              <a:t>Understanding what combinations are used often</a:t>
+              <a:t>Understanding what combinations are used often to prevent developing tendencies/predictability</a:t>
             </a:r>
           </a:p>
           <a:p>
@@ -5157,8 +6272,8 @@
         </p:nvSpPr>
         <p:spPr bwMode="auto">
           <a:xfrm>
-            <a:off x="712312" y="681037"/>
-            <a:ext cx="5343971" cy="828438"/>
+            <a:off x="381000" y="681037"/>
+            <a:ext cx="5675283" cy="828438"/>
           </a:xfrm>
           <a:prstGeom prst="roundRect">
             <a:avLst>
@@ -5320,16 +6435,26 @@
             </a:r>
           </a:p>
           <a:p>
+            <a:pPr lvl="1"/>
             <a:r>
               <a:rPr lang="en-GB" dirty="0"/>
-              <a:t>Data was sampled of all three members each using different types of speed and technique</a:t>
+              <a:t>Only used right hand for punches</a:t>
             </a:r>
           </a:p>
           <a:p>
             <a:r>
               <a:rPr lang="en-GB" dirty="0"/>
-              <a:t>Testing showed that using smaller sliding windows and small prediction frequencies increased accuracy of model</a:t>
-            </a:r>
+              <a:t>Data of all three members was gathered using different types of speed and technique</a:t>
+            </a:r>
+          </a:p>
+          <a:p>
+            <a:r>
+              <a:rPr lang="en-GB" dirty="0"/>
+              <a:t>The IMU Frequency was set to 400Hz</a:t>
+            </a:r>
+          </a:p>
+          <a:p>
+            <a:endParaRPr lang="en-GB" dirty="0"/>
           </a:p>
           <a:p>
             <a:endParaRPr lang="en-GB" dirty="0"/>
@@ -5454,7 +6579,7 @@
                 <a:latin typeface="Arial"/>
                 <a:cs typeface="Arial"/>
               </a:rPr>
-              <a:t>Data sampling &amp; Model Creation</a:t>
+              <a:t>Data sampling</a:t>
             </a:r>
             <a:endParaRPr lang="en-GB" sz="2000" b="1" i="1" kern="0" baseline="30000" noProof="0" dirty="0">
               <a:solidFill>
@@ -5466,6 +6591,96 @@
           </a:p>
         </p:txBody>
       </p:sp>
+      <p:pic>
+        <p:nvPicPr>
+          <p:cNvPr id="7" name="Grafik 6" descr="Ein Bild, das Screenshot, Reihe, Diagramm enthält.&#10;&#10;KI-generierte Inhalte können fehlerhaft sein.">
+            <a:extLst>
+              <a:ext uri="{FF2B5EF4-FFF2-40B4-BE49-F238E27FC236}">
+                <a16:creationId xmlns:a16="http://schemas.microsoft.com/office/drawing/2014/main" id="{2A3B606C-7B43-593F-9DDF-7503F18C3E45}"/>
+              </a:ext>
+            </a:extLst>
+          </p:cNvPr>
+          <p:cNvPicPr>
+            <a:picLocks noChangeAspect="1"/>
+          </p:cNvPicPr>
+          <p:nvPr/>
+        </p:nvPicPr>
+        <p:blipFill>
+          <a:blip r:embed="rId2"/>
+          <a:stretch>
+            <a:fillRect/>
+          </a:stretch>
+        </p:blipFill>
+        <p:spPr>
+          <a:xfrm>
+            <a:off x="1614342" y="4518058"/>
+            <a:ext cx="1643208" cy="1838292"/>
+          </a:xfrm>
+          <a:prstGeom prst="rect">
+            <a:avLst/>
+          </a:prstGeom>
+        </p:spPr>
+      </p:pic>
+      <p:pic>
+        <p:nvPicPr>
+          <p:cNvPr id="10" name="Grafik 9" descr="Ein Bild, das Reihe, Screenshot, Diagramm, Kunst enthält.&#10;&#10;KI-generierte Inhalte können fehlerhaft sein.">
+            <a:extLst>
+              <a:ext uri="{FF2B5EF4-FFF2-40B4-BE49-F238E27FC236}">
+                <a16:creationId xmlns:a16="http://schemas.microsoft.com/office/drawing/2014/main" id="{886BAB85-2640-7874-C35E-F3A93383E4D7}"/>
+              </a:ext>
+            </a:extLst>
+          </p:cNvPr>
+          <p:cNvPicPr>
+            <a:picLocks noChangeAspect="1"/>
+          </p:cNvPicPr>
+          <p:nvPr/>
+        </p:nvPicPr>
+        <p:blipFill>
+          <a:blip r:embed="rId3"/>
+          <a:stretch>
+            <a:fillRect/>
+          </a:stretch>
+        </p:blipFill>
+        <p:spPr>
+          <a:xfrm>
+            <a:off x="4726682" y="4518058"/>
+            <a:ext cx="2414785" cy="1838292"/>
+          </a:xfrm>
+          <a:prstGeom prst="rect">
+            <a:avLst/>
+          </a:prstGeom>
+        </p:spPr>
+      </p:pic>
+      <p:pic>
+        <p:nvPicPr>
+          <p:cNvPr id="12" name="Grafik 11" descr="Ein Bild, das Reihe, Screenshot, Diagramm, Design enthält.&#10;&#10;KI-generierte Inhalte können fehlerhaft sein.">
+            <a:extLst>
+              <a:ext uri="{FF2B5EF4-FFF2-40B4-BE49-F238E27FC236}">
+                <a16:creationId xmlns:a16="http://schemas.microsoft.com/office/drawing/2014/main" id="{9133DA99-03BE-85E7-B6D6-8A7A57F03725}"/>
+              </a:ext>
+            </a:extLst>
+          </p:cNvPr>
+          <p:cNvPicPr>
+            <a:picLocks noChangeAspect="1"/>
+          </p:cNvPicPr>
+          <p:nvPr/>
+        </p:nvPicPr>
+        <p:blipFill>
+          <a:blip r:embed="rId4"/>
+          <a:stretch>
+            <a:fillRect/>
+          </a:stretch>
+        </p:blipFill>
+        <p:spPr>
+          <a:xfrm>
+            <a:off x="8610599" y="4518056"/>
+            <a:ext cx="2067213" cy="1838293"/>
+          </a:xfrm>
+          <a:prstGeom prst="rect">
+            <a:avLst/>
+          </a:prstGeom>
+        </p:spPr>
+      </p:pic>
     </p:spTree>
     <p:extLst>
       <p:ext uri="{BB962C8B-B14F-4D97-AF65-F5344CB8AC3E}">
@@ -5480,248 +6695,6 @@
 </file>
 
 <file path=ppt/slides/slide5.xml><?xml version="1.0" encoding="utf-8"?>
-<p:sld xmlns:a="http://schemas.openxmlformats.org/drawingml/2006/main" xmlns:r="http://schemas.openxmlformats.org/officeDocument/2006/relationships" xmlns:p="http://schemas.openxmlformats.org/presentationml/2006/main">
-  <p:cSld>
-    <p:spTree>
-      <p:nvGrpSpPr>
-        <p:cNvPr id="1" name="">
-          <a:extLst>
-            <a:ext uri="{FF2B5EF4-FFF2-40B4-BE49-F238E27FC236}">
-              <a16:creationId xmlns:a16="http://schemas.microsoft.com/office/drawing/2014/main" id="{BA88F5AF-2E23-BEFE-6BC1-B4D534AFB1B6}"/>
-            </a:ext>
-          </a:extLst>
-        </p:cNvPr>
-        <p:cNvGrpSpPr/>
-        <p:nvPr/>
-      </p:nvGrpSpPr>
-      <p:grpSpPr>
-        <a:xfrm>
-          <a:off x="0" y="0"/>
-          <a:ext cx="0" cy="0"/>
-          <a:chOff x="0" y="0"/>
-          <a:chExt cx="0" cy="0"/>
-        </a:xfrm>
-      </p:grpSpPr>
-      <p:sp>
-        <p:nvSpPr>
-          <p:cNvPr id="2" name="Titel 1">
-            <a:extLst>
-              <a:ext uri="{FF2B5EF4-FFF2-40B4-BE49-F238E27FC236}">
-                <a16:creationId xmlns:a16="http://schemas.microsoft.com/office/drawing/2014/main" id="{E9F140C5-9AA7-C982-774A-2DE2FE881DE4}"/>
-              </a:ext>
-            </a:extLst>
-          </p:cNvPr>
-          <p:cNvSpPr>
-            <a:spLocks noGrp="1"/>
-          </p:cNvSpPr>
-          <p:nvPr>
-            <p:ph type="title"/>
-          </p:nvPr>
-        </p:nvSpPr>
-        <p:spPr/>
-        <p:txBody>
-          <a:bodyPr/>
-          <a:lstStyle/>
-          <a:p>
-            <a:endParaRPr lang="en-GB" noProof="0" dirty="0"/>
-          </a:p>
-        </p:txBody>
-      </p:sp>
-      <p:sp>
-        <p:nvSpPr>
-          <p:cNvPr id="3" name="Inhaltsplatzhalter 2">
-            <a:extLst>
-              <a:ext uri="{FF2B5EF4-FFF2-40B4-BE49-F238E27FC236}">
-                <a16:creationId xmlns:a16="http://schemas.microsoft.com/office/drawing/2014/main" id="{16E70A6D-D365-C64A-387A-75AAE10CB406}"/>
-              </a:ext>
-            </a:extLst>
-          </p:cNvPr>
-          <p:cNvSpPr>
-            <a:spLocks noGrp="1"/>
-          </p:cNvSpPr>
-          <p:nvPr>
-            <p:ph idx="1"/>
-          </p:nvPr>
-        </p:nvSpPr>
-        <p:spPr/>
-        <p:txBody>
-          <a:bodyPr/>
-          <a:lstStyle/>
-          <a:p>
-            <a:r>
-              <a:rPr lang="en-GB" noProof="0" dirty="0"/>
-              <a:t>Overlapping labels</a:t>
-            </a:r>
-          </a:p>
-          <a:p>
-            <a:r>
-              <a:rPr lang="en-GB" dirty="0"/>
-              <a:t>Code generation only worked for one member</a:t>
-            </a:r>
-          </a:p>
-          <a:p>
-            <a:r>
-              <a:rPr lang="en-GB" noProof="0" dirty="0"/>
-              <a:t>No clear indications on what ma</a:t>
-            </a:r>
-            <a:r>
-              <a:rPr lang="en-GB" dirty="0" err="1"/>
-              <a:t>kes</a:t>
-            </a:r>
-            <a:r>
-              <a:rPr lang="en-GB" dirty="0"/>
-              <a:t> model better or worse</a:t>
-            </a:r>
-          </a:p>
-          <a:p>
-            <a:endParaRPr lang="en-GB" noProof="0" dirty="0"/>
-          </a:p>
-        </p:txBody>
-      </p:sp>
-      <p:sp>
-        <p:nvSpPr>
-          <p:cNvPr id="4" name="Datumsplatzhalter 3">
-            <a:extLst>
-              <a:ext uri="{FF2B5EF4-FFF2-40B4-BE49-F238E27FC236}">
-                <a16:creationId xmlns:a16="http://schemas.microsoft.com/office/drawing/2014/main" id="{A662B3FA-00C1-9EE6-1D74-E4B044BBECD8}"/>
-              </a:ext>
-            </a:extLst>
-          </p:cNvPr>
-          <p:cNvSpPr>
-            <a:spLocks noGrp="1"/>
-          </p:cNvSpPr>
-          <p:nvPr>
-            <p:ph type="dt" sz="half" idx="10"/>
-          </p:nvPr>
-        </p:nvSpPr>
-        <p:spPr/>
-        <p:txBody>
-          <a:bodyPr/>
-          <a:lstStyle/>
-          <a:p>
-            <a:r>
-              <a:rPr lang="en-GB" noProof="0" dirty="0"/>
-              <a:t>23.02.2026</a:t>
-            </a:r>
-          </a:p>
-        </p:txBody>
-      </p:sp>
-      <p:sp>
-        <p:nvSpPr>
-          <p:cNvPr id="5" name="Foliennummernplatzhalter 4">
-            <a:extLst>
-              <a:ext uri="{FF2B5EF4-FFF2-40B4-BE49-F238E27FC236}">
-                <a16:creationId xmlns:a16="http://schemas.microsoft.com/office/drawing/2014/main" id="{1358572C-AB05-ECD6-B505-C87F61376D78}"/>
-              </a:ext>
-            </a:extLst>
-          </p:cNvPr>
-          <p:cNvSpPr>
-            <a:spLocks noGrp="1"/>
-          </p:cNvSpPr>
-          <p:nvPr>
-            <p:ph type="sldNum" sz="quarter" idx="12"/>
-          </p:nvPr>
-        </p:nvSpPr>
-        <p:spPr/>
-        <p:txBody>
-          <a:bodyPr/>
-          <a:lstStyle/>
-          <a:p>
-            <a:fld id="{533690DF-FFD6-462A-8578-786984FF8DCB}" type="slidenum">
-              <a:rPr lang="en-GB" noProof="0" smtClean="0"/>
-              <a:t>5</a:t>
-            </a:fld>
-            <a:endParaRPr lang="en-GB" noProof="0" dirty="0"/>
-          </a:p>
-        </p:txBody>
-      </p:sp>
-      <p:sp>
-        <p:nvSpPr>
-          <p:cNvPr id="8" name="Rectangle: Rounded Corners 3">
-            <a:extLst>
-              <a:ext uri="{FF2B5EF4-FFF2-40B4-BE49-F238E27FC236}">
-                <a16:creationId xmlns:a16="http://schemas.microsoft.com/office/drawing/2014/main" id="{2B3438B7-EF5B-59AA-36AC-D1B6B1D0A3AA}"/>
-              </a:ext>
-            </a:extLst>
-          </p:cNvPr>
-          <p:cNvSpPr/>
-          <p:nvPr/>
-        </p:nvSpPr>
-        <p:spPr bwMode="auto">
-          <a:xfrm>
-            <a:off x="388302" y="681037"/>
-            <a:ext cx="11522076" cy="828438"/>
-          </a:xfrm>
-          <a:prstGeom prst="roundRect">
-            <a:avLst>
-              <a:gd name="adj" fmla="val 9662"/>
-            </a:avLst>
-          </a:prstGeom>
-          <a:solidFill>
-            <a:srgbClr val="0A8276"/>
-          </a:solidFill>
-          <a:ln w="9525">
-            <a:noFill/>
-            <a:miter lim="800000"/>
-            <a:headEnd/>
-            <a:tailEnd/>
-          </a:ln>
-        </p:spPr>
-        <p:txBody>
-          <a:bodyPr rot="0" spcFirstLastPara="0" vertOverflow="overflow" horzOverflow="overflow" vert="horz" wrap="square" lIns="72000" tIns="72000" rIns="72000" bIns="72000" numCol="1" spcCol="0" rtlCol="0" fromWordArt="0" anchor="ctr" anchorCtr="0" forceAA="0" compatLnSpc="1">
-            <a:prstTxWarp prst="textNoShape">
-              <a:avLst/>
-            </a:prstTxWarp>
-            <a:noAutofit/>
-          </a:bodyPr>
-          <a:lstStyle/>
-          <a:p>
-            <a:pPr defTabSz="576000" eaLnBrk="0" fontAlgn="base" hangingPunct="0">
-              <a:lnSpc>
-                <a:spcPct val="120000"/>
-              </a:lnSpc>
-              <a:spcBef>
-                <a:spcPct val="0"/>
-              </a:spcBef>
-              <a:spcAft>
-                <a:spcPct val="0"/>
-              </a:spcAft>
-              <a:defRPr/>
-            </a:pPr>
-            <a:r>
-              <a:rPr lang="en-GB" sz="2000" b="1" kern="0" noProof="0" dirty="0">
-                <a:solidFill>
-                  <a:srgbClr val="FFFFFF"/>
-                </a:solidFill>
-                <a:latin typeface="Arial"/>
-                <a:cs typeface="Arial"/>
-              </a:rPr>
-              <a:t>Problems faced</a:t>
-            </a:r>
-            <a:endParaRPr lang="en-GB" sz="2000" b="1" i="1" kern="0" baseline="30000" noProof="0" dirty="0">
-              <a:solidFill>
-                <a:srgbClr val="FFFFFF"/>
-              </a:solidFill>
-              <a:latin typeface="Arial"/>
-              <a:cs typeface="Arial"/>
-            </a:endParaRPr>
-          </a:p>
-        </p:txBody>
-      </p:sp>
-    </p:spTree>
-    <p:extLst>
-      <p:ext uri="{BB962C8B-B14F-4D97-AF65-F5344CB8AC3E}">
-        <p14:creationId xmlns:p14="http://schemas.microsoft.com/office/powerpoint/2010/main" val="616278457"/>
-      </p:ext>
-    </p:extLst>
-  </p:cSld>
-  <p:clrMapOvr>
-    <a:masterClrMapping/>
-  </p:clrMapOvr>
-</p:sld>
-</file>
-
-<file path=ppt/slides/slide6.xml><?xml version="1.0" encoding="utf-8"?>
 <p:sld xmlns:a="http://schemas.openxmlformats.org/drawingml/2006/main" xmlns:r="http://schemas.openxmlformats.org/officeDocument/2006/relationships" xmlns:p="http://schemas.openxmlformats.org/presentationml/2006/main">
   <p:cSld>
     <p:spTree>
@@ -5792,12 +6765,29 @@
           <a:p>
             <a:r>
               <a:rPr lang="en-GB" noProof="0" dirty="0"/>
-              <a:t>As the difference was too great in sampled data only data of one creator was used </a:t>
-            </a:r>
+              <a:t>Only Data of one person was used to achieve greater accuracy</a:t>
+            </a:r>
+            <a:endParaRPr lang="en-GB" dirty="0"/>
+          </a:p>
+          <a:p>
             <a:r>
               <a:rPr lang="en-GB" dirty="0"/>
-              <a:t>to create final model</a:t>
-            </a:r>
+              <a:t>Train/Validation/Test split is roughly 60/20/20</a:t>
+            </a:r>
+          </a:p>
+          <a:p>
+            <a:r>
+              <a:rPr lang="en-GB" dirty="0"/>
+              <a:t>45 minutes of data, 18,5 of which are labelled</a:t>
+            </a:r>
+          </a:p>
+          <a:p>
+            <a:r>
+              <a:rPr lang="en-GB" dirty="0"/>
+              <a:t>Implemented negative Data (warming up, neither distinct punches nor no movement)</a:t>
+            </a:r>
+          </a:p>
+          <a:p>
             <a:endParaRPr lang="en-GB" noProof="0" dirty="0"/>
           </a:p>
         </p:txBody>
@@ -5853,7 +6843,7 @@
           <a:p>
             <a:fld id="{533690DF-FFD6-462A-8578-786984FF8DCB}" type="slidenum">
               <a:rPr lang="en-GB" noProof="0" smtClean="0"/>
-              <a:t>6</a:t>
+              <a:t>5</a:t>
             </a:fld>
             <a:endParaRPr lang="en-GB" noProof="0" dirty="0"/>
           </a:p>
@@ -5932,6 +6922,36 @@
           </a:p>
         </p:txBody>
       </p:sp>
+      <p:pic>
+        <p:nvPicPr>
+          <p:cNvPr id="7" name="Grafik 6" descr="Ein Bild, das Screenshot, Text, Zahl, Schrift enthält.&#10;&#10;KI-generierte Inhalte können fehlerhaft sein.">
+            <a:extLst>
+              <a:ext uri="{FF2B5EF4-FFF2-40B4-BE49-F238E27FC236}">
+                <a16:creationId xmlns:a16="http://schemas.microsoft.com/office/drawing/2014/main" id="{2C1A04C6-7FBD-7DB9-72D3-5B7FB8DD7C34}"/>
+              </a:ext>
+            </a:extLst>
+          </p:cNvPr>
+          <p:cNvPicPr>
+            <a:picLocks noChangeAspect="1"/>
+          </p:cNvPicPr>
+          <p:nvPr/>
+        </p:nvPicPr>
+        <p:blipFill>
+          <a:blip r:embed="rId2"/>
+          <a:stretch>
+            <a:fillRect/>
+          </a:stretch>
+        </p:blipFill>
+        <p:spPr>
+          <a:xfrm>
+            <a:off x="2513335" y="4254368"/>
+            <a:ext cx="7272010" cy="2101982"/>
+          </a:xfrm>
+          <a:prstGeom prst="rect">
+            <a:avLst/>
+          </a:prstGeom>
+        </p:spPr>
+      </p:pic>
     </p:spTree>
     <p:extLst>
       <p:ext uri="{BB962C8B-B14F-4D97-AF65-F5344CB8AC3E}">
@@ -5945,9 +6965,479 @@
 </p:sld>
 </file>
 
+<file path=ppt/slides/slide6.xml><?xml version="1.0" encoding="utf-8"?>
+<p:sld xmlns:a="http://schemas.openxmlformats.org/drawingml/2006/main" xmlns:r="http://schemas.openxmlformats.org/officeDocument/2006/relationships" xmlns:p="http://schemas.openxmlformats.org/presentationml/2006/main">
+  <p:cSld>
+    <p:spTree>
+      <p:nvGrpSpPr>
+        <p:cNvPr id="1" name="">
+          <a:extLst>
+            <a:ext uri="{FF2B5EF4-FFF2-40B4-BE49-F238E27FC236}">
+              <a16:creationId xmlns:a16="http://schemas.microsoft.com/office/drawing/2014/main" id="{4CC4AA44-61AD-F664-DB0E-92EA8157D7BB}"/>
+            </a:ext>
+          </a:extLst>
+        </p:cNvPr>
+        <p:cNvGrpSpPr/>
+        <p:nvPr/>
+      </p:nvGrpSpPr>
+      <p:grpSpPr>
+        <a:xfrm>
+          <a:off x="0" y="0"/>
+          <a:ext cx="0" cy="0"/>
+          <a:chOff x="0" y="0"/>
+          <a:chExt cx="0" cy="0"/>
+        </a:xfrm>
+      </p:grpSpPr>
+      <p:sp>
+        <p:nvSpPr>
+          <p:cNvPr id="2" name="Titel 1">
+            <a:extLst>
+              <a:ext uri="{FF2B5EF4-FFF2-40B4-BE49-F238E27FC236}">
+                <a16:creationId xmlns:a16="http://schemas.microsoft.com/office/drawing/2014/main" id="{49CFFF75-DD03-697D-B265-C835B0118C8F}"/>
+              </a:ext>
+            </a:extLst>
+          </p:cNvPr>
+          <p:cNvSpPr>
+            <a:spLocks noGrp="1"/>
+          </p:cNvSpPr>
+          <p:nvPr>
+            <p:ph type="title"/>
+          </p:nvPr>
+        </p:nvSpPr>
+        <p:spPr/>
+        <p:txBody>
+          <a:bodyPr/>
+          <a:lstStyle/>
+          <a:p>
+            <a:endParaRPr lang="en-GB" noProof="0" dirty="0"/>
+          </a:p>
+        </p:txBody>
+      </p:sp>
+      <p:sp>
+        <p:nvSpPr>
+          <p:cNvPr id="4" name="Datumsplatzhalter 3">
+            <a:extLst>
+              <a:ext uri="{FF2B5EF4-FFF2-40B4-BE49-F238E27FC236}">
+                <a16:creationId xmlns:a16="http://schemas.microsoft.com/office/drawing/2014/main" id="{AB15BA3A-6FC4-9E95-9E85-C621A22BD6E0}"/>
+              </a:ext>
+            </a:extLst>
+          </p:cNvPr>
+          <p:cNvSpPr>
+            <a:spLocks noGrp="1"/>
+          </p:cNvSpPr>
+          <p:nvPr>
+            <p:ph type="dt" sz="half" idx="10"/>
+          </p:nvPr>
+        </p:nvSpPr>
+        <p:spPr/>
+        <p:txBody>
+          <a:bodyPr/>
+          <a:lstStyle/>
+          <a:p>
+            <a:r>
+              <a:rPr lang="en-GB" noProof="0" dirty="0"/>
+              <a:t>23.02.2026</a:t>
+            </a:r>
+          </a:p>
+        </p:txBody>
+      </p:sp>
+      <p:sp>
+        <p:nvSpPr>
+          <p:cNvPr id="5" name="Foliennummernplatzhalter 4">
+            <a:extLst>
+              <a:ext uri="{FF2B5EF4-FFF2-40B4-BE49-F238E27FC236}">
+                <a16:creationId xmlns:a16="http://schemas.microsoft.com/office/drawing/2014/main" id="{804E4EFE-C314-C370-F090-1B891EF01289}"/>
+              </a:ext>
+            </a:extLst>
+          </p:cNvPr>
+          <p:cNvSpPr>
+            <a:spLocks noGrp="1"/>
+          </p:cNvSpPr>
+          <p:nvPr>
+            <p:ph type="sldNum" sz="quarter" idx="12"/>
+          </p:nvPr>
+        </p:nvSpPr>
+        <p:spPr/>
+        <p:txBody>
+          <a:bodyPr/>
+          <a:lstStyle/>
+          <a:p>
+            <a:fld id="{533690DF-FFD6-462A-8578-786984FF8DCB}" type="slidenum">
+              <a:rPr lang="en-GB" noProof="0" smtClean="0"/>
+              <a:t>6</a:t>
+            </a:fld>
+            <a:endParaRPr lang="en-GB" noProof="0" dirty="0"/>
+          </a:p>
+        </p:txBody>
+      </p:sp>
+      <p:sp>
+        <p:nvSpPr>
+          <p:cNvPr id="8" name="Rectangle: Rounded Corners 3">
+            <a:extLst>
+              <a:ext uri="{FF2B5EF4-FFF2-40B4-BE49-F238E27FC236}">
+                <a16:creationId xmlns:a16="http://schemas.microsoft.com/office/drawing/2014/main" id="{02461553-91C8-D815-FE9B-DE812F985953}"/>
+              </a:ext>
+            </a:extLst>
+          </p:cNvPr>
+          <p:cNvSpPr/>
+          <p:nvPr/>
+        </p:nvSpPr>
+        <p:spPr bwMode="auto">
+          <a:xfrm>
+            <a:off x="388302" y="681037"/>
+            <a:ext cx="11522076" cy="828438"/>
+          </a:xfrm>
+          <a:prstGeom prst="roundRect">
+            <a:avLst>
+              <a:gd name="adj" fmla="val 9662"/>
+            </a:avLst>
+          </a:prstGeom>
+          <a:solidFill>
+            <a:srgbClr val="0A8276"/>
+          </a:solidFill>
+          <a:ln w="9525">
+            <a:noFill/>
+            <a:miter lim="800000"/>
+            <a:headEnd/>
+            <a:tailEnd/>
+          </a:ln>
+        </p:spPr>
+        <p:txBody>
+          <a:bodyPr rot="0" spcFirstLastPara="0" vertOverflow="overflow" horzOverflow="overflow" vert="horz" wrap="square" lIns="72000" tIns="72000" rIns="72000" bIns="72000" numCol="1" spcCol="0" rtlCol="0" fromWordArt="0" anchor="ctr" anchorCtr="0" forceAA="0" compatLnSpc="1">
+            <a:prstTxWarp prst="textNoShape">
+              <a:avLst/>
+            </a:prstTxWarp>
+            <a:noAutofit/>
+          </a:bodyPr>
+          <a:lstStyle/>
+          <a:p>
+            <a:pPr defTabSz="576000" eaLnBrk="0" fontAlgn="base" hangingPunct="0">
+              <a:lnSpc>
+                <a:spcPct val="120000"/>
+              </a:lnSpc>
+              <a:spcBef>
+                <a:spcPct val="0"/>
+              </a:spcBef>
+              <a:spcAft>
+                <a:spcPct val="0"/>
+              </a:spcAft>
+              <a:defRPr/>
+            </a:pPr>
+            <a:r>
+              <a:rPr lang="en-GB" sz="2000" b="1" kern="0" noProof="0" dirty="0">
+                <a:solidFill>
+                  <a:srgbClr val="FFFFFF"/>
+                </a:solidFill>
+                <a:latin typeface="Arial"/>
+                <a:cs typeface="Arial"/>
+              </a:rPr>
+              <a:t>Final Classification</a:t>
+            </a:r>
+            <a:endParaRPr lang="en-GB" sz="2000" b="1" i="1" kern="0" baseline="30000" noProof="0" dirty="0">
+              <a:solidFill>
+                <a:srgbClr val="FFFFFF"/>
+              </a:solidFill>
+              <a:latin typeface="Arial"/>
+              <a:cs typeface="Arial"/>
+            </a:endParaRPr>
+          </a:p>
+        </p:txBody>
+      </p:sp>
+    </p:spTree>
+    <p:extLst>
+      <p:ext uri="{BB962C8B-B14F-4D97-AF65-F5344CB8AC3E}">
+        <p14:creationId xmlns:p14="http://schemas.microsoft.com/office/powerpoint/2010/main" val="970482609"/>
+      </p:ext>
+    </p:extLst>
+  </p:cSld>
+  <p:clrMapOvr>
+    <a:masterClrMapping/>
+  </p:clrMapOvr>
+</p:sld>
+</file>
+
 <file path=ppt/slides/slide7.xml><?xml version="1.0" encoding="utf-8"?>
 <p:sld xmlns:a="http://schemas.openxmlformats.org/drawingml/2006/main" xmlns:r="http://schemas.openxmlformats.org/officeDocument/2006/relationships" xmlns:p="http://schemas.openxmlformats.org/presentationml/2006/main">
   <p:cSld>
+    <p:spTree>
+      <p:nvGrpSpPr>
+        <p:cNvPr id="1" name="">
+          <a:extLst>
+            <a:ext uri="{FF2B5EF4-FFF2-40B4-BE49-F238E27FC236}">
+              <a16:creationId xmlns:a16="http://schemas.microsoft.com/office/drawing/2014/main" id="{280EE75E-5108-46B8-62A9-756FA80008F7}"/>
+            </a:ext>
+          </a:extLst>
+        </p:cNvPr>
+        <p:cNvGrpSpPr/>
+        <p:nvPr/>
+      </p:nvGrpSpPr>
+      <p:grpSpPr>
+        <a:xfrm>
+          <a:off x="0" y="0"/>
+          <a:ext cx="0" cy="0"/>
+          <a:chOff x="0" y="0"/>
+          <a:chExt cx="0" cy="0"/>
+        </a:xfrm>
+      </p:grpSpPr>
+      <p:sp>
+        <p:nvSpPr>
+          <p:cNvPr id="2" name="Titel 1">
+            <a:extLst>
+              <a:ext uri="{FF2B5EF4-FFF2-40B4-BE49-F238E27FC236}">
+                <a16:creationId xmlns:a16="http://schemas.microsoft.com/office/drawing/2014/main" id="{8AE88A22-0200-BECC-3D5A-C1D591067494}"/>
+              </a:ext>
+            </a:extLst>
+          </p:cNvPr>
+          <p:cNvSpPr>
+            <a:spLocks noGrp="1"/>
+          </p:cNvSpPr>
+          <p:nvPr>
+            <p:ph type="title"/>
+          </p:nvPr>
+        </p:nvSpPr>
+        <p:spPr/>
+        <p:txBody>
+          <a:bodyPr/>
+          <a:lstStyle/>
+          <a:p>
+            <a:endParaRPr lang="en-GB" noProof="0" dirty="0"/>
+          </a:p>
+        </p:txBody>
+      </p:sp>
+      <p:sp>
+        <p:nvSpPr>
+          <p:cNvPr id="3" name="Inhaltsplatzhalter 2">
+            <a:extLst>
+              <a:ext uri="{FF2B5EF4-FFF2-40B4-BE49-F238E27FC236}">
+                <a16:creationId xmlns:a16="http://schemas.microsoft.com/office/drawing/2014/main" id="{60F60114-55DF-203C-72A4-F9F8BDFB6CC6}"/>
+              </a:ext>
+            </a:extLst>
+          </p:cNvPr>
+          <p:cNvSpPr>
+            <a:spLocks noGrp="1"/>
+          </p:cNvSpPr>
+          <p:nvPr>
+            <p:ph idx="1"/>
+          </p:nvPr>
+        </p:nvSpPr>
+        <p:spPr/>
+        <p:txBody>
+          <a:bodyPr/>
+          <a:lstStyle/>
+          <a:p>
+            <a:r>
+              <a:rPr lang="en-GB" noProof="0" dirty="0"/>
+              <a:t>Only Data of one person was used to achieve greater accuracy</a:t>
+            </a:r>
+            <a:endParaRPr lang="en-GB" dirty="0"/>
+          </a:p>
+          <a:p>
+            <a:r>
+              <a:rPr lang="en-GB" dirty="0"/>
+              <a:t>Train/Validation/Test split is roughly 60/20/20</a:t>
+            </a:r>
+          </a:p>
+          <a:p>
+            <a:r>
+              <a:rPr lang="en-GB" dirty="0"/>
+              <a:t>45 minutes of data, 18,5 of which are labelled</a:t>
+            </a:r>
+          </a:p>
+          <a:p>
+            <a:r>
+              <a:rPr lang="en-GB" dirty="0"/>
+              <a:t>Implemented negative Data (warming up, neither distinct punches nor no movement)</a:t>
+            </a:r>
+          </a:p>
+          <a:p>
+            <a:endParaRPr lang="en-GB" noProof="0" dirty="0"/>
+          </a:p>
+        </p:txBody>
+      </p:sp>
+      <p:sp>
+        <p:nvSpPr>
+          <p:cNvPr id="4" name="Datumsplatzhalter 3">
+            <a:extLst>
+              <a:ext uri="{FF2B5EF4-FFF2-40B4-BE49-F238E27FC236}">
+                <a16:creationId xmlns:a16="http://schemas.microsoft.com/office/drawing/2014/main" id="{DD3A848D-BACC-28FB-C47D-31CAE0EF62B5}"/>
+              </a:ext>
+            </a:extLst>
+          </p:cNvPr>
+          <p:cNvSpPr>
+            <a:spLocks noGrp="1"/>
+          </p:cNvSpPr>
+          <p:nvPr>
+            <p:ph type="dt" sz="half" idx="10"/>
+          </p:nvPr>
+        </p:nvSpPr>
+        <p:spPr/>
+        <p:txBody>
+          <a:bodyPr/>
+          <a:lstStyle/>
+          <a:p>
+            <a:r>
+              <a:rPr lang="en-GB" noProof="0" dirty="0"/>
+              <a:t>23.02.2026</a:t>
+            </a:r>
+          </a:p>
+        </p:txBody>
+      </p:sp>
+      <p:sp>
+        <p:nvSpPr>
+          <p:cNvPr id="5" name="Foliennummernplatzhalter 4">
+            <a:extLst>
+              <a:ext uri="{FF2B5EF4-FFF2-40B4-BE49-F238E27FC236}">
+                <a16:creationId xmlns:a16="http://schemas.microsoft.com/office/drawing/2014/main" id="{0196C664-9F44-6398-877F-88648A2B4E48}"/>
+              </a:ext>
+            </a:extLst>
+          </p:cNvPr>
+          <p:cNvSpPr>
+            <a:spLocks noGrp="1"/>
+          </p:cNvSpPr>
+          <p:nvPr>
+            <p:ph type="sldNum" sz="quarter" idx="12"/>
+          </p:nvPr>
+        </p:nvSpPr>
+        <p:spPr/>
+        <p:txBody>
+          <a:bodyPr/>
+          <a:lstStyle/>
+          <a:p>
+            <a:fld id="{533690DF-FFD6-462A-8578-786984FF8DCB}" type="slidenum">
+              <a:rPr lang="en-GB" noProof="0" smtClean="0"/>
+              <a:t>7</a:t>
+            </a:fld>
+            <a:endParaRPr lang="en-GB" noProof="0" dirty="0"/>
+          </a:p>
+        </p:txBody>
+      </p:sp>
+      <p:sp>
+        <p:nvSpPr>
+          <p:cNvPr id="8" name="Rectangle: Rounded Corners 3">
+            <a:extLst>
+              <a:ext uri="{FF2B5EF4-FFF2-40B4-BE49-F238E27FC236}">
+                <a16:creationId xmlns:a16="http://schemas.microsoft.com/office/drawing/2014/main" id="{6D7C1CA4-8C72-9FE4-9F2B-F4C5C4AAE056}"/>
+              </a:ext>
+            </a:extLst>
+          </p:cNvPr>
+          <p:cNvSpPr/>
+          <p:nvPr/>
+        </p:nvSpPr>
+        <p:spPr bwMode="auto">
+          <a:xfrm>
+            <a:off x="388302" y="681037"/>
+            <a:ext cx="11522076" cy="828438"/>
+          </a:xfrm>
+          <a:prstGeom prst="roundRect">
+            <a:avLst>
+              <a:gd name="adj" fmla="val 9662"/>
+            </a:avLst>
+          </a:prstGeom>
+          <a:solidFill>
+            <a:srgbClr val="0A8276"/>
+          </a:solidFill>
+          <a:ln w="9525">
+            <a:noFill/>
+            <a:miter lim="800000"/>
+            <a:headEnd/>
+            <a:tailEnd/>
+          </a:ln>
+        </p:spPr>
+        <p:txBody>
+          <a:bodyPr rot="0" spcFirstLastPara="0" vertOverflow="overflow" horzOverflow="overflow" vert="horz" wrap="square" lIns="72000" tIns="72000" rIns="72000" bIns="72000" numCol="1" spcCol="0" rtlCol="0" fromWordArt="0" anchor="ctr" anchorCtr="0" forceAA="0" compatLnSpc="1">
+            <a:prstTxWarp prst="textNoShape">
+              <a:avLst/>
+            </a:prstTxWarp>
+            <a:noAutofit/>
+          </a:bodyPr>
+          <a:lstStyle/>
+          <a:p>
+            <a:pPr defTabSz="576000" eaLnBrk="0" fontAlgn="base" hangingPunct="0">
+              <a:lnSpc>
+                <a:spcPct val="120000"/>
+              </a:lnSpc>
+              <a:spcBef>
+                <a:spcPct val="0"/>
+              </a:spcBef>
+              <a:spcAft>
+                <a:spcPct val="0"/>
+              </a:spcAft>
+              <a:defRPr/>
+            </a:pPr>
+            <a:r>
+              <a:rPr lang="en-GB" sz="2000" b="1" kern="0" noProof="0" dirty="0">
+                <a:solidFill>
+                  <a:srgbClr val="FFFFFF"/>
+                </a:solidFill>
+                <a:latin typeface="Arial"/>
+                <a:cs typeface="Arial"/>
+              </a:rPr>
+              <a:t>Final Classification</a:t>
+            </a:r>
+            <a:endParaRPr lang="en-GB" sz="2000" b="1" i="1" kern="0" baseline="30000" noProof="0" dirty="0">
+              <a:solidFill>
+                <a:srgbClr val="FFFFFF"/>
+              </a:solidFill>
+              <a:latin typeface="Arial"/>
+              <a:cs typeface="Arial"/>
+            </a:endParaRPr>
+          </a:p>
+        </p:txBody>
+      </p:sp>
+      <p:pic>
+        <p:nvPicPr>
+          <p:cNvPr id="7" name="Grafik 6" descr="Ein Bild, das Screenshot, Text, Zahl, Schrift enthält.&#10;&#10;KI-generierte Inhalte können fehlerhaft sein.">
+            <a:extLst>
+              <a:ext uri="{FF2B5EF4-FFF2-40B4-BE49-F238E27FC236}">
+                <a16:creationId xmlns:a16="http://schemas.microsoft.com/office/drawing/2014/main" id="{CE170180-FF02-18F9-A44F-793522F1215B}"/>
+              </a:ext>
+            </a:extLst>
+          </p:cNvPr>
+          <p:cNvPicPr>
+            <a:picLocks noChangeAspect="1"/>
+          </p:cNvPicPr>
+          <p:nvPr/>
+        </p:nvPicPr>
+        <p:blipFill>
+          <a:blip r:embed="rId2"/>
+          <a:stretch>
+            <a:fillRect/>
+          </a:stretch>
+        </p:blipFill>
+        <p:spPr>
+          <a:xfrm>
+            <a:off x="2513335" y="4254368"/>
+            <a:ext cx="7272010" cy="2101982"/>
+          </a:xfrm>
+          <a:prstGeom prst="rect">
+            <a:avLst/>
+          </a:prstGeom>
+        </p:spPr>
+      </p:pic>
+    </p:spTree>
+    <p:extLst>
+      <p:ext uri="{BB962C8B-B14F-4D97-AF65-F5344CB8AC3E}">
+        <p14:creationId xmlns:p14="http://schemas.microsoft.com/office/powerpoint/2010/main" val="1447199446"/>
+      </p:ext>
+    </p:extLst>
+  </p:cSld>
+  <p:clrMapOvr>
+    <a:masterClrMapping/>
+  </p:clrMapOvr>
+</p:sld>
+</file>
+
+<file path=ppt/slides/slide8.xml><?xml version="1.0" encoding="utf-8"?>
+<p:sld xmlns:a="http://schemas.openxmlformats.org/drawingml/2006/main" xmlns:r="http://schemas.openxmlformats.org/officeDocument/2006/relationships" xmlns:p="http://schemas.openxmlformats.org/presentationml/2006/main">
+  <p:cSld>
+    <p:bg>
+      <p:bgPr>
+        <a:solidFill>
+          <a:schemeClr val="bg1"/>
+        </a:solidFill>
+        <a:effectLst/>
+      </p:bgPr>
+    </p:bg>
     <p:spTree>
       <p:nvGrpSpPr>
         <p:cNvPr id="1" name="">
@@ -5970,10 +7460,426 @@
       </p:grpSpPr>
       <p:sp>
         <p:nvSpPr>
+          <p:cNvPr id="11" name="Rectangle 10">
+            <a:extLst>
+              <a:ext uri="{FF2B5EF4-FFF2-40B4-BE49-F238E27FC236}">
+                <a16:creationId xmlns:a16="http://schemas.microsoft.com/office/drawing/2014/main" id="{42A4FC2C-047E-45A5-965D-8E1E3BF09BC6}"/>
+              </a:ext>
+              <a:ext uri="{C183D7F6-B498-43B3-948B-1728B52AA6E4}">
+                <adec:decorative xmlns:adec="http://schemas.microsoft.com/office/drawing/2017/decorative" val="1"/>
+              </a:ext>
+            </a:extLst>
+          </p:cNvPr>
+          <p:cNvSpPr>
+            <a:spLocks noGrp="1" noRot="1" noChangeAspect="1" noMove="1" noResize="1" noEditPoints="1" noAdjustHandles="1" noChangeArrowheads="1" noChangeShapeType="1" noTextEdit="1"/>
+          </p:cNvSpPr>
+          <p:nvPr>
+            <p:extLst>
+              <p:ext uri="{386F3935-93C4-4BCD-93E2-E3B085C9AB24}">
+                <p16:designElem xmlns:p16="http://schemas.microsoft.com/office/powerpoint/2015/main" val="1"/>
+              </p:ext>
+            </p:extLst>
+          </p:nvPr>
+        </p:nvSpPr>
+        <p:spPr bwMode="white">
+          <a:xfrm>
+            <a:off x="1524" y="0"/>
+            <a:ext cx="12188952" cy="6858000"/>
+          </a:xfrm>
+          <a:prstGeom prst="rect">
+            <a:avLst/>
+          </a:prstGeom>
+          <a:noFill/>
+          <a:ln>
+            <a:noFill/>
+          </a:ln>
+        </p:spPr>
+        <p:style>
+          <a:lnRef idx="2">
+            <a:schemeClr val="accent1">
+              <a:shade val="50000"/>
+            </a:schemeClr>
+          </a:lnRef>
+          <a:fillRef idx="1">
+            <a:schemeClr val="accent1"/>
+          </a:fillRef>
+          <a:effectRef idx="0">
+            <a:schemeClr val="accent1"/>
+          </a:effectRef>
+          <a:fontRef idx="minor">
+            <a:schemeClr val="lt1"/>
+          </a:fontRef>
+        </p:style>
+        <p:txBody>
+          <a:bodyPr rtlCol="0" anchor="ctr"/>
+          <a:lstStyle>
+            <a:defPPr>
+              <a:defRPr lang="en-US"/>
+            </a:defPPr>
+            <a:lvl1pPr marL="0" algn="l" defTabSz="914400" rtl="0" eaLnBrk="1" latinLnBrk="0" hangingPunct="1">
+              <a:defRPr sz="1800" kern="1200">
+                <a:solidFill>
+                  <a:schemeClr val="lt1"/>
+                </a:solidFill>
+                <a:latin typeface="+mn-lt"/>
+                <a:ea typeface="+mn-ea"/>
+                <a:cs typeface="+mn-cs"/>
+              </a:defRPr>
+            </a:lvl1pPr>
+            <a:lvl2pPr marL="457200" algn="l" defTabSz="914400" rtl="0" eaLnBrk="1" latinLnBrk="0" hangingPunct="1">
+              <a:defRPr sz="1800" kern="1200">
+                <a:solidFill>
+                  <a:schemeClr val="lt1"/>
+                </a:solidFill>
+                <a:latin typeface="+mn-lt"/>
+                <a:ea typeface="+mn-ea"/>
+                <a:cs typeface="+mn-cs"/>
+              </a:defRPr>
+            </a:lvl2pPr>
+            <a:lvl3pPr marL="914400" algn="l" defTabSz="914400" rtl="0" eaLnBrk="1" latinLnBrk="0" hangingPunct="1">
+              <a:defRPr sz="1800" kern="1200">
+                <a:solidFill>
+                  <a:schemeClr val="lt1"/>
+                </a:solidFill>
+                <a:latin typeface="+mn-lt"/>
+                <a:ea typeface="+mn-ea"/>
+                <a:cs typeface="+mn-cs"/>
+              </a:defRPr>
+            </a:lvl3pPr>
+            <a:lvl4pPr marL="1371600" algn="l" defTabSz="914400" rtl="0" eaLnBrk="1" latinLnBrk="0" hangingPunct="1">
+              <a:defRPr sz="1800" kern="1200">
+                <a:solidFill>
+                  <a:schemeClr val="lt1"/>
+                </a:solidFill>
+                <a:latin typeface="+mn-lt"/>
+                <a:ea typeface="+mn-ea"/>
+                <a:cs typeface="+mn-cs"/>
+              </a:defRPr>
+            </a:lvl4pPr>
+            <a:lvl5pPr marL="1828800" algn="l" defTabSz="914400" rtl="0" eaLnBrk="1" latinLnBrk="0" hangingPunct="1">
+              <a:defRPr sz="1800" kern="1200">
+                <a:solidFill>
+                  <a:schemeClr val="lt1"/>
+                </a:solidFill>
+                <a:latin typeface="+mn-lt"/>
+                <a:ea typeface="+mn-ea"/>
+                <a:cs typeface="+mn-cs"/>
+              </a:defRPr>
+            </a:lvl5pPr>
+            <a:lvl6pPr marL="2286000" algn="l" defTabSz="914400" rtl="0" eaLnBrk="1" latinLnBrk="0" hangingPunct="1">
+              <a:defRPr sz="1800" kern="1200">
+                <a:solidFill>
+                  <a:schemeClr val="lt1"/>
+                </a:solidFill>
+                <a:latin typeface="+mn-lt"/>
+                <a:ea typeface="+mn-ea"/>
+                <a:cs typeface="+mn-cs"/>
+              </a:defRPr>
+            </a:lvl6pPr>
+            <a:lvl7pPr marL="2743200" algn="l" defTabSz="914400" rtl="0" eaLnBrk="1" latinLnBrk="0" hangingPunct="1">
+              <a:defRPr sz="1800" kern="1200">
+                <a:solidFill>
+                  <a:schemeClr val="lt1"/>
+                </a:solidFill>
+                <a:latin typeface="+mn-lt"/>
+                <a:ea typeface="+mn-ea"/>
+                <a:cs typeface="+mn-cs"/>
+              </a:defRPr>
+            </a:lvl7pPr>
+            <a:lvl8pPr marL="3200400" algn="l" defTabSz="914400" rtl="0" eaLnBrk="1" latinLnBrk="0" hangingPunct="1">
+              <a:defRPr sz="1800" kern="1200">
+                <a:solidFill>
+                  <a:schemeClr val="lt1"/>
+                </a:solidFill>
+                <a:latin typeface="+mn-lt"/>
+                <a:ea typeface="+mn-ea"/>
+                <a:cs typeface="+mn-cs"/>
+              </a:defRPr>
+            </a:lvl8pPr>
+            <a:lvl9pPr marL="3657600" algn="l" defTabSz="914400" rtl="0" eaLnBrk="1" latinLnBrk="0" hangingPunct="1">
+              <a:defRPr sz="1800" kern="1200">
+                <a:solidFill>
+                  <a:schemeClr val="lt1"/>
+                </a:solidFill>
+                <a:latin typeface="+mn-lt"/>
+                <a:ea typeface="+mn-ea"/>
+                <a:cs typeface="+mn-cs"/>
+              </a:defRPr>
+            </a:lvl9pPr>
+          </a:lstStyle>
+          <a:p>
+            <a:pPr algn="ctr"/>
+            <a:endParaRPr lang="en-US"/>
+          </a:p>
+        </p:txBody>
+      </p:sp>
+      <p:pic>
+        <p:nvPicPr>
+          <p:cNvPr id="6" name="Grafik 5" descr="Ein Bild, das Menschliches Gesicht, Person, Kleidung, Lächeln enthält.">
+            <a:extLst>
+              <a:ext uri="{FF2B5EF4-FFF2-40B4-BE49-F238E27FC236}">
+                <a16:creationId xmlns:a16="http://schemas.microsoft.com/office/drawing/2014/main" id="{DF0707A0-3472-079F-F653-A4BD8251A08A}"/>
+              </a:ext>
+            </a:extLst>
+          </p:cNvPr>
+          <p:cNvPicPr>
+            <a:picLocks noChangeAspect="1"/>
+          </p:cNvPicPr>
+          <p:nvPr/>
+        </p:nvPicPr>
+        <p:blipFill>
+          <a:blip r:embed="rId3">
+            <a:extLst>
+              <a:ext uri="{28A0092B-C50C-407E-A947-70E740481C1C}">
+                <a14:useLocalDpi xmlns:a14="http://schemas.microsoft.com/office/drawing/2010/main" val="0"/>
+              </a:ext>
+            </a:extLst>
+          </a:blip>
+          <a:srcRect l="9844" r="12363" b="-1"/>
+          <a:stretch>
+            <a:fillRect/>
+          </a:stretch>
+        </p:blipFill>
+        <p:spPr>
+          <a:xfrm>
+            <a:off x="20" y="1282"/>
+            <a:ext cx="12191980" cy="6856718"/>
+          </a:xfrm>
+          <a:prstGeom prst="rect">
+            <a:avLst/>
+          </a:prstGeom>
+        </p:spPr>
+      </p:pic>
+      <p:sp>
+        <p:nvSpPr>
+          <p:cNvPr id="4" name="Datumsplatzhalter 3">
+            <a:extLst>
+              <a:ext uri="{FF2B5EF4-FFF2-40B4-BE49-F238E27FC236}">
+                <a16:creationId xmlns:a16="http://schemas.microsoft.com/office/drawing/2014/main" id="{AE362DEC-D7B6-CF9F-2598-6E560D69873C}"/>
+              </a:ext>
+            </a:extLst>
+          </p:cNvPr>
+          <p:cNvSpPr>
+            <a:spLocks noGrp="1"/>
+          </p:cNvSpPr>
+          <p:nvPr>
+            <p:ph type="dt" sz="half" idx="10"/>
+          </p:nvPr>
+        </p:nvSpPr>
+        <p:spPr>
+          <a:xfrm>
+            <a:off x="838200" y="6356350"/>
+            <a:ext cx="2743200" cy="365125"/>
+          </a:xfrm>
+        </p:spPr>
+        <p:txBody>
+          <a:bodyPr vert="horz" lIns="91440" tIns="45720" rIns="91440" bIns="45720" rtlCol="0" anchor="ctr">
+            <a:normAutofit/>
+          </a:bodyPr>
+          <a:lstStyle/>
+          <a:p>
+            <a:pPr>
+              <a:spcAft>
+                <a:spcPts val="600"/>
+              </a:spcAft>
+            </a:pPr>
+            <a:r>
+              <a:rPr lang="en-US" noProof="0">
+                <a:solidFill>
+                  <a:srgbClr val="FFFFFF"/>
+                </a:solidFill>
+              </a:rPr>
+              <a:t>23.02.2026</a:t>
+            </a:r>
+          </a:p>
+        </p:txBody>
+      </p:sp>
+      <p:sp>
+        <p:nvSpPr>
+          <p:cNvPr id="5" name="Foliennummernplatzhalter 4">
+            <a:extLst>
+              <a:ext uri="{FF2B5EF4-FFF2-40B4-BE49-F238E27FC236}">
+                <a16:creationId xmlns:a16="http://schemas.microsoft.com/office/drawing/2014/main" id="{DFA09A85-E254-DAE1-1B28-17A6C1C20F54}"/>
+              </a:ext>
+            </a:extLst>
+          </p:cNvPr>
+          <p:cNvSpPr>
+            <a:spLocks noGrp="1"/>
+          </p:cNvSpPr>
+          <p:nvPr>
+            <p:ph type="sldNum" sz="quarter" idx="12"/>
+          </p:nvPr>
+        </p:nvSpPr>
+        <p:spPr>
+          <a:xfrm>
+            <a:off x="8610600" y="6356350"/>
+            <a:ext cx="2743200" cy="365125"/>
+          </a:xfrm>
+        </p:spPr>
+        <p:txBody>
+          <a:bodyPr vert="horz" lIns="91440" tIns="45720" rIns="91440" bIns="45720" rtlCol="0" anchor="ctr">
+            <a:normAutofit/>
+          </a:bodyPr>
+          <a:lstStyle/>
+          <a:p>
+            <a:pPr>
+              <a:spcAft>
+                <a:spcPts val="600"/>
+              </a:spcAft>
+            </a:pPr>
+            <a:fld id="{533690DF-FFD6-462A-8578-786984FF8DCB}" type="slidenum">
+              <a:rPr lang="en-US" noProof="0">
+                <a:solidFill>
+                  <a:srgbClr val="FFFFFF"/>
+                </a:solidFill>
+              </a:rPr>
+              <a:pPr>
+                <a:spcAft>
+                  <a:spcPts val="600"/>
+                </a:spcAft>
+              </a:pPr>
+              <a:t>8</a:t>
+            </a:fld>
+            <a:endParaRPr lang="en-US" noProof="0">
+              <a:solidFill>
+                <a:srgbClr val="FFFFFF"/>
+              </a:solidFill>
+            </a:endParaRPr>
+          </a:p>
+        </p:txBody>
+      </p:sp>
+      <p:pic>
+        <p:nvPicPr>
+          <p:cNvPr id="9" name="Grafik 8" descr="Ein Bild, das Screenshot, Text, Diagramm, Reihe enthält.&#10;&#10;KI-generierte Inhalte können fehlerhaft sein.">
+            <a:extLst>
+              <a:ext uri="{FF2B5EF4-FFF2-40B4-BE49-F238E27FC236}">
+                <a16:creationId xmlns:a16="http://schemas.microsoft.com/office/drawing/2014/main" id="{A6192898-C8A5-E828-28E0-EDBF1B02539D}"/>
+              </a:ext>
+            </a:extLst>
+          </p:cNvPr>
+          <p:cNvPicPr>
+            <a:picLocks noChangeAspect="1"/>
+          </p:cNvPicPr>
+          <p:nvPr/>
+        </p:nvPicPr>
+        <p:blipFill>
+          <a:blip r:embed="rId4"/>
+          <a:stretch>
+            <a:fillRect/>
+          </a:stretch>
+        </p:blipFill>
+        <p:spPr>
+          <a:xfrm>
+            <a:off x="5014741" y="4557158"/>
+            <a:ext cx="2300459" cy="1799192"/>
+          </a:xfrm>
+          <a:prstGeom prst="rect">
+            <a:avLst/>
+          </a:prstGeom>
+        </p:spPr>
+      </p:pic>
+      <p:pic>
+        <p:nvPicPr>
+          <p:cNvPr id="12" name="Grafik 11" descr="Ein Bild, das Screenshot, Reihe, Design enthält.&#10;&#10;KI-generierte Inhalte können fehlerhaft sein.">
+            <a:extLst>
+              <a:ext uri="{FF2B5EF4-FFF2-40B4-BE49-F238E27FC236}">
+                <a16:creationId xmlns:a16="http://schemas.microsoft.com/office/drawing/2014/main" id="{5D2FD7F0-484E-2EE4-913E-33017D3CE0EA}"/>
+              </a:ext>
+            </a:extLst>
+          </p:cNvPr>
+          <p:cNvPicPr>
+            <a:picLocks noChangeAspect="1"/>
+          </p:cNvPicPr>
+          <p:nvPr/>
+        </p:nvPicPr>
+        <p:blipFill>
+          <a:blip r:embed="rId5"/>
+          <a:stretch>
+            <a:fillRect/>
+          </a:stretch>
+        </p:blipFill>
+        <p:spPr>
+          <a:xfrm>
+            <a:off x="1216740" y="3711973"/>
+            <a:ext cx="1986120" cy="2053162"/>
+          </a:xfrm>
+          <a:prstGeom prst="rect">
+            <a:avLst/>
+          </a:prstGeom>
+        </p:spPr>
+      </p:pic>
+      <p:pic>
+        <p:nvPicPr>
+          <p:cNvPr id="14" name="Grafik 13" descr="Ein Bild, das Screenshot, Reihe, Diagramm, Design enthält.&#10;&#10;KI-generierte Inhalte können fehlerhaft sein.">
+            <a:extLst>
+              <a:ext uri="{FF2B5EF4-FFF2-40B4-BE49-F238E27FC236}">
+                <a16:creationId xmlns:a16="http://schemas.microsoft.com/office/drawing/2014/main" id="{5A6A1DE2-D9CC-759E-7A28-19FC531233D7}"/>
+              </a:ext>
+            </a:extLst>
+          </p:cNvPr>
+          <p:cNvPicPr>
+            <a:picLocks noChangeAspect="1"/>
+          </p:cNvPicPr>
+          <p:nvPr/>
+        </p:nvPicPr>
+        <p:blipFill>
+          <a:blip r:embed="rId6"/>
+          <a:stretch>
+            <a:fillRect/>
+          </a:stretch>
+        </p:blipFill>
+        <p:spPr>
+          <a:xfrm>
+            <a:off x="8748541" y="3643149"/>
+            <a:ext cx="1867161" cy="2333951"/>
+          </a:xfrm>
+          <a:prstGeom prst="rect">
+            <a:avLst/>
+          </a:prstGeom>
+        </p:spPr>
+      </p:pic>
+    </p:spTree>
+    <p:extLst>
+      <p:ext uri="{BB962C8B-B14F-4D97-AF65-F5344CB8AC3E}">
+        <p14:creationId xmlns:p14="http://schemas.microsoft.com/office/powerpoint/2010/main" val="400555273"/>
+      </p:ext>
+    </p:extLst>
+  </p:cSld>
+  <p:clrMapOvr>
+    <a:masterClrMapping/>
+  </p:clrMapOvr>
+</p:sld>
+</file>
+
+<file path=ppt/slides/slide9.xml><?xml version="1.0" encoding="utf-8"?>
+<p:sld xmlns:a="http://schemas.openxmlformats.org/drawingml/2006/main" xmlns:r="http://schemas.openxmlformats.org/officeDocument/2006/relationships" xmlns:p="http://schemas.openxmlformats.org/presentationml/2006/main">
+  <p:cSld>
+    <p:spTree>
+      <p:nvGrpSpPr>
+        <p:cNvPr id="1" name="">
+          <a:extLst>
+            <a:ext uri="{FF2B5EF4-FFF2-40B4-BE49-F238E27FC236}">
+              <a16:creationId xmlns:a16="http://schemas.microsoft.com/office/drawing/2014/main" id="{8A2F5540-A834-3F82-495B-09628574077D}"/>
+            </a:ext>
+          </a:extLst>
+        </p:cNvPr>
+        <p:cNvGrpSpPr/>
+        <p:nvPr/>
+      </p:nvGrpSpPr>
+      <p:grpSpPr>
+        <a:xfrm>
+          <a:off x="0" y="0"/>
+          <a:ext cx="0" cy="0"/>
+          <a:chOff x="0" y="0"/>
+          <a:chExt cx="0" cy="0"/>
+        </a:xfrm>
+      </p:grpSpPr>
+      <p:sp>
+        <p:nvSpPr>
           <p:cNvPr id="2" name="Titel 1">
             <a:extLst>
               <a:ext uri="{FF2B5EF4-FFF2-40B4-BE49-F238E27FC236}">
-                <a16:creationId xmlns:a16="http://schemas.microsoft.com/office/drawing/2014/main" id="{D8E40E54-2750-D826-2B85-E09956ACC701}"/>
+                <a16:creationId xmlns:a16="http://schemas.microsoft.com/office/drawing/2014/main" id="{10465A4F-AE0F-8B98-CC0D-AE35ADD19547}"/>
               </a:ext>
             </a:extLst>
           </p:cNvPr>
@@ -5998,7 +7904,7 @@
           <p:cNvPr id="3" name="Inhaltsplatzhalter 2">
             <a:extLst>
               <a:ext uri="{FF2B5EF4-FFF2-40B4-BE49-F238E27FC236}">
-                <a16:creationId xmlns:a16="http://schemas.microsoft.com/office/drawing/2014/main" id="{40513D45-7E88-18F0-3C4E-A5367BD677EB}"/>
+                <a16:creationId xmlns:a16="http://schemas.microsoft.com/office/drawing/2014/main" id="{F9F68FB4-5819-C412-835B-67F7206F85E2}"/>
               </a:ext>
             </a:extLst>
           </p:cNvPr>
@@ -6014,7 +7920,63 @@
           <a:bodyPr/>
           <a:lstStyle/>
           <a:p>
-            <a:endParaRPr lang="en-GB" noProof="0" dirty="0"/>
+            <a:r>
+              <a:rPr lang="en-GB" noProof="0" dirty="0"/>
+              <a:t>Preprocessor used: Contextual Window (0.5s length,</a:t>
+            </a:r>
+            <a:br>
+              <a:rPr lang="en-GB" noProof="0" dirty="0"/>
+            </a:br>
+            <a:r>
+              <a:rPr lang="en-GB" noProof="0" dirty="0"/>
+              <a:t>2Hz prediction frequency)</a:t>
+            </a:r>
+          </a:p>
+          <a:p>
+            <a:r>
+              <a:rPr lang="en-GB" dirty="0"/>
+              <a:t>Created a model with:</a:t>
+            </a:r>
+          </a:p>
+          <a:p>
+            <a:pPr lvl="1"/>
+            <a:r>
+              <a:rPr lang="en-GB" dirty="0"/>
+              <a:t>Model Family Conv1d</a:t>
+            </a:r>
+          </a:p>
+          <a:p>
+            <a:pPr lvl="1"/>
+            <a:r>
+              <a:rPr lang="en-GB" dirty="0"/>
+              <a:t>Medium Model Size</a:t>
+            </a:r>
+          </a:p>
+          <a:p>
+            <a:pPr lvl="1"/>
+            <a:r>
+              <a:rPr lang="en-GB" dirty="0"/>
+              <a:t>Balanced Optimization</a:t>
+            </a:r>
+          </a:p>
+          <a:p>
+            <a:pPr lvl="1"/>
+            <a:r>
+              <a:rPr lang="en-GB" dirty="0"/>
+              <a:t>Mid Learn Rate &amp; Regularization</a:t>
+            </a:r>
+          </a:p>
+          <a:p>
+            <a:pPr marL="457200" lvl="1" indent="0">
+              <a:buNone/>
+            </a:pPr>
+            <a:endParaRPr lang="en-GB" dirty="0"/>
+          </a:p>
+          <a:p>
+            <a:r>
+              <a:rPr lang="en-GB" noProof="0" dirty="0"/>
+              <a:t>Tried out different combination, the mentioned one lead to the best Test Statistics</a:t>
+            </a:r>
           </a:p>
         </p:txBody>
       </p:sp>
@@ -6023,7 +7985,7 @@
           <p:cNvPr id="4" name="Datumsplatzhalter 3">
             <a:extLst>
               <a:ext uri="{FF2B5EF4-FFF2-40B4-BE49-F238E27FC236}">
-                <a16:creationId xmlns:a16="http://schemas.microsoft.com/office/drawing/2014/main" id="{AE362DEC-D7B6-CF9F-2598-6E560D69873C}"/>
+                <a16:creationId xmlns:a16="http://schemas.microsoft.com/office/drawing/2014/main" id="{75206309-0EB5-1ECA-A30C-249E7C020352}"/>
               </a:ext>
             </a:extLst>
           </p:cNvPr>
@@ -6051,7 +8013,7 @@
           <p:cNvPr id="5" name="Foliennummernplatzhalter 4">
             <a:extLst>
               <a:ext uri="{FF2B5EF4-FFF2-40B4-BE49-F238E27FC236}">
-                <a16:creationId xmlns:a16="http://schemas.microsoft.com/office/drawing/2014/main" id="{DFA09A85-E254-DAE1-1B28-17A6C1C20F54}"/>
+                <a16:creationId xmlns:a16="http://schemas.microsoft.com/office/drawing/2014/main" id="{4EB5A81C-DA26-8B95-E384-0FF59D7ECC17}"/>
               </a:ext>
             </a:extLst>
           </p:cNvPr>
@@ -6069,7 +8031,7 @@
           <a:p>
             <a:fld id="{533690DF-FFD6-462A-8578-786984FF8DCB}" type="slidenum">
               <a:rPr lang="en-GB" noProof="0" smtClean="0"/>
-              <a:t>7</a:t>
+              <a:t>9</a:t>
             </a:fld>
             <a:endParaRPr lang="en-GB" noProof="0" dirty="0"/>
           </a:p>
@@ -6080,7 +8042,7 @@
           <p:cNvPr id="8" name="Rectangle: Rounded Corners 3">
             <a:extLst>
               <a:ext uri="{FF2B5EF4-FFF2-40B4-BE49-F238E27FC236}">
-                <a16:creationId xmlns:a16="http://schemas.microsoft.com/office/drawing/2014/main" id="{CB177610-EA83-8840-09D2-B29A8FF3B992}"/>
+                <a16:creationId xmlns:a16="http://schemas.microsoft.com/office/drawing/2014/main" id="{96E85EC3-D9DF-9DB5-4479-BE4F95EDA8A0}"/>
               </a:ext>
             </a:extLst>
           </p:cNvPr>
@@ -6129,16 +8091,6 @@
               <a:defRPr/>
             </a:pPr>
             <a:r>
-              <a:rPr lang="en-GB" sz="2000" b="1" kern="0" noProof="0" dirty="0" err="1">
-                <a:solidFill>
-                  <a:srgbClr val="FFFFFF"/>
-                </a:solidFill>
-                <a:latin typeface="Arial"/>
-                <a:cs typeface="Arial"/>
-              </a:rPr>
-              <a:t>Micropython</a:t>
-            </a:r>
-            <a:r>
               <a:rPr lang="en-GB" sz="2000" b="1" kern="0" noProof="0" dirty="0">
                 <a:solidFill>
                   <a:srgbClr val="FFFFFF"/>
@@ -6146,7 +8098,7 @@
                 <a:latin typeface="Arial"/>
                 <a:cs typeface="Arial"/>
               </a:rPr>
-              <a:t> </a:t>
+              <a:t>Final Classification</a:t>
             </a:r>
             <a:endParaRPr lang="en-GB" sz="2000" b="1" i="1" kern="0" baseline="30000" noProof="0" dirty="0">
               <a:solidFill>
@@ -6158,491 +8110,70 @@
           </a:p>
         </p:txBody>
       </p:sp>
+      <p:pic>
+        <p:nvPicPr>
+          <p:cNvPr id="9" name="Grafik 8" descr="Ein Bild, das Schrift, Text, Screenshot, Zahl enthält.&#10;&#10;KI-generierte Inhalte können fehlerhaft sein.">
+            <a:extLst>
+              <a:ext uri="{FF2B5EF4-FFF2-40B4-BE49-F238E27FC236}">
+                <a16:creationId xmlns:a16="http://schemas.microsoft.com/office/drawing/2014/main" id="{5FFD4FB8-5CC3-0A10-5E5A-C18E2D451B2C}"/>
+              </a:ext>
+            </a:extLst>
+          </p:cNvPr>
+          <p:cNvPicPr>
+            <a:picLocks noChangeAspect="1"/>
+          </p:cNvPicPr>
+          <p:nvPr/>
+        </p:nvPicPr>
+        <p:blipFill>
+          <a:blip r:embed="rId2"/>
+          <a:stretch>
+            <a:fillRect/>
+          </a:stretch>
+        </p:blipFill>
+        <p:spPr>
+          <a:xfrm>
+            <a:off x="9349737" y="1922944"/>
+            <a:ext cx="2086266" cy="924054"/>
+          </a:xfrm>
+          <a:prstGeom prst="rect">
+            <a:avLst/>
+          </a:prstGeom>
+        </p:spPr>
+      </p:pic>
+      <p:pic>
+        <p:nvPicPr>
+          <p:cNvPr id="11" name="Grafik 10" descr="Ein Bild, das Text, Screenshot, Schrift, Zahl enthält.&#10;&#10;KI-generierte Inhalte können fehlerhaft sein.">
+            <a:extLst>
+              <a:ext uri="{FF2B5EF4-FFF2-40B4-BE49-F238E27FC236}">
+                <a16:creationId xmlns:a16="http://schemas.microsoft.com/office/drawing/2014/main" id="{F3F44AB0-BF71-137A-958D-E48BCE1AEB05}"/>
+              </a:ext>
+            </a:extLst>
+          </p:cNvPr>
+          <p:cNvPicPr>
+            <a:picLocks noChangeAspect="1"/>
+          </p:cNvPicPr>
+          <p:nvPr/>
+        </p:nvPicPr>
+        <p:blipFill>
+          <a:blip r:embed="rId3"/>
+          <a:stretch>
+            <a:fillRect/>
+          </a:stretch>
+        </p:blipFill>
+        <p:spPr>
+          <a:xfrm>
+            <a:off x="6739084" y="2846998"/>
+            <a:ext cx="4696920" cy="2296502"/>
+          </a:xfrm>
+          <a:prstGeom prst="rect">
+            <a:avLst/>
+          </a:prstGeom>
+        </p:spPr>
+      </p:pic>
     </p:spTree>
     <p:extLst>
       <p:ext uri="{BB962C8B-B14F-4D97-AF65-F5344CB8AC3E}">
-        <p14:creationId xmlns:p14="http://schemas.microsoft.com/office/powerpoint/2010/main" val="400555273"/>
-      </p:ext>
-    </p:extLst>
-  </p:cSld>
-  <p:clrMapOvr>
-    <a:masterClrMapping/>
-  </p:clrMapOvr>
-</p:sld>
-</file>
-
-<file path=ppt/slides/slide8.xml><?xml version="1.0" encoding="utf-8"?>
-<p:sld xmlns:a="http://schemas.openxmlformats.org/drawingml/2006/main" xmlns:r="http://schemas.openxmlformats.org/officeDocument/2006/relationships" xmlns:p="http://schemas.openxmlformats.org/presentationml/2006/main">
-  <p:cSld>
-    <p:spTree>
-      <p:nvGrpSpPr>
-        <p:cNvPr id="1" name="">
-          <a:extLst>
-            <a:ext uri="{FF2B5EF4-FFF2-40B4-BE49-F238E27FC236}">
-              <a16:creationId xmlns:a16="http://schemas.microsoft.com/office/drawing/2014/main" id="{580E206E-F9F0-B1F3-3831-EFA56FAF9180}"/>
-            </a:ext>
-          </a:extLst>
-        </p:cNvPr>
-        <p:cNvGrpSpPr/>
-        <p:nvPr/>
-      </p:nvGrpSpPr>
-      <p:grpSpPr>
-        <a:xfrm>
-          <a:off x="0" y="0"/>
-          <a:ext cx="0" cy="0"/>
-          <a:chOff x="0" y="0"/>
-          <a:chExt cx="0" cy="0"/>
-        </a:xfrm>
-      </p:grpSpPr>
-      <p:sp>
-        <p:nvSpPr>
-          <p:cNvPr id="2" name="Titel 1">
-            <a:extLst>
-              <a:ext uri="{FF2B5EF4-FFF2-40B4-BE49-F238E27FC236}">
-                <a16:creationId xmlns:a16="http://schemas.microsoft.com/office/drawing/2014/main" id="{63651015-7065-37DE-2A96-992FCAE30DD3}"/>
-              </a:ext>
-            </a:extLst>
-          </p:cNvPr>
-          <p:cNvSpPr>
-            <a:spLocks noGrp="1"/>
-          </p:cNvSpPr>
-          <p:nvPr>
-            <p:ph type="title"/>
-          </p:nvPr>
-        </p:nvSpPr>
-        <p:spPr/>
-        <p:txBody>
-          <a:bodyPr/>
-          <a:lstStyle/>
-          <a:p>
-            <a:endParaRPr lang="en-GB" noProof="0" dirty="0"/>
-          </a:p>
-        </p:txBody>
-      </p:sp>
-      <p:sp>
-        <p:nvSpPr>
-          <p:cNvPr id="3" name="Inhaltsplatzhalter 2">
-            <a:extLst>
-              <a:ext uri="{FF2B5EF4-FFF2-40B4-BE49-F238E27FC236}">
-                <a16:creationId xmlns:a16="http://schemas.microsoft.com/office/drawing/2014/main" id="{F02E0872-877F-0BA3-51D1-35C51BF24B60}"/>
-              </a:ext>
-            </a:extLst>
-          </p:cNvPr>
-          <p:cNvSpPr>
-            <a:spLocks noGrp="1"/>
-          </p:cNvSpPr>
-          <p:nvPr>
-            <p:ph idx="1"/>
-          </p:nvPr>
-        </p:nvSpPr>
-        <p:spPr/>
-        <p:txBody>
-          <a:bodyPr/>
-          <a:lstStyle/>
-          <a:p>
-            <a:r>
-              <a:rPr lang="en-GB" noProof="0" dirty="0"/>
-              <a:t>Implementing the game function</a:t>
-            </a:r>
-          </a:p>
-          <a:p>
-            <a:r>
-              <a:rPr lang="en-GB" dirty="0"/>
-              <a:t>Gathering more sampling data</a:t>
-            </a:r>
-          </a:p>
-          <a:p>
-            <a:r>
-              <a:rPr lang="en-GB" noProof="0" dirty="0"/>
-              <a:t>Creating a function to read the velocity of thrown punches</a:t>
-            </a:r>
-          </a:p>
-          <a:p>
-            <a:r>
-              <a:rPr lang="en-GB" noProof="0" dirty="0"/>
-              <a:t>Using the boards button </a:t>
-            </a:r>
-            <a:r>
-              <a:rPr lang="en-GB" dirty="0"/>
-              <a:t>to start and stop sessions</a:t>
-            </a:r>
-          </a:p>
-          <a:p>
-            <a:r>
-              <a:rPr lang="en-GB" noProof="0" dirty="0"/>
-              <a:t>Creation of c</a:t>
-            </a:r>
-            <a:r>
-              <a:rPr lang="en-GB" dirty="0"/>
-              <a:t>harts for easier understanding</a:t>
-            </a:r>
-            <a:endParaRPr lang="en-GB" noProof="0" dirty="0"/>
-          </a:p>
-          <a:p>
-            <a:endParaRPr lang="en-GB" noProof="0" dirty="0"/>
-          </a:p>
-        </p:txBody>
-      </p:sp>
-      <p:sp>
-        <p:nvSpPr>
-          <p:cNvPr id="4" name="Datumsplatzhalter 3">
-            <a:extLst>
-              <a:ext uri="{FF2B5EF4-FFF2-40B4-BE49-F238E27FC236}">
-                <a16:creationId xmlns:a16="http://schemas.microsoft.com/office/drawing/2014/main" id="{B5D3B9EB-9901-5950-F169-B1D0A08C57BD}"/>
-              </a:ext>
-            </a:extLst>
-          </p:cNvPr>
-          <p:cNvSpPr>
-            <a:spLocks noGrp="1"/>
-          </p:cNvSpPr>
-          <p:nvPr>
-            <p:ph type="dt" sz="half" idx="10"/>
-          </p:nvPr>
-        </p:nvSpPr>
-        <p:spPr/>
-        <p:txBody>
-          <a:bodyPr/>
-          <a:lstStyle/>
-          <a:p>
-            <a:r>
-              <a:rPr lang="en-GB" noProof="0" dirty="0"/>
-              <a:t>23.02.2026</a:t>
-            </a:r>
-          </a:p>
-        </p:txBody>
-      </p:sp>
-      <p:sp>
-        <p:nvSpPr>
-          <p:cNvPr id="5" name="Foliennummernplatzhalter 4">
-            <a:extLst>
-              <a:ext uri="{FF2B5EF4-FFF2-40B4-BE49-F238E27FC236}">
-                <a16:creationId xmlns:a16="http://schemas.microsoft.com/office/drawing/2014/main" id="{8A053F44-783F-C8DC-CE39-9F9027F85018}"/>
-              </a:ext>
-            </a:extLst>
-          </p:cNvPr>
-          <p:cNvSpPr>
-            <a:spLocks noGrp="1"/>
-          </p:cNvSpPr>
-          <p:nvPr>
-            <p:ph type="sldNum" sz="quarter" idx="12"/>
-          </p:nvPr>
-        </p:nvSpPr>
-        <p:spPr/>
-        <p:txBody>
-          <a:bodyPr/>
-          <a:lstStyle/>
-          <a:p>
-            <a:fld id="{533690DF-FFD6-462A-8578-786984FF8DCB}" type="slidenum">
-              <a:rPr lang="en-GB" noProof="0" smtClean="0"/>
-              <a:t>8</a:t>
-            </a:fld>
-            <a:endParaRPr lang="en-GB" noProof="0" dirty="0"/>
-          </a:p>
-        </p:txBody>
-      </p:sp>
-      <p:sp>
-        <p:nvSpPr>
-          <p:cNvPr id="8" name="Rectangle: Rounded Corners 3">
-            <a:extLst>
-              <a:ext uri="{FF2B5EF4-FFF2-40B4-BE49-F238E27FC236}">
-                <a16:creationId xmlns:a16="http://schemas.microsoft.com/office/drawing/2014/main" id="{FDB87BB3-2B66-4842-355C-9286C653C6EA}"/>
-              </a:ext>
-            </a:extLst>
-          </p:cNvPr>
-          <p:cNvSpPr/>
-          <p:nvPr/>
-        </p:nvSpPr>
-        <p:spPr bwMode="auto">
-          <a:xfrm>
-            <a:off x="388302" y="681037"/>
-            <a:ext cx="11522076" cy="828438"/>
-          </a:xfrm>
-          <a:prstGeom prst="roundRect">
-            <a:avLst>
-              <a:gd name="adj" fmla="val 9662"/>
-            </a:avLst>
-          </a:prstGeom>
-          <a:solidFill>
-            <a:srgbClr val="0A8276"/>
-          </a:solidFill>
-          <a:ln w="9525">
-            <a:noFill/>
-            <a:miter lim="800000"/>
-            <a:headEnd/>
-            <a:tailEnd/>
-          </a:ln>
-        </p:spPr>
-        <p:txBody>
-          <a:bodyPr rot="0" spcFirstLastPara="0" vertOverflow="overflow" horzOverflow="overflow" vert="horz" wrap="square" lIns="72000" tIns="72000" rIns="72000" bIns="72000" numCol="1" spcCol="0" rtlCol="0" fromWordArt="0" anchor="ctr" anchorCtr="0" forceAA="0" compatLnSpc="1">
-            <a:prstTxWarp prst="textNoShape">
-              <a:avLst/>
-            </a:prstTxWarp>
-            <a:noAutofit/>
-          </a:bodyPr>
-          <a:lstStyle/>
-          <a:p>
-            <a:pPr defTabSz="576000" eaLnBrk="0" fontAlgn="base" hangingPunct="0">
-              <a:lnSpc>
-                <a:spcPct val="120000"/>
-              </a:lnSpc>
-              <a:spcBef>
-                <a:spcPct val="0"/>
-              </a:spcBef>
-              <a:spcAft>
-                <a:spcPct val="0"/>
-              </a:spcAft>
-              <a:defRPr/>
-            </a:pPr>
-            <a:r>
-              <a:rPr lang="en-GB" sz="2000" b="1" kern="0" noProof="0" dirty="0">
-                <a:solidFill>
-                  <a:srgbClr val="FFFFFF"/>
-                </a:solidFill>
-                <a:latin typeface="Arial"/>
-                <a:cs typeface="Arial"/>
-              </a:rPr>
-              <a:t>Possible ways to make it better in the future </a:t>
-            </a:r>
-            <a:endParaRPr lang="en-GB" sz="2000" b="1" i="1" kern="0" baseline="30000" noProof="0" dirty="0">
-              <a:solidFill>
-                <a:srgbClr val="FFFFFF"/>
-              </a:solidFill>
-              <a:latin typeface="Arial"/>
-              <a:cs typeface="Arial"/>
-            </a:endParaRPr>
-          </a:p>
-        </p:txBody>
-      </p:sp>
-    </p:spTree>
-    <p:extLst>
-      <p:ext uri="{BB962C8B-B14F-4D97-AF65-F5344CB8AC3E}">
-        <p14:creationId xmlns:p14="http://schemas.microsoft.com/office/powerpoint/2010/main" val="3854629248"/>
-      </p:ext>
-    </p:extLst>
-  </p:cSld>
-  <p:clrMapOvr>
-    <a:masterClrMapping/>
-  </p:clrMapOvr>
-</p:sld>
-</file>
-
-<file path=ppt/slides/slide9.xml><?xml version="1.0" encoding="utf-8"?>
-<p:sld xmlns:a="http://schemas.openxmlformats.org/drawingml/2006/main" xmlns:r="http://schemas.openxmlformats.org/officeDocument/2006/relationships" xmlns:p="http://schemas.openxmlformats.org/presentationml/2006/main">
-  <p:cSld>
-    <p:spTree>
-      <p:nvGrpSpPr>
-        <p:cNvPr id="1" name="">
-          <a:extLst>
-            <a:ext uri="{FF2B5EF4-FFF2-40B4-BE49-F238E27FC236}">
-              <a16:creationId xmlns:a16="http://schemas.microsoft.com/office/drawing/2014/main" id="{A57008C3-ED2D-EB62-394B-433722099C04}"/>
-            </a:ext>
-          </a:extLst>
-        </p:cNvPr>
-        <p:cNvGrpSpPr/>
-        <p:nvPr/>
-      </p:nvGrpSpPr>
-      <p:grpSpPr>
-        <a:xfrm>
-          <a:off x="0" y="0"/>
-          <a:ext cx="0" cy="0"/>
-          <a:chOff x="0" y="0"/>
-          <a:chExt cx="0" cy="0"/>
-        </a:xfrm>
-      </p:grpSpPr>
-      <p:sp>
-        <p:nvSpPr>
-          <p:cNvPr id="2" name="Titel 1">
-            <a:extLst>
-              <a:ext uri="{FF2B5EF4-FFF2-40B4-BE49-F238E27FC236}">
-                <a16:creationId xmlns:a16="http://schemas.microsoft.com/office/drawing/2014/main" id="{0D9A040E-1E96-2C07-B001-F42A0250F033}"/>
-              </a:ext>
-            </a:extLst>
-          </p:cNvPr>
-          <p:cNvSpPr>
-            <a:spLocks noGrp="1"/>
-          </p:cNvSpPr>
-          <p:nvPr>
-            <p:ph type="title"/>
-          </p:nvPr>
-        </p:nvSpPr>
-        <p:spPr/>
-        <p:txBody>
-          <a:bodyPr/>
-          <a:lstStyle/>
-          <a:p>
-            <a:endParaRPr lang="en-GB" noProof="0" dirty="0"/>
-          </a:p>
-        </p:txBody>
-      </p:sp>
-      <p:sp>
-        <p:nvSpPr>
-          <p:cNvPr id="3" name="Inhaltsplatzhalter 2">
-            <a:extLst>
-              <a:ext uri="{FF2B5EF4-FFF2-40B4-BE49-F238E27FC236}">
-                <a16:creationId xmlns:a16="http://schemas.microsoft.com/office/drawing/2014/main" id="{F3F8CDC0-BC9F-14E4-28C1-E083C63F0BC5}"/>
-              </a:ext>
-            </a:extLst>
-          </p:cNvPr>
-          <p:cNvSpPr>
-            <a:spLocks noGrp="1"/>
-          </p:cNvSpPr>
-          <p:nvPr>
-            <p:ph idx="1"/>
-          </p:nvPr>
-        </p:nvSpPr>
-        <p:spPr/>
-        <p:txBody>
-          <a:bodyPr/>
-          <a:lstStyle/>
-          <a:p>
-            <a:endParaRPr lang="en-GB" noProof="0" dirty="0"/>
-          </a:p>
-        </p:txBody>
-      </p:sp>
-      <p:sp>
-        <p:nvSpPr>
-          <p:cNvPr id="4" name="Datumsplatzhalter 3">
-            <a:extLst>
-              <a:ext uri="{FF2B5EF4-FFF2-40B4-BE49-F238E27FC236}">
-                <a16:creationId xmlns:a16="http://schemas.microsoft.com/office/drawing/2014/main" id="{79CDA017-7409-470C-BDAC-910FD8EBC774}"/>
-              </a:ext>
-            </a:extLst>
-          </p:cNvPr>
-          <p:cNvSpPr>
-            <a:spLocks noGrp="1"/>
-          </p:cNvSpPr>
-          <p:nvPr>
-            <p:ph type="dt" sz="half" idx="10"/>
-          </p:nvPr>
-        </p:nvSpPr>
-        <p:spPr/>
-        <p:txBody>
-          <a:bodyPr/>
-          <a:lstStyle/>
-          <a:p>
-            <a:r>
-              <a:rPr lang="en-GB" noProof="0" dirty="0"/>
-              <a:t>23.02.2026</a:t>
-            </a:r>
-          </a:p>
-        </p:txBody>
-      </p:sp>
-      <p:sp>
-        <p:nvSpPr>
-          <p:cNvPr id="5" name="Foliennummernplatzhalter 4">
-            <a:extLst>
-              <a:ext uri="{FF2B5EF4-FFF2-40B4-BE49-F238E27FC236}">
-                <a16:creationId xmlns:a16="http://schemas.microsoft.com/office/drawing/2014/main" id="{44323A6F-8BD8-7FEF-6E7C-D070DC6A6CAC}"/>
-              </a:ext>
-            </a:extLst>
-          </p:cNvPr>
-          <p:cNvSpPr>
-            <a:spLocks noGrp="1"/>
-          </p:cNvSpPr>
-          <p:nvPr>
-            <p:ph type="sldNum" sz="quarter" idx="12"/>
-          </p:nvPr>
-        </p:nvSpPr>
-        <p:spPr/>
-        <p:txBody>
-          <a:bodyPr/>
-          <a:lstStyle/>
-          <a:p>
-            <a:fld id="{533690DF-FFD6-462A-8578-786984FF8DCB}" type="slidenum">
-              <a:rPr lang="en-GB" noProof="0" smtClean="0"/>
-              <a:t>9</a:t>
-            </a:fld>
-            <a:endParaRPr lang="en-GB" noProof="0" dirty="0"/>
-          </a:p>
-        </p:txBody>
-      </p:sp>
-      <p:sp>
-        <p:nvSpPr>
-          <p:cNvPr id="8" name="Rectangle: Rounded Corners 3">
-            <a:extLst>
-              <a:ext uri="{FF2B5EF4-FFF2-40B4-BE49-F238E27FC236}">
-                <a16:creationId xmlns:a16="http://schemas.microsoft.com/office/drawing/2014/main" id="{9F550BB5-19AF-75E8-64F7-05BABF369E56}"/>
-              </a:ext>
-            </a:extLst>
-          </p:cNvPr>
-          <p:cNvSpPr/>
-          <p:nvPr/>
-        </p:nvSpPr>
-        <p:spPr bwMode="auto">
-          <a:xfrm>
-            <a:off x="334962" y="365125"/>
-            <a:ext cx="11522076" cy="5811838"/>
-          </a:xfrm>
-          <a:prstGeom prst="roundRect">
-            <a:avLst>
-              <a:gd name="adj" fmla="val 9662"/>
-            </a:avLst>
-          </a:prstGeom>
-          <a:solidFill>
-            <a:srgbClr val="0A8276"/>
-          </a:solidFill>
-          <a:ln w="9525">
-            <a:noFill/>
-            <a:miter lim="800000"/>
-            <a:headEnd/>
-            <a:tailEnd/>
-          </a:ln>
-        </p:spPr>
-        <p:txBody>
-          <a:bodyPr rot="0" spcFirstLastPara="0" vertOverflow="overflow" horzOverflow="overflow" vert="horz" wrap="square" lIns="72000" tIns="72000" rIns="72000" bIns="72000" numCol="1" spcCol="0" rtlCol="0" fromWordArt="0" anchor="ctr" anchorCtr="0" forceAA="0" compatLnSpc="1">
-            <a:prstTxWarp prst="textNoShape">
-              <a:avLst/>
-            </a:prstTxWarp>
-            <a:noAutofit/>
-          </a:bodyPr>
-          <a:lstStyle/>
-          <a:p>
-            <a:pPr algn="ctr" defTabSz="576000" eaLnBrk="0" fontAlgn="base" hangingPunct="0">
-              <a:lnSpc>
-                <a:spcPct val="120000"/>
-              </a:lnSpc>
-              <a:spcBef>
-                <a:spcPct val="0"/>
-              </a:spcBef>
-              <a:spcAft>
-                <a:spcPct val="0"/>
-              </a:spcAft>
-              <a:defRPr/>
-            </a:pPr>
-            <a:r>
-              <a:rPr lang="en-GB" sz="6000" b="1" kern="0" noProof="0" dirty="0">
-                <a:solidFill>
-                  <a:srgbClr val="FFFFFF"/>
-                </a:solidFill>
-                <a:latin typeface="Arial"/>
-                <a:cs typeface="Arial"/>
-              </a:rPr>
-              <a:t>Demonstration</a:t>
-            </a:r>
-            <a:r>
-              <a:rPr lang="en-GB" sz="2000" b="1" kern="0" noProof="0" dirty="0">
-                <a:solidFill>
-                  <a:srgbClr val="FFFFFF"/>
-                </a:solidFill>
-                <a:latin typeface="Arial"/>
-                <a:cs typeface="Arial"/>
-              </a:rPr>
-              <a:t> </a:t>
-            </a:r>
-            <a:endParaRPr lang="en-GB" sz="2000" b="1" i="1" kern="0" baseline="30000" noProof="0" dirty="0">
-              <a:solidFill>
-                <a:srgbClr val="FFFFFF"/>
-              </a:solidFill>
-              <a:latin typeface="Arial"/>
-              <a:cs typeface="Arial"/>
-            </a:endParaRPr>
-          </a:p>
-        </p:txBody>
-      </p:sp>
-    </p:spTree>
-    <p:extLst>
-      <p:ext uri="{BB962C8B-B14F-4D97-AF65-F5344CB8AC3E}">
-        <p14:creationId xmlns:p14="http://schemas.microsoft.com/office/powerpoint/2010/main" val="2089918606"/>
+        <p14:creationId xmlns:p14="http://schemas.microsoft.com/office/powerpoint/2010/main" val="4245453861"/>
       </p:ext>
     </p:extLst>
   </p:cSld>
@@ -7283,20 +8814,20 @@
 </file>
 
 <file path=customXml/item1.xml><?xml version="1.0" encoding="utf-8"?>
-<p:properties xmlns:p="http://schemas.microsoft.com/office/2006/metadata/properties" xmlns:xsi="http://www.w3.org/2001/XMLSchema-instance" xmlns:pc="http://schemas.microsoft.com/office/infopath/2007/PartnerControls">
-  <documentManagement>
-    <_activity xmlns="bf1a47b5-10f0-4178-af4a-bbe7cc4004c3" xsi:nil="true"/>
-  </documentManagement>
-</p:properties>
-</file>
-
-<file path=customXml/item2.xml><?xml version="1.0" encoding="utf-8"?>
 <?mso-contentType ?>
 <FormTemplates xmlns="http://schemas.microsoft.com/sharepoint/v3/contenttype/forms">
   <Display>DocumentLibraryForm</Display>
   <Edit>DocumentLibraryForm</Edit>
   <New>DocumentLibraryForm</New>
 </FormTemplates>
+</file>
+
+<file path=customXml/item2.xml><?xml version="1.0" encoding="utf-8"?>
+<p:properties xmlns:p="http://schemas.microsoft.com/office/2006/metadata/properties" xmlns:xsi="http://www.w3.org/2001/XMLSchema-instance" xmlns:pc="http://schemas.microsoft.com/office/infopath/2007/PartnerControls">
+  <documentManagement>
+    <_activity xmlns="bf1a47b5-10f0-4178-af4a-bbe7cc4004c3" xsi:nil="true"/>
+  </documentManagement>
+</p:properties>
 </file>
 
 <file path=customXml/item3.xml><?xml version="1.0" encoding="utf-8"?>
@@ -7488,6 +9019,14 @@
 </file>
 
 <file path=customXml/itemProps1.xml><?xml version="1.0" encoding="utf-8"?>
+<ds:datastoreItem xmlns:ds="http://schemas.openxmlformats.org/officeDocument/2006/customXml" ds:itemID="{D12945CB-A677-4013-820C-0AEFE2C4DC48}">
+  <ds:schemaRefs>
+    <ds:schemaRef ds:uri="http://schemas.microsoft.com/sharepoint/v3/contenttype/forms"/>
+  </ds:schemaRefs>
+</ds:datastoreItem>
+</file>
+
+<file path=customXml/itemProps2.xml><?xml version="1.0" encoding="utf-8"?>
 <ds:datastoreItem xmlns:ds="http://schemas.openxmlformats.org/officeDocument/2006/customXml" ds:itemID="{2C2A40F2-5398-4DE1-A8FC-C0BA56DCE4EA}">
   <ds:schemaRefs>
     <ds:schemaRef ds:uri="bf1a47b5-10f0-4178-af4a-bbe7cc4004c3"/>
@@ -7499,14 +9038,6 @@
     <ds:schemaRef ds:uri="http://www.w3.org/XML/1998/namespace"/>
     <ds:schemaRef ds:uri="http://purl.org/dc/dcmitype/"/>
     <ds:schemaRef ds:uri="http://schemas.microsoft.com/office/2006/metadata/properties"/>
-  </ds:schemaRefs>
-</ds:datastoreItem>
-</file>
-
-<file path=customXml/itemProps2.xml><?xml version="1.0" encoding="utf-8"?>
-<ds:datastoreItem xmlns:ds="http://schemas.openxmlformats.org/officeDocument/2006/customXml" ds:itemID="{D12945CB-A677-4013-820C-0AEFE2C4DC48}">
-  <ds:schemaRefs>
-    <ds:schemaRef ds:uri="http://schemas.microsoft.com/sharepoint/v3/contenttype/forms"/>
   </ds:schemaRefs>
 </ds:datastoreItem>
 </file>

</xml_diff>

<commit_message>
small tweaks to presentation
</commit_message>
<xml_diff>
--- a/report/Präsentation.pptx
+++ b/report/Präsentation.pptx
@@ -5,7 +5,7 @@
     <p:sldMasterId id="2147483648" r:id="rId4"/>
   </p:sldMasterIdLst>
   <p:notesMasterIdLst>
-    <p:notesMasterId r:id="rId19"/>
+    <p:notesMasterId r:id="rId17"/>
   </p:notesMasterIdLst>
   <p:sldIdLst>
     <p:sldId id="256" r:id="rId5"/>
@@ -13,15 +13,13 @@
     <p:sldId id="258" r:id="rId7"/>
     <p:sldId id="261" r:id="rId8"/>
     <p:sldId id="263" r:id="rId9"/>
-    <p:sldId id="269" r:id="rId10"/>
-    <p:sldId id="268" r:id="rId11"/>
-    <p:sldId id="264" r:id="rId12"/>
-    <p:sldId id="270" r:id="rId13"/>
-    <p:sldId id="271" r:id="rId14"/>
-    <p:sldId id="262" r:id="rId15"/>
-    <p:sldId id="267" r:id="rId16"/>
-    <p:sldId id="265" r:id="rId17"/>
-    <p:sldId id="266" r:id="rId18"/>
+    <p:sldId id="264" r:id="rId10"/>
+    <p:sldId id="270" r:id="rId11"/>
+    <p:sldId id="271" r:id="rId12"/>
+    <p:sldId id="262" r:id="rId13"/>
+    <p:sldId id="267" r:id="rId14"/>
+    <p:sldId id="265" r:id="rId15"/>
+    <p:sldId id="266" r:id="rId16"/>
   </p:sldIdLst>
   <p:sldSz cx="12192000" cy="6858000"/>
   <p:notesSz cx="6858000" cy="9144000"/>
@@ -543,7 +541,7 @@
           <a:p>
             <a:fld id="{46421F40-A2A0-451B-91E9-F1FF0F435D37}" type="slidenum">
               <a:rPr lang="de-AT" smtClean="0"/>
-              <a:t>8</a:t>
+              <a:t>6</a:t>
             </a:fld>
             <a:endParaRPr lang="de-AT"/>
           </a:p>
@@ -3964,7 +3962,7 @@
         </p:nvSpPr>
         <p:spPr>
           <a:xfrm>
-            <a:off x="8019775" y="6535926"/>
+            <a:off x="6095999" y="6105812"/>
             <a:ext cx="5296450" cy="369332"/>
           </a:xfrm>
           <a:prstGeom prst="rect">
@@ -4019,7 +4017,7 @@
         </p:nvSpPr>
         <p:spPr>
           <a:xfrm>
-            <a:off x="-1200150" y="6105812"/>
+            <a:off x="799551" y="6105812"/>
             <a:ext cx="1007007" cy="646331"/>
           </a:xfrm>
           <a:prstGeom prst="rect">
@@ -4069,7 +4067,7 @@
         </p:nvSpPr>
         <p:spPr>
           <a:xfrm>
-            <a:off x="-1200150" y="6387018"/>
+            <a:off x="838201" y="6356976"/>
             <a:ext cx="2743200" cy="365125"/>
           </a:xfrm>
         </p:spPr>
@@ -4127,526 +4125,6 @@
 </file>
 
 <file path=ppt/slides/slide10.xml><?xml version="1.0" encoding="utf-8"?>
-<p:sld xmlns:a="http://schemas.openxmlformats.org/drawingml/2006/main" xmlns:r="http://schemas.openxmlformats.org/officeDocument/2006/relationships" xmlns:p="http://schemas.openxmlformats.org/presentationml/2006/main">
-  <p:cSld>
-    <p:spTree>
-      <p:nvGrpSpPr>
-        <p:cNvPr id="1" name="">
-          <a:extLst>
-            <a:ext uri="{FF2B5EF4-FFF2-40B4-BE49-F238E27FC236}">
-              <a16:creationId xmlns:a16="http://schemas.microsoft.com/office/drawing/2014/main" id="{8FBE68D7-2926-547B-759F-905B45C7A03D}"/>
-            </a:ext>
-          </a:extLst>
-        </p:cNvPr>
-        <p:cNvGrpSpPr/>
-        <p:nvPr/>
-      </p:nvGrpSpPr>
-      <p:grpSpPr>
-        <a:xfrm>
-          <a:off x="0" y="0"/>
-          <a:ext cx="0" cy="0"/>
-          <a:chOff x="0" y="0"/>
-          <a:chExt cx="0" cy="0"/>
-        </a:xfrm>
-      </p:grpSpPr>
-      <p:sp>
-        <p:nvSpPr>
-          <p:cNvPr id="2" name="Titel 1">
-            <a:extLst>
-              <a:ext uri="{FF2B5EF4-FFF2-40B4-BE49-F238E27FC236}">
-                <a16:creationId xmlns:a16="http://schemas.microsoft.com/office/drawing/2014/main" id="{E480F9FB-47AF-52EB-CAFC-EE7CC7631B52}"/>
-              </a:ext>
-            </a:extLst>
-          </p:cNvPr>
-          <p:cNvSpPr>
-            <a:spLocks noGrp="1"/>
-          </p:cNvSpPr>
-          <p:nvPr>
-            <p:ph type="title"/>
-          </p:nvPr>
-        </p:nvSpPr>
-        <p:spPr/>
-        <p:txBody>
-          <a:bodyPr/>
-          <a:lstStyle/>
-          <a:p>
-            <a:endParaRPr lang="en-GB" noProof="0" dirty="0"/>
-          </a:p>
-        </p:txBody>
-      </p:sp>
-      <p:sp>
-        <p:nvSpPr>
-          <p:cNvPr id="3" name="Inhaltsplatzhalter 2">
-            <a:extLst>
-              <a:ext uri="{FF2B5EF4-FFF2-40B4-BE49-F238E27FC236}">
-                <a16:creationId xmlns:a16="http://schemas.microsoft.com/office/drawing/2014/main" id="{81D83B08-D5ED-F1AE-4C68-8F439E7FE99D}"/>
-              </a:ext>
-            </a:extLst>
-          </p:cNvPr>
-          <p:cNvSpPr>
-            <a:spLocks noGrp="1"/>
-          </p:cNvSpPr>
-          <p:nvPr>
-            <p:ph idx="1"/>
-          </p:nvPr>
-        </p:nvSpPr>
-        <p:spPr/>
-        <p:txBody>
-          <a:bodyPr/>
-          <a:lstStyle/>
-          <a:p>
-            <a:r>
-              <a:rPr lang="en-GB" noProof="0" dirty="0"/>
-              <a:t>Generated Code of used Model and converted it to usable MP-model</a:t>
-            </a:r>
-          </a:p>
-        </p:txBody>
-      </p:sp>
-      <p:sp>
-        <p:nvSpPr>
-          <p:cNvPr id="4" name="Datumsplatzhalter 3">
-            <a:extLst>
-              <a:ext uri="{FF2B5EF4-FFF2-40B4-BE49-F238E27FC236}">
-                <a16:creationId xmlns:a16="http://schemas.microsoft.com/office/drawing/2014/main" id="{1481A1BE-373A-5FDD-44F3-E3FFDC5FED11}"/>
-              </a:ext>
-            </a:extLst>
-          </p:cNvPr>
-          <p:cNvSpPr>
-            <a:spLocks noGrp="1"/>
-          </p:cNvSpPr>
-          <p:nvPr>
-            <p:ph type="dt" sz="half" idx="10"/>
-          </p:nvPr>
-        </p:nvSpPr>
-        <p:spPr/>
-        <p:txBody>
-          <a:bodyPr/>
-          <a:lstStyle/>
-          <a:p>
-            <a:r>
-              <a:rPr lang="en-GB" noProof="0" dirty="0"/>
-              <a:t>23.02.2026</a:t>
-            </a:r>
-          </a:p>
-        </p:txBody>
-      </p:sp>
-      <p:sp>
-        <p:nvSpPr>
-          <p:cNvPr id="5" name="Foliennummernplatzhalter 4">
-            <a:extLst>
-              <a:ext uri="{FF2B5EF4-FFF2-40B4-BE49-F238E27FC236}">
-                <a16:creationId xmlns:a16="http://schemas.microsoft.com/office/drawing/2014/main" id="{A67E69F2-9F56-AF44-B4AD-1335808D1D98}"/>
-              </a:ext>
-            </a:extLst>
-          </p:cNvPr>
-          <p:cNvSpPr>
-            <a:spLocks noGrp="1"/>
-          </p:cNvSpPr>
-          <p:nvPr>
-            <p:ph type="sldNum" sz="quarter" idx="12"/>
-          </p:nvPr>
-        </p:nvSpPr>
-        <p:spPr/>
-        <p:txBody>
-          <a:bodyPr/>
-          <a:lstStyle/>
-          <a:p>
-            <a:fld id="{533690DF-FFD6-462A-8578-786984FF8DCB}" type="slidenum">
-              <a:rPr lang="en-GB" noProof="0" smtClean="0"/>
-              <a:t>10</a:t>
-            </a:fld>
-            <a:endParaRPr lang="en-GB" noProof="0" dirty="0"/>
-          </a:p>
-        </p:txBody>
-      </p:sp>
-      <p:sp>
-        <p:nvSpPr>
-          <p:cNvPr id="8" name="Rectangle: Rounded Corners 3">
-            <a:extLst>
-              <a:ext uri="{FF2B5EF4-FFF2-40B4-BE49-F238E27FC236}">
-                <a16:creationId xmlns:a16="http://schemas.microsoft.com/office/drawing/2014/main" id="{798DA5B3-5766-002C-E7E4-331B21440828}"/>
-              </a:ext>
-            </a:extLst>
-          </p:cNvPr>
-          <p:cNvSpPr/>
-          <p:nvPr/>
-        </p:nvSpPr>
-        <p:spPr bwMode="auto">
-          <a:xfrm>
-            <a:off x="388302" y="681037"/>
-            <a:ext cx="11522076" cy="828438"/>
-          </a:xfrm>
-          <a:prstGeom prst="roundRect">
-            <a:avLst>
-              <a:gd name="adj" fmla="val 9662"/>
-            </a:avLst>
-          </a:prstGeom>
-          <a:solidFill>
-            <a:srgbClr val="0A8276"/>
-          </a:solidFill>
-          <a:ln w="9525">
-            <a:noFill/>
-            <a:miter lim="800000"/>
-            <a:headEnd/>
-            <a:tailEnd/>
-          </a:ln>
-        </p:spPr>
-        <p:txBody>
-          <a:bodyPr rot="0" spcFirstLastPara="0" vertOverflow="overflow" horzOverflow="overflow" vert="horz" wrap="square" lIns="72000" tIns="72000" rIns="72000" bIns="72000" numCol="1" spcCol="0" rtlCol="0" fromWordArt="0" anchor="ctr" anchorCtr="0" forceAA="0" compatLnSpc="1">
-            <a:prstTxWarp prst="textNoShape">
-              <a:avLst/>
-            </a:prstTxWarp>
-            <a:noAutofit/>
-          </a:bodyPr>
-          <a:lstStyle/>
-          <a:p>
-            <a:pPr defTabSz="576000" eaLnBrk="0" fontAlgn="base" hangingPunct="0">
-              <a:lnSpc>
-                <a:spcPct val="120000"/>
-              </a:lnSpc>
-              <a:spcBef>
-                <a:spcPct val="0"/>
-              </a:spcBef>
-              <a:spcAft>
-                <a:spcPct val="0"/>
-              </a:spcAft>
-              <a:defRPr/>
-            </a:pPr>
-            <a:r>
-              <a:rPr lang="en-GB" sz="2000" b="1" kern="0" noProof="0" dirty="0" err="1">
-                <a:solidFill>
-                  <a:srgbClr val="FFFFFF"/>
-                </a:solidFill>
-                <a:latin typeface="Arial"/>
-                <a:cs typeface="Arial"/>
-              </a:rPr>
-              <a:t>Micropython</a:t>
-            </a:r>
-            <a:r>
-              <a:rPr lang="en-GB" sz="2000" b="1" kern="0" noProof="0" dirty="0">
-                <a:solidFill>
-                  <a:srgbClr val="FFFFFF"/>
-                </a:solidFill>
-                <a:latin typeface="Arial"/>
-                <a:cs typeface="Arial"/>
-              </a:rPr>
-              <a:t> Code</a:t>
-            </a:r>
-            <a:endParaRPr lang="en-GB" sz="2000" b="1" i="1" kern="0" baseline="30000" noProof="0" dirty="0">
-              <a:solidFill>
-                <a:srgbClr val="FFFFFF"/>
-              </a:solidFill>
-              <a:latin typeface="Arial"/>
-              <a:cs typeface="Arial"/>
-            </a:endParaRPr>
-          </a:p>
-        </p:txBody>
-      </p:sp>
-    </p:spTree>
-    <p:extLst>
-      <p:ext uri="{BB962C8B-B14F-4D97-AF65-F5344CB8AC3E}">
-        <p14:creationId xmlns:p14="http://schemas.microsoft.com/office/powerpoint/2010/main" val="4267612672"/>
-      </p:ext>
-    </p:extLst>
-  </p:cSld>
-  <p:clrMapOvr>
-    <a:masterClrMapping/>
-  </p:clrMapOvr>
-</p:sld>
-</file>
-
-<file path=ppt/slides/slide11.xml><?xml version="1.0" encoding="utf-8"?>
-<p:sld xmlns:a="http://schemas.openxmlformats.org/drawingml/2006/main" xmlns:r="http://schemas.openxmlformats.org/officeDocument/2006/relationships" xmlns:p="http://schemas.openxmlformats.org/presentationml/2006/main">
-  <p:cSld>
-    <p:spTree>
-      <p:nvGrpSpPr>
-        <p:cNvPr id="1" name="">
-          <a:extLst>
-            <a:ext uri="{FF2B5EF4-FFF2-40B4-BE49-F238E27FC236}">
-              <a16:creationId xmlns:a16="http://schemas.microsoft.com/office/drawing/2014/main" id="{BA88F5AF-2E23-BEFE-6BC1-B4D534AFB1B6}"/>
-            </a:ext>
-          </a:extLst>
-        </p:cNvPr>
-        <p:cNvGrpSpPr/>
-        <p:nvPr/>
-      </p:nvGrpSpPr>
-      <p:grpSpPr>
-        <a:xfrm>
-          <a:off x="0" y="0"/>
-          <a:ext cx="0" cy="0"/>
-          <a:chOff x="0" y="0"/>
-          <a:chExt cx="0" cy="0"/>
-        </a:xfrm>
-      </p:grpSpPr>
-      <p:sp>
-        <p:nvSpPr>
-          <p:cNvPr id="2" name="Titel 1">
-            <a:extLst>
-              <a:ext uri="{FF2B5EF4-FFF2-40B4-BE49-F238E27FC236}">
-                <a16:creationId xmlns:a16="http://schemas.microsoft.com/office/drawing/2014/main" id="{E9F140C5-9AA7-C982-774A-2DE2FE881DE4}"/>
-              </a:ext>
-            </a:extLst>
-          </p:cNvPr>
-          <p:cNvSpPr>
-            <a:spLocks noGrp="1"/>
-          </p:cNvSpPr>
-          <p:nvPr>
-            <p:ph type="title"/>
-          </p:nvPr>
-        </p:nvSpPr>
-        <p:spPr/>
-        <p:txBody>
-          <a:bodyPr/>
-          <a:lstStyle/>
-          <a:p>
-            <a:endParaRPr lang="en-GB" noProof="0" dirty="0"/>
-          </a:p>
-        </p:txBody>
-      </p:sp>
-      <p:sp>
-        <p:nvSpPr>
-          <p:cNvPr id="3" name="Inhaltsplatzhalter 2">
-            <a:extLst>
-              <a:ext uri="{FF2B5EF4-FFF2-40B4-BE49-F238E27FC236}">
-                <a16:creationId xmlns:a16="http://schemas.microsoft.com/office/drawing/2014/main" id="{16E70A6D-D365-C64A-387A-75AAE10CB406}"/>
-              </a:ext>
-            </a:extLst>
-          </p:cNvPr>
-          <p:cNvSpPr>
-            <a:spLocks noGrp="1"/>
-          </p:cNvSpPr>
-          <p:nvPr>
-            <p:ph idx="1"/>
-          </p:nvPr>
-        </p:nvSpPr>
-        <p:spPr/>
-        <p:txBody>
-          <a:bodyPr>
-            <a:normAutofit fontScale="92500" lnSpcReduction="10000"/>
-          </a:bodyPr>
-          <a:lstStyle/>
-          <a:p>
-            <a:r>
-              <a:rPr lang="en-GB" noProof="0" dirty="0"/>
-              <a:t>Overlapping labels</a:t>
-            </a:r>
-            <a:r>
-              <a:rPr lang="en-GB" dirty="0"/>
-              <a:t>, DEEPCRAFT Studio sometimes set two labels above each other</a:t>
-            </a:r>
-            <a:endParaRPr lang="en-GB" noProof="0" dirty="0"/>
-          </a:p>
-          <a:p>
-            <a:r>
-              <a:rPr lang="en-GB" noProof="0" dirty="0"/>
-              <a:t>No clear indications on what ma</a:t>
-            </a:r>
-            <a:r>
-              <a:rPr lang="en-GB" dirty="0" err="1"/>
-              <a:t>kes</a:t>
-            </a:r>
-            <a:r>
-              <a:rPr lang="en-GB" dirty="0"/>
-              <a:t> model better or worse</a:t>
-            </a:r>
-          </a:p>
-          <a:p>
-            <a:r>
-              <a:rPr lang="en-GB" dirty="0"/>
-              <a:t>It was not achievable to enqueue Data fast enough in our </a:t>
-            </a:r>
-            <a:r>
-              <a:rPr lang="en-GB" dirty="0" err="1"/>
-              <a:t>Micropython</a:t>
-            </a:r>
-            <a:r>
-              <a:rPr lang="en-GB" dirty="0"/>
-              <a:t> Code (fastest Loop runtime 3ms). Needed to </a:t>
-            </a:r>
-            <a:r>
-              <a:rPr lang="en-GB" dirty="0" err="1"/>
-              <a:t>downsample</a:t>
-            </a:r>
-            <a:r>
-              <a:rPr lang="en-GB" dirty="0"/>
-              <a:t> our Data to 100Hz</a:t>
-            </a:r>
-          </a:p>
-          <a:p>
-            <a:r>
-              <a:rPr lang="en-GB" dirty="0"/>
-              <a:t>Using an if-selection to time enqueue did not work/lead to the PSOC6 stalling after a few seconds (Busy waiting). Used </a:t>
-            </a:r>
-            <a:r>
-              <a:rPr lang="en-GB" dirty="0" err="1"/>
-              <a:t>time.wait_ms</a:t>
-            </a:r>
-            <a:r>
-              <a:rPr lang="en-GB" dirty="0"/>
-              <a:t>() instead</a:t>
-            </a:r>
-          </a:p>
-          <a:p>
-            <a:r>
-              <a:rPr lang="en-GB" dirty="0"/>
-              <a:t>Predictions for one punch are greater than 0.6 over two contextual windows.</a:t>
-            </a:r>
-          </a:p>
-          <a:p>
-            <a:endParaRPr lang="en-GB" dirty="0"/>
-          </a:p>
-          <a:p>
-            <a:endParaRPr lang="en-GB" dirty="0"/>
-          </a:p>
-          <a:p>
-            <a:endParaRPr lang="en-GB" noProof="0" dirty="0"/>
-          </a:p>
-        </p:txBody>
-      </p:sp>
-      <p:sp>
-        <p:nvSpPr>
-          <p:cNvPr id="4" name="Datumsplatzhalter 3">
-            <a:extLst>
-              <a:ext uri="{FF2B5EF4-FFF2-40B4-BE49-F238E27FC236}">
-                <a16:creationId xmlns:a16="http://schemas.microsoft.com/office/drawing/2014/main" id="{A662B3FA-00C1-9EE6-1D74-E4B044BBECD8}"/>
-              </a:ext>
-            </a:extLst>
-          </p:cNvPr>
-          <p:cNvSpPr>
-            <a:spLocks noGrp="1"/>
-          </p:cNvSpPr>
-          <p:nvPr>
-            <p:ph type="dt" sz="half" idx="10"/>
-          </p:nvPr>
-        </p:nvSpPr>
-        <p:spPr/>
-        <p:txBody>
-          <a:bodyPr/>
-          <a:lstStyle/>
-          <a:p>
-            <a:r>
-              <a:rPr lang="en-GB" noProof="0" dirty="0"/>
-              <a:t>23.02.2026</a:t>
-            </a:r>
-          </a:p>
-        </p:txBody>
-      </p:sp>
-      <p:sp>
-        <p:nvSpPr>
-          <p:cNvPr id="5" name="Foliennummernplatzhalter 4">
-            <a:extLst>
-              <a:ext uri="{FF2B5EF4-FFF2-40B4-BE49-F238E27FC236}">
-                <a16:creationId xmlns:a16="http://schemas.microsoft.com/office/drawing/2014/main" id="{1358572C-AB05-ECD6-B505-C87F61376D78}"/>
-              </a:ext>
-            </a:extLst>
-          </p:cNvPr>
-          <p:cNvSpPr>
-            <a:spLocks noGrp="1"/>
-          </p:cNvSpPr>
-          <p:nvPr>
-            <p:ph type="sldNum" sz="quarter" idx="12"/>
-          </p:nvPr>
-        </p:nvSpPr>
-        <p:spPr/>
-        <p:txBody>
-          <a:bodyPr/>
-          <a:lstStyle/>
-          <a:p>
-            <a:fld id="{533690DF-FFD6-462A-8578-786984FF8DCB}" type="slidenum">
-              <a:rPr lang="en-GB" noProof="0" smtClean="0"/>
-              <a:t>11</a:t>
-            </a:fld>
-            <a:endParaRPr lang="en-GB" noProof="0" dirty="0"/>
-          </a:p>
-        </p:txBody>
-      </p:sp>
-      <p:sp>
-        <p:nvSpPr>
-          <p:cNvPr id="8" name="Rectangle: Rounded Corners 3">
-            <a:extLst>
-              <a:ext uri="{FF2B5EF4-FFF2-40B4-BE49-F238E27FC236}">
-                <a16:creationId xmlns:a16="http://schemas.microsoft.com/office/drawing/2014/main" id="{2B3438B7-EF5B-59AA-36AC-D1B6B1D0A3AA}"/>
-              </a:ext>
-            </a:extLst>
-          </p:cNvPr>
-          <p:cNvSpPr/>
-          <p:nvPr/>
-        </p:nvSpPr>
-        <p:spPr bwMode="auto">
-          <a:xfrm>
-            <a:off x="388302" y="681037"/>
-            <a:ext cx="11522076" cy="828438"/>
-          </a:xfrm>
-          <a:prstGeom prst="roundRect">
-            <a:avLst>
-              <a:gd name="adj" fmla="val 9662"/>
-            </a:avLst>
-          </a:prstGeom>
-          <a:solidFill>
-            <a:srgbClr val="0A8276"/>
-          </a:solidFill>
-          <a:ln w="9525">
-            <a:noFill/>
-            <a:miter lim="800000"/>
-            <a:headEnd/>
-            <a:tailEnd/>
-          </a:ln>
-        </p:spPr>
-        <p:txBody>
-          <a:bodyPr rot="0" spcFirstLastPara="0" vertOverflow="overflow" horzOverflow="overflow" vert="horz" wrap="square" lIns="72000" tIns="72000" rIns="72000" bIns="72000" numCol="1" spcCol="0" rtlCol="0" fromWordArt="0" anchor="ctr" anchorCtr="0" forceAA="0" compatLnSpc="1">
-            <a:prstTxWarp prst="textNoShape">
-              <a:avLst/>
-            </a:prstTxWarp>
-            <a:noAutofit/>
-          </a:bodyPr>
-          <a:lstStyle/>
-          <a:p>
-            <a:pPr defTabSz="576000" eaLnBrk="0" fontAlgn="base" hangingPunct="0">
-              <a:lnSpc>
-                <a:spcPct val="120000"/>
-              </a:lnSpc>
-              <a:spcBef>
-                <a:spcPct val="0"/>
-              </a:spcBef>
-              <a:spcAft>
-                <a:spcPct val="0"/>
-              </a:spcAft>
-              <a:defRPr/>
-            </a:pPr>
-            <a:r>
-              <a:rPr lang="en-GB" sz="2000" b="1" kern="0" noProof="0" dirty="0">
-                <a:solidFill>
-                  <a:srgbClr val="FFFFFF"/>
-                </a:solidFill>
-                <a:latin typeface="Arial"/>
-                <a:cs typeface="Arial"/>
-              </a:rPr>
-              <a:t>Problems faced</a:t>
-            </a:r>
-            <a:endParaRPr lang="en-GB" sz="2000" b="1" i="1" kern="0" baseline="30000" noProof="0" dirty="0">
-              <a:solidFill>
-                <a:srgbClr val="FFFFFF"/>
-              </a:solidFill>
-              <a:latin typeface="Arial"/>
-              <a:cs typeface="Arial"/>
-            </a:endParaRPr>
-          </a:p>
-        </p:txBody>
-      </p:sp>
-    </p:spTree>
-    <p:extLst>
-      <p:ext uri="{BB962C8B-B14F-4D97-AF65-F5344CB8AC3E}">
-        <p14:creationId xmlns:p14="http://schemas.microsoft.com/office/powerpoint/2010/main" val="616278457"/>
-      </p:ext>
-    </p:extLst>
-  </p:cSld>
-  <p:clrMapOvr>
-    <a:masterClrMapping/>
-  </p:clrMapOvr>
-</p:sld>
-</file>
-
-<file path=ppt/slides/slide12.xml><?xml version="1.0" encoding="utf-8"?>
 <p:sld xmlns:a="http://schemas.openxmlformats.org/drawingml/2006/main" xmlns:r="http://schemas.openxmlformats.org/officeDocument/2006/relationships" xmlns:p="http://schemas.openxmlformats.org/presentationml/2006/main">
   <p:cSld>
     <p:spTree>
@@ -4734,7 +4212,7 @@
           <a:p>
             <a:r>
               <a:rPr lang="en-GB" dirty="0"/>
-              <a:t>Gather data of left hand punches to make it suitable for real training purposes</a:t>
+              <a:t>Gather data of left-handed punches to make it suitable for real training purposes</a:t>
             </a:r>
           </a:p>
           <a:p>
@@ -4820,7 +4298,7 @@
           <a:p>
             <a:fld id="{533690DF-FFD6-462A-8578-786984FF8DCB}" type="slidenum">
               <a:rPr lang="en-GB" noProof="0" smtClean="0"/>
-              <a:t>12</a:t>
+              <a:t>10</a:t>
             </a:fld>
             <a:endParaRPr lang="en-GB" noProof="0" dirty="0"/>
           </a:p>
@@ -4922,7 +4400,7 @@
 </p:sld>
 </file>
 
-<file path=ppt/slides/slide13.xml><?xml version="1.0" encoding="utf-8"?>
+<file path=ppt/slides/slide11.xml><?xml version="1.0" encoding="utf-8"?>
 <p:sld xmlns:a="http://schemas.openxmlformats.org/drawingml/2006/main" xmlns:r="http://schemas.openxmlformats.org/officeDocument/2006/relationships" xmlns:p="http://schemas.openxmlformats.org/presentationml/2006/main">
   <p:cSld>
     <p:spTree>
@@ -5046,7 +4524,7 @@
           <a:p>
             <a:fld id="{533690DF-FFD6-462A-8578-786984FF8DCB}" type="slidenum">
               <a:rPr lang="en-GB" noProof="0" smtClean="0"/>
-              <a:t>13</a:t>
+              <a:t>11</a:t>
             </a:fld>
             <a:endParaRPr lang="en-GB" noProof="0" dirty="0"/>
           </a:p>
@@ -5148,7 +4626,7 @@
 </p:sld>
 </file>
 
-<file path=ppt/slides/slide14.xml><?xml version="1.0" encoding="utf-8"?>
+<file path=ppt/slides/slide12.xml><?xml version="1.0" encoding="utf-8"?>
 <p:sld xmlns:a="http://schemas.openxmlformats.org/drawingml/2006/main" xmlns:r="http://schemas.openxmlformats.org/officeDocument/2006/relationships" xmlns:p="http://schemas.openxmlformats.org/presentationml/2006/main">
   <p:cSld>
     <p:spTree>
@@ -5272,7 +4750,7 @@
           <a:p>
             <a:fld id="{533690DF-FFD6-462A-8578-786984FF8DCB}" type="slidenum">
               <a:rPr lang="en-GB" noProof="0" smtClean="0"/>
-              <a:t>14</a:t>
+              <a:t>12</a:t>
             </a:fld>
             <a:endParaRPr lang="en-GB" noProof="0" dirty="0"/>
           </a:p>
@@ -6966,468 +6444,6 @@
 </file>
 
 <file path=ppt/slides/slide6.xml><?xml version="1.0" encoding="utf-8"?>
-<p:sld xmlns:a="http://schemas.openxmlformats.org/drawingml/2006/main" xmlns:r="http://schemas.openxmlformats.org/officeDocument/2006/relationships" xmlns:p="http://schemas.openxmlformats.org/presentationml/2006/main">
-  <p:cSld>
-    <p:spTree>
-      <p:nvGrpSpPr>
-        <p:cNvPr id="1" name="">
-          <a:extLst>
-            <a:ext uri="{FF2B5EF4-FFF2-40B4-BE49-F238E27FC236}">
-              <a16:creationId xmlns:a16="http://schemas.microsoft.com/office/drawing/2014/main" id="{4CC4AA44-61AD-F664-DB0E-92EA8157D7BB}"/>
-            </a:ext>
-          </a:extLst>
-        </p:cNvPr>
-        <p:cNvGrpSpPr/>
-        <p:nvPr/>
-      </p:nvGrpSpPr>
-      <p:grpSpPr>
-        <a:xfrm>
-          <a:off x="0" y="0"/>
-          <a:ext cx="0" cy="0"/>
-          <a:chOff x="0" y="0"/>
-          <a:chExt cx="0" cy="0"/>
-        </a:xfrm>
-      </p:grpSpPr>
-      <p:sp>
-        <p:nvSpPr>
-          <p:cNvPr id="2" name="Titel 1">
-            <a:extLst>
-              <a:ext uri="{FF2B5EF4-FFF2-40B4-BE49-F238E27FC236}">
-                <a16:creationId xmlns:a16="http://schemas.microsoft.com/office/drawing/2014/main" id="{49CFFF75-DD03-697D-B265-C835B0118C8F}"/>
-              </a:ext>
-            </a:extLst>
-          </p:cNvPr>
-          <p:cNvSpPr>
-            <a:spLocks noGrp="1"/>
-          </p:cNvSpPr>
-          <p:nvPr>
-            <p:ph type="title"/>
-          </p:nvPr>
-        </p:nvSpPr>
-        <p:spPr/>
-        <p:txBody>
-          <a:bodyPr/>
-          <a:lstStyle/>
-          <a:p>
-            <a:endParaRPr lang="en-GB" noProof="0" dirty="0"/>
-          </a:p>
-        </p:txBody>
-      </p:sp>
-      <p:sp>
-        <p:nvSpPr>
-          <p:cNvPr id="4" name="Datumsplatzhalter 3">
-            <a:extLst>
-              <a:ext uri="{FF2B5EF4-FFF2-40B4-BE49-F238E27FC236}">
-                <a16:creationId xmlns:a16="http://schemas.microsoft.com/office/drawing/2014/main" id="{AB15BA3A-6FC4-9E95-9E85-C621A22BD6E0}"/>
-              </a:ext>
-            </a:extLst>
-          </p:cNvPr>
-          <p:cNvSpPr>
-            <a:spLocks noGrp="1"/>
-          </p:cNvSpPr>
-          <p:nvPr>
-            <p:ph type="dt" sz="half" idx="10"/>
-          </p:nvPr>
-        </p:nvSpPr>
-        <p:spPr/>
-        <p:txBody>
-          <a:bodyPr/>
-          <a:lstStyle/>
-          <a:p>
-            <a:r>
-              <a:rPr lang="en-GB" noProof="0" dirty="0"/>
-              <a:t>23.02.2026</a:t>
-            </a:r>
-          </a:p>
-        </p:txBody>
-      </p:sp>
-      <p:sp>
-        <p:nvSpPr>
-          <p:cNvPr id="5" name="Foliennummernplatzhalter 4">
-            <a:extLst>
-              <a:ext uri="{FF2B5EF4-FFF2-40B4-BE49-F238E27FC236}">
-                <a16:creationId xmlns:a16="http://schemas.microsoft.com/office/drawing/2014/main" id="{804E4EFE-C314-C370-F090-1B891EF01289}"/>
-              </a:ext>
-            </a:extLst>
-          </p:cNvPr>
-          <p:cNvSpPr>
-            <a:spLocks noGrp="1"/>
-          </p:cNvSpPr>
-          <p:nvPr>
-            <p:ph type="sldNum" sz="quarter" idx="12"/>
-          </p:nvPr>
-        </p:nvSpPr>
-        <p:spPr/>
-        <p:txBody>
-          <a:bodyPr/>
-          <a:lstStyle/>
-          <a:p>
-            <a:fld id="{533690DF-FFD6-462A-8578-786984FF8DCB}" type="slidenum">
-              <a:rPr lang="en-GB" noProof="0" smtClean="0"/>
-              <a:t>6</a:t>
-            </a:fld>
-            <a:endParaRPr lang="en-GB" noProof="0" dirty="0"/>
-          </a:p>
-        </p:txBody>
-      </p:sp>
-      <p:sp>
-        <p:nvSpPr>
-          <p:cNvPr id="8" name="Rectangle: Rounded Corners 3">
-            <a:extLst>
-              <a:ext uri="{FF2B5EF4-FFF2-40B4-BE49-F238E27FC236}">
-                <a16:creationId xmlns:a16="http://schemas.microsoft.com/office/drawing/2014/main" id="{02461553-91C8-D815-FE9B-DE812F985953}"/>
-              </a:ext>
-            </a:extLst>
-          </p:cNvPr>
-          <p:cNvSpPr/>
-          <p:nvPr/>
-        </p:nvSpPr>
-        <p:spPr bwMode="auto">
-          <a:xfrm>
-            <a:off x="388302" y="681037"/>
-            <a:ext cx="11522076" cy="828438"/>
-          </a:xfrm>
-          <a:prstGeom prst="roundRect">
-            <a:avLst>
-              <a:gd name="adj" fmla="val 9662"/>
-            </a:avLst>
-          </a:prstGeom>
-          <a:solidFill>
-            <a:srgbClr val="0A8276"/>
-          </a:solidFill>
-          <a:ln w="9525">
-            <a:noFill/>
-            <a:miter lim="800000"/>
-            <a:headEnd/>
-            <a:tailEnd/>
-          </a:ln>
-        </p:spPr>
-        <p:txBody>
-          <a:bodyPr rot="0" spcFirstLastPara="0" vertOverflow="overflow" horzOverflow="overflow" vert="horz" wrap="square" lIns="72000" tIns="72000" rIns="72000" bIns="72000" numCol="1" spcCol="0" rtlCol="0" fromWordArt="0" anchor="ctr" anchorCtr="0" forceAA="0" compatLnSpc="1">
-            <a:prstTxWarp prst="textNoShape">
-              <a:avLst/>
-            </a:prstTxWarp>
-            <a:noAutofit/>
-          </a:bodyPr>
-          <a:lstStyle/>
-          <a:p>
-            <a:pPr defTabSz="576000" eaLnBrk="0" fontAlgn="base" hangingPunct="0">
-              <a:lnSpc>
-                <a:spcPct val="120000"/>
-              </a:lnSpc>
-              <a:spcBef>
-                <a:spcPct val="0"/>
-              </a:spcBef>
-              <a:spcAft>
-                <a:spcPct val="0"/>
-              </a:spcAft>
-              <a:defRPr/>
-            </a:pPr>
-            <a:r>
-              <a:rPr lang="en-GB" sz="2000" b="1" kern="0" noProof="0" dirty="0">
-                <a:solidFill>
-                  <a:srgbClr val="FFFFFF"/>
-                </a:solidFill>
-                <a:latin typeface="Arial"/>
-                <a:cs typeface="Arial"/>
-              </a:rPr>
-              <a:t>Final Classification</a:t>
-            </a:r>
-            <a:endParaRPr lang="en-GB" sz="2000" b="1" i="1" kern="0" baseline="30000" noProof="0" dirty="0">
-              <a:solidFill>
-                <a:srgbClr val="FFFFFF"/>
-              </a:solidFill>
-              <a:latin typeface="Arial"/>
-              <a:cs typeface="Arial"/>
-            </a:endParaRPr>
-          </a:p>
-        </p:txBody>
-      </p:sp>
-    </p:spTree>
-    <p:extLst>
-      <p:ext uri="{BB962C8B-B14F-4D97-AF65-F5344CB8AC3E}">
-        <p14:creationId xmlns:p14="http://schemas.microsoft.com/office/powerpoint/2010/main" val="970482609"/>
-      </p:ext>
-    </p:extLst>
-  </p:cSld>
-  <p:clrMapOvr>
-    <a:masterClrMapping/>
-  </p:clrMapOvr>
-</p:sld>
-</file>
-
-<file path=ppt/slides/slide7.xml><?xml version="1.0" encoding="utf-8"?>
-<p:sld xmlns:a="http://schemas.openxmlformats.org/drawingml/2006/main" xmlns:r="http://schemas.openxmlformats.org/officeDocument/2006/relationships" xmlns:p="http://schemas.openxmlformats.org/presentationml/2006/main">
-  <p:cSld>
-    <p:spTree>
-      <p:nvGrpSpPr>
-        <p:cNvPr id="1" name="">
-          <a:extLst>
-            <a:ext uri="{FF2B5EF4-FFF2-40B4-BE49-F238E27FC236}">
-              <a16:creationId xmlns:a16="http://schemas.microsoft.com/office/drawing/2014/main" id="{280EE75E-5108-46B8-62A9-756FA80008F7}"/>
-            </a:ext>
-          </a:extLst>
-        </p:cNvPr>
-        <p:cNvGrpSpPr/>
-        <p:nvPr/>
-      </p:nvGrpSpPr>
-      <p:grpSpPr>
-        <a:xfrm>
-          <a:off x="0" y="0"/>
-          <a:ext cx="0" cy="0"/>
-          <a:chOff x="0" y="0"/>
-          <a:chExt cx="0" cy="0"/>
-        </a:xfrm>
-      </p:grpSpPr>
-      <p:sp>
-        <p:nvSpPr>
-          <p:cNvPr id="2" name="Titel 1">
-            <a:extLst>
-              <a:ext uri="{FF2B5EF4-FFF2-40B4-BE49-F238E27FC236}">
-                <a16:creationId xmlns:a16="http://schemas.microsoft.com/office/drawing/2014/main" id="{8AE88A22-0200-BECC-3D5A-C1D591067494}"/>
-              </a:ext>
-            </a:extLst>
-          </p:cNvPr>
-          <p:cNvSpPr>
-            <a:spLocks noGrp="1"/>
-          </p:cNvSpPr>
-          <p:nvPr>
-            <p:ph type="title"/>
-          </p:nvPr>
-        </p:nvSpPr>
-        <p:spPr/>
-        <p:txBody>
-          <a:bodyPr/>
-          <a:lstStyle/>
-          <a:p>
-            <a:endParaRPr lang="en-GB" noProof="0" dirty="0"/>
-          </a:p>
-        </p:txBody>
-      </p:sp>
-      <p:sp>
-        <p:nvSpPr>
-          <p:cNvPr id="3" name="Inhaltsplatzhalter 2">
-            <a:extLst>
-              <a:ext uri="{FF2B5EF4-FFF2-40B4-BE49-F238E27FC236}">
-                <a16:creationId xmlns:a16="http://schemas.microsoft.com/office/drawing/2014/main" id="{60F60114-55DF-203C-72A4-F9F8BDFB6CC6}"/>
-              </a:ext>
-            </a:extLst>
-          </p:cNvPr>
-          <p:cNvSpPr>
-            <a:spLocks noGrp="1"/>
-          </p:cNvSpPr>
-          <p:nvPr>
-            <p:ph idx="1"/>
-          </p:nvPr>
-        </p:nvSpPr>
-        <p:spPr/>
-        <p:txBody>
-          <a:bodyPr/>
-          <a:lstStyle/>
-          <a:p>
-            <a:r>
-              <a:rPr lang="en-GB" noProof="0" dirty="0"/>
-              <a:t>Only Data of one person was used to achieve greater accuracy</a:t>
-            </a:r>
-            <a:endParaRPr lang="en-GB" dirty="0"/>
-          </a:p>
-          <a:p>
-            <a:r>
-              <a:rPr lang="en-GB" dirty="0"/>
-              <a:t>Train/Validation/Test split is roughly 60/20/20</a:t>
-            </a:r>
-          </a:p>
-          <a:p>
-            <a:r>
-              <a:rPr lang="en-GB" dirty="0"/>
-              <a:t>45 minutes of data, 18,5 of which are labelled</a:t>
-            </a:r>
-          </a:p>
-          <a:p>
-            <a:r>
-              <a:rPr lang="en-GB" dirty="0"/>
-              <a:t>Implemented negative Data (warming up, neither distinct punches nor no movement)</a:t>
-            </a:r>
-          </a:p>
-          <a:p>
-            <a:endParaRPr lang="en-GB" noProof="0" dirty="0"/>
-          </a:p>
-        </p:txBody>
-      </p:sp>
-      <p:sp>
-        <p:nvSpPr>
-          <p:cNvPr id="4" name="Datumsplatzhalter 3">
-            <a:extLst>
-              <a:ext uri="{FF2B5EF4-FFF2-40B4-BE49-F238E27FC236}">
-                <a16:creationId xmlns:a16="http://schemas.microsoft.com/office/drawing/2014/main" id="{DD3A848D-BACC-28FB-C47D-31CAE0EF62B5}"/>
-              </a:ext>
-            </a:extLst>
-          </p:cNvPr>
-          <p:cNvSpPr>
-            <a:spLocks noGrp="1"/>
-          </p:cNvSpPr>
-          <p:nvPr>
-            <p:ph type="dt" sz="half" idx="10"/>
-          </p:nvPr>
-        </p:nvSpPr>
-        <p:spPr/>
-        <p:txBody>
-          <a:bodyPr/>
-          <a:lstStyle/>
-          <a:p>
-            <a:r>
-              <a:rPr lang="en-GB" noProof="0" dirty="0"/>
-              <a:t>23.02.2026</a:t>
-            </a:r>
-          </a:p>
-        </p:txBody>
-      </p:sp>
-      <p:sp>
-        <p:nvSpPr>
-          <p:cNvPr id="5" name="Foliennummernplatzhalter 4">
-            <a:extLst>
-              <a:ext uri="{FF2B5EF4-FFF2-40B4-BE49-F238E27FC236}">
-                <a16:creationId xmlns:a16="http://schemas.microsoft.com/office/drawing/2014/main" id="{0196C664-9F44-6398-877F-88648A2B4E48}"/>
-              </a:ext>
-            </a:extLst>
-          </p:cNvPr>
-          <p:cNvSpPr>
-            <a:spLocks noGrp="1"/>
-          </p:cNvSpPr>
-          <p:nvPr>
-            <p:ph type="sldNum" sz="quarter" idx="12"/>
-          </p:nvPr>
-        </p:nvSpPr>
-        <p:spPr/>
-        <p:txBody>
-          <a:bodyPr/>
-          <a:lstStyle/>
-          <a:p>
-            <a:fld id="{533690DF-FFD6-462A-8578-786984FF8DCB}" type="slidenum">
-              <a:rPr lang="en-GB" noProof="0" smtClean="0"/>
-              <a:t>7</a:t>
-            </a:fld>
-            <a:endParaRPr lang="en-GB" noProof="0" dirty="0"/>
-          </a:p>
-        </p:txBody>
-      </p:sp>
-      <p:sp>
-        <p:nvSpPr>
-          <p:cNvPr id="8" name="Rectangle: Rounded Corners 3">
-            <a:extLst>
-              <a:ext uri="{FF2B5EF4-FFF2-40B4-BE49-F238E27FC236}">
-                <a16:creationId xmlns:a16="http://schemas.microsoft.com/office/drawing/2014/main" id="{6D7C1CA4-8C72-9FE4-9F2B-F4C5C4AAE056}"/>
-              </a:ext>
-            </a:extLst>
-          </p:cNvPr>
-          <p:cNvSpPr/>
-          <p:nvPr/>
-        </p:nvSpPr>
-        <p:spPr bwMode="auto">
-          <a:xfrm>
-            <a:off x="388302" y="681037"/>
-            <a:ext cx="11522076" cy="828438"/>
-          </a:xfrm>
-          <a:prstGeom prst="roundRect">
-            <a:avLst>
-              <a:gd name="adj" fmla="val 9662"/>
-            </a:avLst>
-          </a:prstGeom>
-          <a:solidFill>
-            <a:srgbClr val="0A8276"/>
-          </a:solidFill>
-          <a:ln w="9525">
-            <a:noFill/>
-            <a:miter lim="800000"/>
-            <a:headEnd/>
-            <a:tailEnd/>
-          </a:ln>
-        </p:spPr>
-        <p:txBody>
-          <a:bodyPr rot="0" spcFirstLastPara="0" vertOverflow="overflow" horzOverflow="overflow" vert="horz" wrap="square" lIns="72000" tIns="72000" rIns="72000" bIns="72000" numCol="1" spcCol="0" rtlCol="0" fromWordArt="0" anchor="ctr" anchorCtr="0" forceAA="0" compatLnSpc="1">
-            <a:prstTxWarp prst="textNoShape">
-              <a:avLst/>
-            </a:prstTxWarp>
-            <a:noAutofit/>
-          </a:bodyPr>
-          <a:lstStyle/>
-          <a:p>
-            <a:pPr defTabSz="576000" eaLnBrk="0" fontAlgn="base" hangingPunct="0">
-              <a:lnSpc>
-                <a:spcPct val="120000"/>
-              </a:lnSpc>
-              <a:spcBef>
-                <a:spcPct val="0"/>
-              </a:spcBef>
-              <a:spcAft>
-                <a:spcPct val="0"/>
-              </a:spcAft>
-              <a:defRPr/>
-            </a:pPr>
-            <a:r>
-              <a:rPr lang="en-GB" sz="2000" b="1" kern="0" noProof="0" dirty="0">
-                <a:solidFill>
-                  <a:srgbClr val="FFFFFF"/>
-                </a:solidFill>
-                <a:latin typeface="Arial"/>
-                <a:cs typeface="Arial"/>
-              </a:rPr>
-              <a:t>Final Classification</a:t>
-            </a:r>
-            <a:endParaRPr lang="en-GB" sz="2000" b="1" i="1" kern="0" baseline="30000" noProof="0" dirty="0">
-              <a:solidFill>
-                <a:srgbClr val="FFFFFF"/>
-              </a:solidFill>
-              <a:latin typeface="Arial"/>
-              <a:cs typeface="Arial"/>
-            </a:endParaRPr>
-          </a:p>
-        </p:txBody>
-      </p:sp>
-      <p:pic>
-        <p:nvPicPr>
-          <p:cNvPr id="7" name="Grafik 6" descr="Ein Bild, das Screenshot, Text, Zahl, Schrift enthält.&#10;&#10;KI-generierte Inhalte können fehlerhaft sein.">
-            <a:extLst>
-              <a:ext uri="{FF2B5EF4-FFF2-40B4-BE49-F238E27FC236}">
-                <a16:creationId xmlns:a16="http://schemas.microsoft.com/office/drawing/2014/main" id="{CE170180-FF02-18F9-A44F-793522F1215B}"/>
-              </a:ext>
-            </a:extLst>
-          </p:cNvPr>
-          <p:cNvPicPr>
-            <a:picLocks noChangeAspect="1"/>
-          </p:cNvPicPr>
-          <p:nvPr/>
-        </p:nvPicPr>
-        <p:blipFill>
-          <a:blip r:embed="rId2"/>
-          <a:stretch>
-            <a:fillRect/>
-          </a:stretch>
-        </p:blipFill>
-        <p:spPr>
-          <a:xfrm>
-            <a:off x="2513335" y="4254368"/>
-            <a:ext cx="7272010" cy="2101982"/>
-          </a:xfrm>
-          <a:prstGeom prst="rect">
-            <a:avLst/>
-          </a:prstGeom>
-        </p:spPr>
-      </p:pic>
-    </p:spTree>
-    <p:extLst>
-      <p:ext uri="{BB962C8B-B14F-4D97-AF65-F5344CB8AC3E}">
-        <p14:creationId xmlns:p14="http://schemas.microsoft.com/office/powerpoint/2010/main" val="1447199446"/>
-      </p:ext>
-    </p:extLst>
-  </p:cSld>
-  <p:clrMapOvr>
-    <a:masterClrMapping/>
-  </p:clrMapOvr>
-</p:sld>
-</file>
-
-<file path=ppt/slides/slide8.xml><?xml version="1.0" encoding="utf-8"?>
 <p:sld xmlns:a="http://schemas.openxmlformats.org/drawingml/2006/main" xmlns:r="http://schemas.openxmlformats.org/officeDocument/2006/relationships" xmlns:p="http://schemas.openxmlformats.org/presentationml/2006/main">
   <p:cSld>
     <p:bg>
@@ -7738,7 +6754,7 @@
                   <a:spcPts val="600"/>
                 </a:spcAft>
               </a:pPr>
-              <a:t>8</a:t>
+              <a:t>6</a:t>
             </a:fld>
             <a:endParaRPr lang="en-US" noProof="0">
               <a:solidFill>
@@ -7851,7 +6867,7 @@
 </p:sld>
 </file>
 
-<file path=ppt/slides/slide9.xml><?xml version="1.0" encoding="utf-8"?>
+<file path=ppt/slides/slide7.xml><?xml version="1.0" encoding="utf-8"?>
 <p:sld xmlns:a="http://schemas.openxmlformats.org/drawingml/2006/main" xmlns:r="http://schemas.openxmlformats.org/officeDocument/2006/relationships" xmlns:p="http://schemas.openxmlformats.org/presentationml/2006/main">
   <p:cSld>
     <p:spTree>
@@ -8031,7 +7047,7 @@
           <a:p>
             <a:fld id="{533690DF-FFD6-462A-8578-786984FF8DCB}" type="slidenum">
               <a:rPr lang="en-GB" noProof="0" smtClean="0"/>
-              <a:t>9</a:t>
+              <a:t>7</a:t>
             </a:fld>
             <a:endParaRPr lang="en-GB" noProof="0" dirty="0"/>
           </a:p>
@@ -8174,6 +7190,526 @@
     <p:extLst>
       <p:ext uri="{BB962C8B-B14F-4D97-AF65-F5344CB8AC3E}">
         <p14:creationId xmlns:p14="http://schemas.microsoft.com/office/powerpoint/2010/main" val="4245453861"/>
+      </p:ext>
+    </p:extLst>
+  </p:cSld>
+  <p:clrMapOvr>
+    <a:masterClrMapping/>
+  </p:clrMapOvr>
+</p:sld>
+</file>
+
+<file path=ppt/slides/slide8.xml><?xml version="1.0" encoding="utf-8"?>
+<p:sld xmlns:a="http://schemas.openxmlformats.org/drawingml/2006/main" xmlns:r="http://schemas.openxmlformats.org/officeDocument/2006/relationships" xmlns:p="http://schemas.openxmlformats.org/presentationml/2006/main">
+  <p:cSld>
+    <p:spTree>
+      <p:nvGrpSpPr>
+        <p:cNvPr id="1" name="">
+          <a:extLst>
+            <a:ext uri="{FF2B5EF4-FFF2-40B4-BE49-F238E27FC236}">
+              <a16:creationId xmlns:a16="http://schemas.microsoft.com/office/drawing/2014/main" id="{8FBE68D7-2926-547B-759F-905B45C7A03D}"/>
+            </a:ext>
+          </a:extLst>
+        </p:cNvPr>
+        <p:cNvGrpSpPr/>
+        <p:nvPr/>
+      </p:nvGrpSpPr>
+      <p:grpSpPr>
+        <a:xfrm>
+          <a:off x="0" y="0"/>
+          <a:ext cx="0" cy="0"/>
+          <a:chOff x="0" y="0"/>
+          <a:chExt cx="0" cy="0"/>
+        </a:xfrm>
+      </p:grpSpPr>
+      <p:sp>
+        <p:nvSpPr>
+          <p:cNvPr id="2" name="Titel 1">
+            <a:extLst>
+              <a:ext uri="{FF2B5EF4-FFF2-40B4-BE49-F238E27FC236}">
+                <a16:creationId xmlns:a16="http://schemas.microsoft.com/office/drawing/2014/main" id="{E480F9FB-47AF-52EB-CAFC-EE7CC7631B52}"/>
+              </a:ext>
+            </a:extLst>
+          </p:cNvPr>
+          <p:cNvSpPr>
+            <a:spLocks noGrp="1"/>
+          </p:cNvSpPr>
+          <p:nvPr>
+            <p:ph type="title"/>
+          </p:nvPr>
+        </p:nvSpPr>
+        <p:spPr/>
+        <p:txBody>
+          <a:bodyPr/>
+          <a:lstStyle/>
+          <a:p>
+            <a:endParaRPr lang="en-GB" noProof="0" dirty="0"/>
+          </a:p>
+        </p:txBody>
+      </p:sp>
+      <p:sp>
+        <p:nvSpPr>
+          <p:cNvPr id="3" name="Inhaltsplatzhalter 2">
+            <a:extLst>
+              <a:ext uri="{FF2B5EF4-FFF2-40B4-BE49-F238E27FC236}">
+                <a16:creationId xmlns:a16="http://schemas.microsoft.com/office/drawing/2014/main" id="{81D83B08-D5ED-F1AE-4C68-8F439E7FE99D}"/>
+              </a:ext>
+            </a:extLst>
+          </p:cNvPr>
+          <p:cNvSpPr>
+            <a:spLocks noGrp="1"/>
+          </p:cNvSpPr>
+          <p:nvPr>
+            <p:ph idx="1"/>
+          </p:nvPr>
+        </p:nvSpPr>
+        <p:spPr/>
+        <p:txBody>
+          <a:bodyPr/>
+          <a:lstStyle/>
+          <a:p>
+            <a:r>
+              <a:rPr lang="en-GB" noProof="0" dirty="0"/>
+              <a:t>Generated Code of used Model and converted it to usable MP-model</a:t>
+            </a:r>
+          </a:p>
+        </p:txBody>
+      </p:sp>
+      <p:sp>
+        <p:nvSpPr>
+          <p:cNvPr id="4" name="Datumsplatzhalter 3">
+            <a:extLst>
+              <a:ext uri="{FF2B5EF4-FFF2-40B4-BE49-F238E27FC236}">
+                <a16:creationId xmlns:a16="http://schemas.microsoft.com/office/drawing/2014/main" id="{1481A1BE-373A-5FDD-44F3-E3FFDC5FED11}"/>
+              </a:ext>
+            </a:extLst>
+          </p:cNvPr>
+          <p:cNvSpPr>
+            <a:spLocks noGrp="1"/>
+          </p:cNvSpPr>
+          <p:nvPr>
+            <p:ph type="dt" sz="half" idx="10"/>
+          </p:nvPr>
+        </p:nvSpPr>
+        <p:spPr/>
+        <p:txBody>
+          <a:bodyPr/>
+          <a:lstStyle/>
+          <a:p>
+            <a:r>
+              <a:rPr lang="en-GB" noProof="0" dirty="0"/>
+              <a:t>23.02.2026</a:t>
+            </a:r>
+          </a:p>
+        </p:txBody>
+      </p:sp>
+      <p:sp>
+        <p:nvSpPr>
+          <p:cNvPr id="5" name="Foliennummernplatzhalter 4">
+            <a:extLst>
+              <a:ext uri="{FF2B5EF4-FFF2-40B4-BE49-F238E27FC236}">
+                <a16:creationId xmlns:a16="http://schemas.microsoft.com/office/drawing/2014/main" id="{A67E69F2-9F56-AF44-B4AD-1335808D1D98}"/>
+              </a:ext>
+            </a:extLst>
+          </p:cNvPr>
+          <p:cNvSpPr>
+            <a:spLocks noGrp="1"/>
+          </p:cNvSpPr>
+          <p:nvPr>
+            <p:ph type="sldNum" sz="quarter" idx="12"/>
+          </p:nvPr>
+        </p:nvSpPr>
+        <p:spPr/>
+        <p:txBody>
+          <a:bodyPr/>
+          <a:lstStyle/>
+          <a:p>
+            <a:fld id="{533690DF-FFD6-462A-8578-786984FF8DCB}" type="slidenum">
+              <a:rPr lang="en-GB" noProof="0" smtClean="0"/>
+              <a:t>8</a:t>
+            </a:fld>
+            <a:endParaRPr lang="en-GB" noProof="0" dirty="0"/>
+          </a:p>
+        </p:txBody>
+      </p:sp>
+      <p:sp>
+        <p:nvSpPr>
+          <p:cNvPr id="8" name="Rectangle: Rounded Corners 3">
+            <a:extLst>
+              <a:ext uri="{FF2B5EF4-FFF2-40B4-BE49-F238E27FC236}">
+                <a16:creationId xmlns:a16="http://schemas.microsoft.com/office/drawing/2014/main" id="{798DA5B3-5766-002C-E7E4-331B21440828}"/>
+              </a:ext>
+            </a:extLst>
+          </p:cNvPr>
+          <p:cNvSpPr/>
+          <p:nvPr/>
+        </p:nvSpPr>
+        <p:spPr bwMode="auto">
+          <a:xfrm>
+            <a:off x="388302" y="681037"/>
+            <a:ext cx="11522076" cy="828438"/>
+          </a:xfrm>
+          <a:prstGeom prst="roundRect">
+            <a:avLst>
+              <a:gd name="adj" fmla="val 9662"/>
+            </a:avLst>
+          </a:prstGeom>
+          <a:solidFill>
+            <a:srgbClr val="0A8276"/>
+          </a:solidFill>
+          <a:ln w="9525">
+            <a:noFill/>
+            <a:miter lim="800000"/>
+            <a:headEnd/>
+            <a:tailEnd/>
+          </a:ln>
+        </p:spPr>
+        <p:txBody>
+          <a:bodyPr rot="0" spcFirstLastPara="0" vertOverflow="overflow" horzOverflow="overflow" vert="horz" wrap="square" lIns="72000" tIns="72000" rIns="72000" bIns="72000" numCol="1" spcCol="0" rtlCol="0" fromWordArt="0" anchor="ctr" anchorCtr="0" forceAA="0" compatLnSpc="1">
+            <a:prstTxWarp prst="textNoShape">
+              <a:avLst/>
+            </a:prstTxWarp>
+            <a:noAutofit/>
+          </a:bodyPr>
+          <a:lstStyle/>
+          <a:p>
+            <a:pPr defTabSz="576000" eaLnBrk="0" fontAlgn="base" hangingPunct="0">
+              <a:lnSpc>
+                <a:spcPct val="120000"/>
+              </a:lnSpc>
+              <a:spcBef>
+                <a:spcPct val="0"/>
+              </a:spcBef>
+              <a:spcAft>
+                <a:spcPct val="0"/>
+              </a:spcAft>
+              <a:defRPr/>
+            </a:pPr>
+            <a:r>
+              <a:rPr lang="en-GB" sz="2000" b="1" kern="0" noProof="0" dirty="0" err="1">
+                <a:solidFill>
+                  <a:srgbClr val="FFFFFF"/>
+                </a:solidFill>
+                <a:latin typeface="Arial"/>
+                <a:cs typeface="Arial"/>
+              </a:rPr>
+              <a:t>Micropython</a:t>
+            </a:r>
+            <a:r>
+              <a:rPr lang="en-GB" sz="2000" b="1" kern="0" noProof="0" dirty="0">
+                <a:solidFill>
+                  <a:srgbClr val="FFFFFF"/>
+                </a:solidFill>
+                <a:latin typeface="Arial"/>
+                <a:cs typeface="Arial"/>
+              </a:rPr>
+              <a:t> Code</a:t>
+            </a:r>
+            <a:endParaRPr lang="en-GB" sz="2000" b="1" i="1" kern="0" baseline="30000" noProof="0" dirty="0">
+              <a:solidFill>
+                <a:srgbClr val="FFFFFF"/>
+              </a:solidFill>
+              <a:latin typeface="Arial"/>
+              <a:cs typeface="Arial"/>
+            </a:endParaRPr>
+          </a:p>
+        </p:txBody>
+      </p:sp>
+    </p:spTree>
+    <p:extLst>
+      <p:ext uri="{BB962C8B-B14F-4D97-AF65-F5344CB8AC3E}">
+        <p14:creationId xmlns:p14="http://schemas.microsoft.com/office/powerpoint/2010/main" val="4267612672"/>
+      </p:ext>
+    </p:extLst>
+  </p:cSld>
+  <p:clrMapOvr>
+    <a:masterClrMapping/>
+  </p:clrMapOvr>
+</p:sld>
+</file>
+
+<file path=ppt/slides/slide9.xml><?xml version="1.0" encoding="utf-8"?>
+<p:sld xmlns:a="http://schemas.openxmlformats.org/drawingml/2006/main" xmlns:r="http://schemas.openxmlformats.org/officeDocument/2006/relationships" xmlns:p="http://schemas.openxmlformats.org/presentationml/2006/main">
+  <p:cSld>
+    <p:spTree>
+      <p:nvGrpSpPr>
+        <p:cNvPr id="1" name="">
+          <a:extLst>
+            <a:ext uri="{FF2B5EF4-FFF2-40B4-BE49-F238E27FC236}">
+              <a16:creationId xmlns:a16="http://schemas.microsoft.com/office/drawing/2014/main" id="{BA88F5AF-2E23-BEFE-6BC1-B4D534AFB1B6}"/>
+            </a:ext>
+          </a:extLst>
+        </p:cNvPr>
+        <p:cNvGrpSpPr/>
+        <p:nvPr/>
+      </p:nvGrpSpPr>
+      <p:grpSpPr>
+        <a:xfrm>
+          <a:off x="0" y="0"/>
+          <a:ext cx="0" cy="0"/>
+          <a:chOff x="0" y="0"/>
+          <a:chExt cx="0" cy="0"/>
+        </a:xfrm>
+      </p:grpSpPr>
+      <p:sp>
+        <p:nvSpPr>
+          <p:cNvPr id="2" name="Titel 1">
+            <a:extLst>
+              <a:ext uri="{FF2B5EF4-FFF2-40B4-BE49-F238E27FC236}">
+                <a16:creationId xmlns:a16="http://schemas.microsoft.com/office/drawing/2014/main" id="{E9F140C5-9AA7-C982-774A-2DE2FE881DE4}"/>
+              </a:ext>
+            </a:extLst>
+          </p:cNvPr>
+          <p:cNvSpPr>
+            <a:spLocks noGrp="1"/>
+          </p:cNvSpPr>
+          <p:nvPr>
+            <p:ph type="title"/>
+          </p:nvPr>
+        </p:nvSpPr>
+        <p:spPr/>
+        <p:txBody>
+          <a:bodyPr/>
+          <a:lstStyle/>
+          <a:p>
+            <a:endParaRPr lang="en-GB" noProof="0" dirty="0"/>
+          </a:p>
+        </p:txBody>
+      </p:sp>
+      <p:sp>
+        <p:nvSpPr>
+          <p:cNvPr id="3" name="Inhaltsplatzhalter 2">
+            <a:extLst>
+              <a:ext uri="{FF2B5EF4-FFF2-40B4-BE49-F238E27FC236}">
+                <a16:creationId xmlns:a16="http://schemas.microsoft.com/office/drawing/2014/main" id="{16E70A6D-D365-C64A-387A-75AAE10CB406}"/>
+              </a:ext>
+            </a:extLst>
+          </p:cNvPr>
+          <p:cNvSpPr>
+            <a:spLocks noGrp="1"/>
+          </p:cNvSpPr>
+          <p:nvPr>
+            <p:ph idx="1"/>
+          </p:nvPr>
+        </p:nvSpPr>
+        <p:spPr/>
+        <p:txBody>
+          <a:bodyPr>
+            <a:normAutofit fontScale="92500" lnSpcReduction="10000"/>
+          </a:bodyPr>
+          <a:lstStyle/>
+          <a:p>
+            <a:r>
+              <a:rPr lang="en-GB" noProof="0" dirty="0"/>
+              <a:t>Overlapping labels</a:t>
+            </a:r>
+            <a:r>
+              <a:rPr lang="en-GB" dirty="0"/>
+              <a:t>, DEEPCRAFT Studio sometimes set two labels above each other</a:t>
+            </a:r>
+            <a:endParaRPr lang="en-GB" noProof="0" dirty="0"/>
+          </a:p>
+          <a:p>
+            <a:r>
+              <a:rPr lang="en-GB" noProof="0" dirty="0"/>
+              <a:t>No clear indications on what ma</a:t>
+            </a:r>
+            <a:r>
+              <a:rPr lang="en-GB" dirty="0" err="1"/>
+              <a:t>kes</a:t>
+            </a:r>
+            <a:r>
+              <a:rPr lang="en-GB" dirty="0"/>
+              <a:t> model better or worse</a:t>
+            </a:r>
+          </a:p>
+          <a:p>
+            <a:r>
+              <a:rPr lang="en-GB" dirty="0"/>
+              <a:t>It was not achievable to enqueue Data fast enough in our </a:t>
+            </a:r>
+            <a:r>
+              <a:rPr lang="en-GB" dirty="0" err="1"/>
+              <a:t>Micropython</a:t>
+            </a:r>
+            <a:r>
+              <a:rPr lang="en-GB" dirty="0"/>
+              <a:t> Code (fastest Loop runtime 3ms). Needed to </a:t>
+            </a:r>
+            <a:r>
+              <a:rPr lang="en-GB" dirty="0" err="1"/>
+              <a:t>downsample</a:t>
+            </a:r>
+            <a:r>
+              <a:rPr lang="en-GB" dirty="0"/>
+              <a:t> our Data to 100Hz</a:t>
+            </a:r>
+          </a:p>
+          <a:p>
+            <a:r>
+              <a:rPr lang="en-GB" dirty="0"/>
+              <a:t>Using an if-selection to time enqueue did not work/lead to the PSOC6 stalling after a few seconds (Busy waiting). Used </a:t>
+            </a:r>
+            <a:r>
+              <a:rPr lang="en-GB" dirty="0" err="1"/>
+              <a:t>time.wait_ms</a:t>
+            </a:r>
+            <a:r>
+              <a:rPr lang="en-GB" dirty="0"/>
+              <a:t>() instead</a:t>
+            </a:r>
+          </a:p>
+          <a:p>
+            <a:r>
+              <a:rPr lang="en-GB" dirty="0"/>
+              <a:t>Predictions for one punch are greater than 0.6 over two contextual windows.</a:t>
+            </a:r>
+          </a:p>
+          <a:p>
+            <a:endParaRPr lang="en-GB" dirty="0"/>
+          </a:p>
+          <a:p>
+            <a:endParaRPr lang="en-GB" dirty="0"/>
+          </a:p>
+          <a:p>
+            <a:endParaRPr lang="en-GB" noProof="0" dirty="0"/>
+          </a:p>
+        </p:txBody>
+      </p:sp>
+      <p:sp>
+        <p:nvSpPr>
+          <p:cNvPr id="4" name="Datumsplatzhalter 3">
+            <a:extLst>
+              <a:ext uri="{FF2B5EF4-FFF2-40B4-BE49-F238E27FC236}">
+                <a16:creationId xmlns:a16="http://schemas.microsoft.com/office/drawing/2014/main" id="{A662B3FA-00C1-9EE6-1D74-E4B044BBECD8}"/>
+              </a:ext>
+            </a:extLst>
+          </p:cNvPr>
+          <p:cNvSpPr>
+            <a:spLocks noGrp="1"/>
+          </p:cNvSpPr>
+          <p:nvPr>
+            <p:ph type="dt" sz="half" idx="10"/>
+          </p:nvPr>
+        </p:nvSpPr>
+        <p:spPr/>
+        <p:txBody>
+          <a:bodyPr/>
+          <a:lstStyle/>
+          <a:p>
+            <a:r>
+              <a:rPr lang="en-GB" noProof="0" dirty="0"/>
+              <a:t>23.02.2026</a:t>
+            </a:r>
+          </a:p>
+        </p:txBody>
+      </p:sp>
+      <p:sp>
+        <p:nvSpPr>
+          <p:cNvPr id="5" name="Foliennummernplatzhalter 4">
+            <a:extLst>
+              <a:ext uri="{FF2B5EF4-FFF2-40B4-BE49-F238E27FC236}">
+                <a16:creationId xmlns:a16="http://schemas.microsoft.com/office/drawing/2014/main" id="{1358572C-AB05-ECD6-B505-C87F61376D78}"/>
+              </a:ext>
+            </a:extLst>
+          </p:cNvPr>
+          <p:cNvSpPr>
+            <a:spLocks noGrp="1"/>
+          </p:cNvSpPr>
+          <p:nvPr>
+            <p:ph type="sldNum" sz="quarter" idx="12"/>
+          </p:nvPr>
+        </p:nvSpPr>
+        <p:spPr/>
+        <p:txBody>
+          <a:bodyPr/>
+          <a:lstStyle/>
+          <a:p>
+            <a:fld id="{533690DF-FFD6-462A-8578-786984FF8DCB}" type="slidenum">
+              <a:rPr lang="en-GB" noProof="0" smtClean="0"/>
+              <a:t>9</a:t>
+            </a:fld>
+            <a:endParaRPr lang="en-GB" noProof="0" dirty="0"/>
+          </a:p>
+        </p:txBody>
+      </p:sp>
+      <p:sp>
+        <p:nvSpPr>
+          <p:cNvPr id="8" name="Rectangle: Rounded Corners 3">
+            <a:extLst>
+              <a:ext uri="{FF2B5EF4-FFF2-40B4-BE49-F238E27FC236}">
+                <a16:creationId xmlns:a16="http://schemas.microsoft.com/office/drawing/2014/main" id="{2B3438B7-EF5B-59AA-36AC-D1B6B1D0A3AA}"/>
+              </a:ext>
+            </a:extLst>
+          </p:cNvPr>
+          <p:cNvSpPr/>
+          <p:nvPr/>
+        </p:nvSpPr>
+        <p:spPr bwMode="auto">
+          <a:xfrm>
+            <a:off x="388302" y="681037"/>
+            <a:ext cx="11522076" cy="828438"/>
+          </a:xfrm>
+          <a:prstGeom prst="roundRect">
+            <a:avLst>
+              <a:gd name="adj" fmla="val 9662"/>
+            </a:avLst>
+          </a:prstGeom>
+          <a:solidFill>
+            <a:srgbClr val="0A8276"/>
+          </a:solidFill>
+          <a:ln w="9525">
+            <a:noFill/>
+            <a:miter lim="800000"/>
+            <a:headEnd/>
+            <a:tailEnd/>
+          </a:ln>
+        </p:spPr>
+        <p:txBody>
+          <a:bodyPr rot="0" spcFirstLastPara="0" vertOverflow="overflow" horzOverflow="overflow" vert="horz" wrap="square" lIns="72000" tIns="72000" rIns="72000" bIns="72000" numCol="1" spcCol="0" rtlCol="0" fromWordArt="0" anchor="ctr" anchorCtr="0" forceAA="0" compatLnSpc="1">
+            <a:prstTxWarp prst="textNoShape">
+              <a:avLst/>
+            </a:prstTxWarp>
+            <a:noAutofit/>
+          </a:bodyPr>
+          <a:lstStyle/>
+          <a:p>
+            <a:pPr defTabSz="576000" eaLnBrk="0" fontAlgn="base" hangingPunct="0">
+              <a:lnSpc>
+                <a:spcPct val="120000"/>
+              </a:lnSpc>
+              <a:spcBef>
+                <a:spcPct val="0"/>
+              </a:spcBef>
+              <a:spcAft>
+                <a:spcPct val="0"/>
+              </a:spcAft>
+              <a:defRPr/>
+            </a:pPr>
+            <a:r>
+              <a:rPr lang="en-GB" sz="2000" b="1" kern="0" noProof="0" dirty="0">
+                <a:solidFill>
+                  <a:srgbClr val="FFFFFF"/>
+                </a:solidFill>
+                <a:latin typeface="Arial"/>
+                <a:cs typeface="Arial"/>
+              </a:rPr>
+              <a:t>Problems faced</a:t>
+            </a:r>
+            <a:endParaRPr lang="en-GB" sz="2000" b="1" i="1" kern="0" baseline="30000" noProof="0" dirty="0">
+              <a:solidFill>
+                <a:srgbClr val="FFFFFF"/>
+              </a:solidFill>
+              <a:latin typeface="Arial"/>
+              <a:cs typeface="Arial"/>
+            </a:endParaRPr>
+          </a:p>
+        </p:txBody>
+      </p:sp>
+    </p:spTree>
+    <p:extLst>
+      <p:ext uri="{BB962C8B-B14F-4D97-AF65-F5344CB8AC3E}">
+        <p14:creationId xmlns:p14="http://schemas.microsoft.com/office/powerpoint/2010/main" val="616278457"/>
       </p:ext>
     </p:extLst>
   </p:cSld>
@@ -8814,23 +8350,6 @@
 </file>
 
 <file path=customXml/item1.xml><?xml version="1.0" encoding="utf-8"?>
-<?mso-contentType ?>
-<FormTemplates xmlns="http://schemas.microsoft.com/sharepoint/v3/contenttype/forms">
-  <Display>DocumentLibraryForm</Display>
-  <Edit>DocumentLibraryForm</Edit>
-  <New>DocumentLibraryForm</New>
-</FormTemplates>
-</file>
-
-<file path=customXml/item2.xml><?xml version="1.0" encoding="utf-8"?>
-<p:properties xmlns:p="http://schemas.microsoft.com/office/2006/metadata/properties" xmlns:xsi="http://www.w3.org/2001/XMLSchema-instance" xmlns:pc="http://schemas.microsoft.com/office/infopath/2007/PartnerControls">
-  <documentManagement>
-    <_activity xmlns="bf1a47b5-10f0-4178-af4a-bbe7cc4004c3" xsi:nil="true"/>
-  </documentManagement>
-</p:properties>
-</file>
-
-<file path=customXml/item3.xml><?xml version="1.0" encoding="utf-8"?>
 <ct:contentTypeSchema xmlns:ct="http://schemas.microsoft.com/office/2006/metadata/contentType" xmlns:ma="http://schemas.microsoft.com/office/2006/metadata/properties/metaAttributes" ct:_="" ma:_="" ma:contentTypeName="Dokument" ma:contentTypeID="0x010100B041D5FB7F9ADB4FA3268D6933894E4E" ma:contentTypeVersion="11" ma:contentTypeDescription="Ein neues Dokument erstellen." ma:contentTypeScope="" ma:versionID="1716f861161e7a5f6104ad8e56853467">
   <xsd:schema xmlns:xsd="http://www.w3.org/2001/XMLSchema" xmlns:xs="http://www.w3.org/2001/XMLSchema" xmlns:p="http://schemas.microsoft.com/office/2006/metadata/properties" xmlns:ns3="bf1a47b5-10f0-4178-af4a-bbe7cc4004c3" targetNamespace="http://schemas.microsoft.com/office/2006/metadata/properties" ma:root="true" ma:fieldsID="8ee1bf931531000dc41501df99fd4e2b" ns3:_="">
     <xsd:import namespace="bf1a47b5-10f0-4178-af4a-bbe7cc4004c3"/>
@@ -9018,10 +8537,37 @@
 </ct:contentTypeSchema>
 </file>
 
+<file path=customXml/item2.xml><?xml version="1.0" encoding="utf-8"?>
+<p:properties xmlns:p="http://schemas.microsoft.com/office/2006/metadata/properties" xmlns:xsi="http://www.w3.org/2001/XMLSchema-instance" xmlns:pc="http://schemas.microsoft.com/office/infopath/2007/PartnerControls">
+  <documentManagement>
+    <_activity xmlns="bf1a47b5-10f0-4178-af4a-bbe7cc4004c3" xsi:nil="true"/>
+  </documentManagement>
+</p:properties>
+</file>
+
+<file path=customXml/item3.xml><?xml version="1.0" encoding="utf-8"?>
+<?mso-contentType ?>
+<FormTemplates xmlns="http://schemas.microsoft.com/sharepoint/v3/contenttype/forms">
+  <Display>DocumentLibraryForm</Display>
+  <Edit>DocumentLibraryForm</Edit>
+  <New>DocumentLibraryForm</New>
+</FormTemplates>
+</file>
+
 <file path=customXml/itemProps1.xml><?xml version="1.0" encoding="utf-8"?>
-<ds:datastoreItem xmlns:ds="http://schemas.openxmlformats.org/officeDocument/2006/customXml" ds:itemID="{D12945CB-A677-4013-820C-0AEFE2C4DC48}">
+<ds:datastoreItem xmlns:ds="http://schemas.openxmlformats.org/officeDocument/2006/customXml" ds:itemID="{68909959-C625-4C65-88C3-A1F8ACE56D22}">
   <ds:schemaRefs>
-    <ds:schemaRef ds:uri="http://schemas.microsoft.com/sharepoint/v3/contenttype/forms"/>
+    <ds:schemaRef ds:uri="http://schemas.microsoft.com/office/2006/metadata/contentType"/>
+    <ds:schemaRef ds:uri="http://schemas.microsoft.com/office/2006/metadata/properties/metaAttributes"/>
+    <ds:schemaRef ds:uri="http://www.w3.org/2001/XMLSchema"/>
+    <ds:schemaRef ds:uri="http://schemas.microsoft.com/office/2006/metadata/properties"/>
+    <ds:schemaRef ds:uri="bf1a47b5-10f0-4178-af4a-bbe7cc4004c3"/>
+    <ds:schemaRef ds:uri="http://schemas.microsoft.com/office/2006/documentManagement/types"/>
+    <ds:schemaRef ds:uri="http://schemas.microsoft.com/office/infopath/2007/PartnerControls"/>
+    <ds:schemaRef ds:uri="http://schemas.openxmlformats.org/package/2006/metadata/core-properties"/>
+    <ds:schemaRef ds:uri="http://purl.org/dc/elements/1.1/"/>
+    <ds:schemaRef ds:uri="http://purl.org/dc/terms/"/>
+    <ds:schemaRef ds:uri="http://schemas.microsoft.com/internal/obd"/>
   </ds:schemaRefs>
 </ds:datastoreItem>
 </file>
@@ -9043,19 +8589,9 @@
 </file>
 
 <file path=customXml/itemProps3.xml><?xml version="1.0" encoding="utf-8"?>
-<ds:datastoreItem xmlns:ds="http://schemas.openxmlformats.org/officeDocument/2006/customXml" ds:itemID="{68909959-C625-4C65-88C3-A1F8ACE56D22}">
+<ds:datastoreItem xmlns:ds="http://schemas.openxmlformats.org/officeDocument/2006/customXml" ds:itemID="{D12945CB-A677-4013-820C-0AEFE2C4DC48}">
   <ds:schemaRefs>
-    <ds:schemaRef ds:uri="http://schemas.microsoft.com/office/2006/metadata/contentType"/>
-    <ds:schemaRef ds:uri="http://schemas.microsoft.com/office/2006/metadata/properties/metaAttributes"/>
-    <ds:schemaRef ds:uri="http://www.w3.org/2001/XMLSchema"/>
-    <ds:schemaRef ds:uri="http://schemas.microsoft.com/office/2006/metadata/properties"/>
-    <ds:schemaRef ds:uri="bf1a47b5-10f0-4178-af4a-bbe7cc4004c3"/>
-    <ds:schemaRef ds:uri="http://schemas.microsoft.com/office/2006/documentManagement/types"/>
-    <ds:schemaRef ds:uri="http://schemas.microsoft.com/office/infopath/2007/PartnerControls"/>
-    <ds:schemaRef ds:uri="http://schemas.openxmlformats.org/package/2006/metadata/core-properties"/>
-    <ds:schemaRef ds:uri="http://purl.org/dc/elements/1.1/"/>
-    <ds:schemaRef ds:uri="http://purl.org/dc/terms/"/>
-    <ds:schemaRef ds:uri="http://schemas.microsoft.com/internal/obd"/>
+    <ds:schemaRef ds:uri="http://schemas.microsoft.com/sharepoint/v3/contenttype/forms"/>
   </ds:schemaRefs>
 </ds:datastoreItem>
 </file>
</xml_diff>